<commit_message>
Completed background slide on Foldseek.
</commit_message>
<xml_diff>
--- a/vis/reports/2026-02-18_projectUpdate_1.pptx
+++ b/vis/reports/2026-02-18_projectUpdate_1.pptx
@@ -4,10 +4,15 @@
   <p:sldMasterIdLst>
     <p:sldMasterId id="2147483648" r:id="rId1"/>
   </p:sldMasterIdLst>
+  <p:notesMasterIdLst>
+    <p:notesMasterId r:id="rId7"/>
+  </p:notesMasterIdLst>
   <p:sldIdLst>
     <p:sldId id="256" r:id="rId2"/>
     <p:sldId id="258" r:id="rId3"/>
-    <p:sldId id="257" r:id="rId4"/>
+    <p:sldId id="259" r:id="rId4"/>
+    <p:sldId id="257" r:id="rId5"/>
+    <p:sldId id="260" r:id="rId6"/>
   </p:sldIdLst>
   <p:sldSz cx="12192000" cy="6858000"/>
   <p:notesSz cx="6858000" cy="9144000"/>
@@ -109,6 +114,356 @@
 </p:presentation>
 </file>
 
+<file path=ppt/notesMasters/notesMaster1.xml><?xml version="1.0" encoding="utf-8"?>
+<p:notesMaster xmlns:a="http://schemas.openxmlformats.org/drawingml/2006/main" xmlns:r="http://schemas.openxmlformats.org/officeDocument/2006/relationships" xmlns:p="http://schemas.openxmlformats.org/presentationml/2006/main">
+  <p:cSld>
+    <p:bg>
+      <p:bgRef idx="1001">
+        <a:schemeClr val="bg1"/>
+      </p:bgRef>
+    </p:bg>
+    <p:spTree>
+      <p:nvGrpSpPr>
+        <p:cNvPr id="1" name=""/>
+        <p:cNvGrpSpPr/>
+        <p:nvPr/>
+      </p:nvGrpSpPr>
+      <p:grpSpPr>
+        <a:xfrm>
+          <a:off x="0" y="0"/>
+          <a:ext cx="0" cy="0"/>
+          <a:chOff x="0" y="0"/>
+          <a:chExt cx="0" cy="0"/>
+        </a:xfrm>
+      </p:grpSpPr>
+      <p:sp>
+        <p:nvSpPr>
+          <p:cNvPr id="2" name="Header Placeholder 1"/>
+          <p:cNvSpPr>
+            <a:spLocks noGrp="1"/>
+          </p:cNvSpPr>
+          <p:nvPr>
+            <p:ph type="hdr" sz="quarter"/>
+          </p:nvPr>
+        </p:nvSpPr>
+        <p:spPr>
+          <a:xfrm>
+            <a:off x="0" y="0"/>
+            <a:ext cx="2971800" cy="458788"/>
+          </a:xfrm>
+          <a:prstGeom prst="rect">
+            <a:avLst/>
+          </a:prstGeom>
+        </p:spPr>
+        <p:txBody>
+          <a:bodyPr vert="horz" lIns="91440" tIns="45720" rIns="91440" bIns="45720" rtlCol="0"/>
+          <a:lstStyle>
+            <a:lvl1pPr algn="l">
+              <a:defRPr sz="1200"/>
+            </a:lvl1pPr>
+          </a:lstStyle>
+          <a:p>
+            <a:endParaRPr lang="en-CA"/>
+          </a:p>
+        </p:txBody>
+      </p:sp>
+      <p:sp>
+        <p:nvSpPr>
+          <p:cNvPr id="3" name="Date Placeholder 2"/>
+          <p:cNvSpPr>
+            <a:spLocks noGrp="1"/>
+          </p:cNvSpPr>
+          <p:nvPr>
+            <p:ph type="dt" idx="1"/>
+          </p:nvPr>
+        </p:nvSpPr>
+        <p:spPr>
+          <a:xfrm>
+            <a:off x="3884613" y="0"/>
+            <a:ext cx="2971800" cy="458788"/>
+          </a:xfrm>
+          <a:prstGeom prst="rect">
+            <a:avLst/>
+          </a:prstGeom>
+        </p:spPr>
+        <p:txBody>
+          <a:bodyPr vert="horz" lIns="91440" tIns="45720" rIns="91440" bIns="45720" rtlCol="0"/>
+          <a:lstStyle>
+            <a:lvl1pPr algn="r">
+              <a:defRPr sz="1200"/>
+            </a:lvl1pPr>
+          </a:lstStyle>
+          <a:p>
+            <a:fld id="{F0213E3E-99C3-4924-8BC9-8C32863166AD}" type="datetimeFigureOut">
+              <a:rPr lang="en-CA" smtClean="0"/>
+              <a:t>2026-02-18</a:t>
+            </a:fld>
+            <a:endParaRPr lang="en-CA"/>
+          </a:p>
+        </p:txBody>
+      </p:sp>
+      <p:sp>
+        <p:nvSpPr>
+          <p:cNvPr id="4" name="Slide Image Placeholder 3"/>
+          <p:cNvSpPr>
+            <a:spLocks noGrp="1" noRot="1" noChangeAspect="1"/>
+          </p:cNvSpPr>
+          <p:nvPr>
+            <p:ph type="sldImg" idx="2"/>
+          </p:nvPr>
+        </p:nvSpPr>
+        <p:spPr>
+          <a:xfrm>
+            <a:off x="685800" y="1143000"/>
+            <a:ext cx="5486400" cy="3086100"/>
+          </a:xfrm>
+          <a:prstGeom prst="rect">
+            <a:avLst/>
+          </a:prstGeom>
+          <a:noFill/>
+          <a:ln w="12700">
+            <a:solidFill>
+              <a:prstClr val="black"/>
+            </a:solidFill>
+          </a:ln>
+        </p:spPr>
+        <p:txBody>
+          <a:bodyPr vert="horz" lIns="91440" tIns="45720" rIns="91440" bIns="45720" rtlCol="0" anchor="ctr"/>
+          <a:lstStyle/>
+          <a:p>
+            <a:endParaRPr lang="en-CA"/>
+          </a:p>
+        </p:txBody>
+      </p:sp>
+      <p:sp>
+        <p:nvSpPr>
+          <p:cNvPr id="5" name="Notes Placeholder 4"/>
+          <p:cNvSpPr>
+            <a:spLocks noGrp="1"/>
+          </p:cNvSpPr>
+          <p:nvPr>
+            <p:ph type="body" sz="quarter" idx="3"/>
+          </p:nvPr>
+        </p:nvSpPr>
+        <p:spPr>
+          <a:xfrm>
+            <a:off x="685800" y="4400550"/>
+            <a:ext cx="5486400" cy="3600450"/>
+          </a:xfrm>
+          <a:prstGeom prst="rect">
+            <a:avLst/>
+          </a:prstGeom>
+        </p:spPr>
+        <p:txBody>
+          <a:bodyPr vert="horz" lIns="91440" tIns="45720" rIns="91440" bIns="45720" rtlCol="0"/>
+          <a:lstStyle/>
+          <a:p>
+            <a:pPr lvl="0"/>
+            <a:r>
+              <a:rPr lang="en-US"/>
+              <a:t>Click to edit Master text styles</a:t>
+            </a:r>
+          </a:p>
+          <a:p>
+            <a:pPr lvl="1"/>
+            <a:r>
+              <a:rPr lang="en-US"/>
+              <a:t>Second level</a:t>
+            </a:r>
+          </a:p>
+          <a:p>
+            <a:pPr lvl="2"/>
+            <a:r>
+              <a:rPr lang="en-US"/>
+              <a:t>Third level</a:t>
+            </a:r>
+          </a:p>
+          <a:p>
+            <a:pPr lvl="3"/>
+            <a:r>
+              <a:rPr lang="en-US"/>
+              <a:t>Fourth level</a:t>
+            </a:r>
+          </a:p>
+          <a:p>
+            <a:pPr lvl="4"/>
+            <a:r>
+              <a:rPr lang="en-US"/>
+              <a:t>Fifth level</a:t>
+            </a:r>
+            <a:endParaRPr lang="en-CA"/>
+          </a:p>
+        </p:txBody>
+      </p:sp>
+      <p:sp>
+        <p:nvSpPr>
+          <p:cNvPr id="6" name="Footer Placeholder 5"/>
+          <p:cNvSpPr>
+            <a:spLocks noGrp="1"/>
+          </p:cNvSpPr>
+          <p:nvPr>
+            <p:ph type="ftr" sz="quarter" idx="4"/>
+          </p:nvPr>
+        </p:nvSpPr>
+        <p:spPr>
+          <a:xfrm>
+            <a:off x="0" y="8685213"/>
+            <a:ext cx="2971800" cy="458787"/>
+          </a:xfrm>
+          <a:prstGeom prst="rect">
+            <a:avLst/>
+          </a:prstGeom>
+        </p:spPr>
+        <p:txBody>
+          <a:bodyPr vert="horz" lIns="91440" tIns="45720" rIns="91440" bIns="45720" rtlCol="0" anchor="b"/>
+          <a:lstStyle>
+            <a:lvl1pPr algn="l">
+              <a:defRPr sz="1200"/>
+            </a:lvl1pPr>
+          </a:lstStyle>
+          <a:p>
+            <a:endParaRPr lang="en-CA"/>
+          </a:p>
+        </p:txBody>
+      </p:sp>
+      <p:sp>
+        <p:nvSpPr>
+          <p:cNvPr id="7" name="Slide Number Placeholder 6"/>
+          <p:cNvSpPr>
+            <a:spLocks noGrp="1"/>
+          </p:cNvSpPr>
+          <p:nvPr>
+            <p:ph type="sldNum" sz="quarter" idx="5"/>
+          </p:nvPr>
+        </p:nvSpPr>
+        <p:spPr>
+          <a:xfrm>
+            <a:off x="3884613" y="8685213"/>
+            <a:ext cx="2971800" cy="458787"/>
+          </a:xfrm>
+          <a:prstGeom prst="rect">
+            <a:avLst/>
+          </a:prstGeom>
+        </p:spPr>
+        <p:txBody>
+          <a:bodyPr vert="horz" lIns="91440" tIns="45720" rIns="91440" bIns="45720" rtlCol="0" anchor="b"/>
+          <a:lstStyle>
+            <a:lvl1pPr algn="r">
+              <a:defRPr sz="1200"/>
+            </a:lvl1pPr>
+          </a:lstStyle>
+          <a:p>
+            <a:fld id="{B0C7A837-00D9-4D65-B917-5078A695B722}" type="slidenum">
+              <a:rPr lang="en-CA" smtClean="0"/>
+              <a:t>‹#›</a:t>
+            </a:fld>
+            <a:endParaRPr lang="en-CA"/>
+          </a:p>
+        </p:txBody>
+      </p:sp>
+    </p:spTree>
+    <p:extLst>
+      <p:ext uri="{BB962C8B-B14F-4D97-AF65-F5344CB8AC3E}">
+        <p14:creationId xmlns:p14="http://schemas.microsoft.com/office/powerpoint/2010/main" val="387430638"/>
+      </p:ext>
+    </p:extLst>
+  </p:cSld>
+  <p:clrMap bg1="lt1" tx1="dk1" bg2="lt2" tx2="dk2" accent1="accent1" accent2="accent2" accent3="accent3" accent4="accent4" accent5="accent5" accent6="accent6" hlink="hlink" folHlink="folHlink"/>
+  <p:notesStyle>
+    <a:lvl1pPr marL="0" algn="l" defTabSz="914400" rtl="0" eaLnBrk="1" latinLnBrk="0" hangingPunct="1">
+      <a:defRPr sz="1200" kern="1200">
+        <a:solidFill>
+          <a:schemeClr val="tx1"/>
+        </a:solidFill>
+        <a:latin typeface="+mn-lt"/>
+        <a:ea typeface="+mn-ea"/>
+        <a:cs typeface="+mn-cs"/>
+      </a:defRPr>
+    </a:lvl1pPr>
+    <a:lvl2pPr marL="457200" algn="l" defTabSz="914400" rtl="0" eaLnBrk="1" latinLnBrk="0" hangingPunct="1">
+      <a:defRPr sz="1200" kern="1200">
+        <a:solidFill>
+          <a:schemeClr val="tx1"/>
+        </a:solidFill>
+        <a:latin typeface="+mn-lt"/>
+        <a:ea typeface="+mn-ea"/>
+        <a:cs typeface="+mn-cs"/>
+      </a:defRPr>
+    </a:lvl2pPr>
+    <a:lvl3pPr marL="914400" algn="l" defTabSz="914400" rtl="0" eaLnBrk="1" latinLnBrk="0" hangingPunct="1">
+      <a:defRPr sz="1200" kern="1200">
+        <a:solidFill>
+          <a:schemeClr val="tx1"/>
+        </a:solidFill>
+        <a:latin typeface="+mn-lt"/>
+        <a:ea typeface="+mn-ea"/>
+        <a:cs typeface="+mn-cs"/>
+      </a:defRPr>
+    </a:lvl3pPr>
+    <a:lvl4pPr marL="1371600" algn="l" defTabSz="914400" rtl="0" eaLnBrk="1" latinLnBrk="0" hangingPunct="1">
+      <a:defRPr sz="1200" kern="1200">
+        <a:solidFill>
+          <a:schemeClr val="tx1"/>
+        </a:solidFill>
+        <a:latin typeface="+mn-lt"/>
+        <a:ea typeface="+mn-ea"/>
+        <a:cs typeface="+mn-cs"/>
+      </a:defRPr>
+    </a:lvl4pPr>
+    <a:lvl5pPr marL="1828800" algn="l" defTabSz="914400" rtl="0" eaLnBrk="1" latinLnBrk="0" hangingPunct="1">
+      <a:defRPr sz="1200" kern="1200">
+        <a:solidFill>
+          <a:schemeClr val="tx1"/>
+        </a:solidFill>
+        <a:latin typeface="+mn-lt"/>
+        <a:ea typeface="+mn-ea"/>
+        <a:cs typeface="+mn-cs"/>
+      </a:defRPr>
+    </a:lvl5pPr>
+    <a:lvl6pPr marL="2286000" algn="l" defTabSz="914400" rtl="0" eaLnBrk="1" latinLnBrk="0" hangingPunct="1">
+      <a:defRPr sz="1200" kern="1200">
+        <a:solidFill>
+          <a:schemeClr val="tx1"/>
+        </a:solidFill>
+        <a:latin typeface="+mn-lt"/>
+        <a:ea typeface="+mn-ea"/>
+        <a:cs typeface="+mn-cs"/>
+      </a:defRPr>
+    </a:lvl6pPr>
+    <a:lvl7pPr marL="2743200" algn="l" defTabSz="914400" rtl="0" eaLnBrk="1" latinLnBrk="0" hangingPunct="1">
+      <a:defRPr sz="1200" kern="1200">
+        <a:solidFill>
+          <a:schemeClr val="tx1"/>
+        </a:solidFill>
+        <a:latin typeface="+mn-lt"/>
+        <a:ea typeface="+mn-ea"/>
+        <a:cs typeface="+mn-cs"/>
+      </a:defRPr>
+    </a:lvl7pPr>
+    <a:lvl8pPr marL="3200400" algn="l" defTabSz="914400" rtl="0" eaLnBrk="1" latinLnBrk="0" hangingPunct="1">
+      <a:defRPr sz="1200" kern="1200">
+        <a:solidFill>
+          <a:schemeClr val="tx1"/>
+        </a:solidFill>
+        <a:latin typeface="+mn-lt"/>
+        <a:ea typeface="+mn-ea"/>
+        <a:cs typeface="+mn-cs"/>
+      </a:defRPr>
+    </a:lvl8pPr>
+    <a:lvl9pPr marL="3657600" algn="l" defTabSz="914400" rtl="0" eaLnBrk="1" latinLnBrk="0" hangingPunct="1">
+      <a:defRPr sz="1200" kern="1200">
+        <a:solidFill>
+          <a:schemeClr val="tx1"/>
+        </a:solidFill>
+        <a:latin typeface="+mn-lt"/>
+        <a:ea typeface="+mn-ea"/>
+        <a:cs typeface="+mn-cs"/>
+      </a:defRPr>
+    </a:lvl9pPr>
+  </p:notesStyle>
+</p:notesMaster>
+</file>
+
 <file path=ppt/slideLayouts/slideLayout1.xml><?xml version="1.0" encoding="utf-8"?>
 <p:sldLayout xmlns:a="http://schemas.openxmlformats.org/drawingml/2006/main" xmlns:r="http://schemas.openxmlformats.org/officeDocument/2006/relationships" xmlns:p="http://schemas.openxmlformats.org/presentationml/2006/main" type="title" preserve="1">
   <p:cSld name="Title Slide">
@@ -256,7 +611,7 @@
           <a:bodyPr/>
           <a:lstStyle/>
           <a:p>
-            <a:fld id="{743CF668-C101-4E7E-94E2-7030205CD9E8}" type="datetimeFigureOut">
+            <a:fld id="{74ABED0B-9A42-47E0-99B1-1140364C30B4}" type="datetime1">
               <a:rPr lang="en-CA" smtClean="0"/>
               <a:t>2026-02-18</a:t>
             </a:fld>
@@ -308,13 +663,18 @@
         <p:spPr/>
         <p:txBody>
           <a:bodyPr/>
-          <a:lstStyle/>
+          <a:lstStyle>
+            <a:lvl1pPr>
+              <a:defRPr sz="1400"/>
+            </a:lvl1pPr>
+          </a:lstStyle>
           <a:p>
             <a:fld id="{3899FC77-40C7-4C49-9A19-86BDE9B75E8A}" type="slidenum">
               <a:rPr lang="en-CA" smtClean="0"/>
+              <a:pPr/>
               <a:t>‹#›</a:t>
             </a:fld>
-            <a:endParaRPr lang="en-CA"/>
+            <a:endParaRPr lang="en-CA" sz="1400"/>
           </a:p>
         </p:txBody>
       </p:sp>
@@ -456,7 +816,7 @@
           <a:bodyPr/>
           <a:lstStyle/>
           <a:p>
-            <a:fld id="{743CF668-C101-4E7E-94E2-7030205CD9E8}" type="datetimeFigureOut">
+            <a:fld id="{515021F5-2C66-4B71-977D-F5801045D8C2}" type="datetime1">
               <a:rPr lang="en-CA" smtClean="0"/>
               <a:t>2026-02-18</a:t>
             </a:fld>
@@ -666,7 +1026,7 @@
           <a:bodyPr/>
           <a:lstStyle/>
           <a:p>
-            <a:fld id="{743CF668-C101-4E7E-94E2-7030205CD9E8}" type="datetimeFigureOut">
+            <a:fld id="{8FA893F5-30BD-4E02-A794-2D37AE7D84CF}" type="datetime1">
               <a:rPr lang="en-CA" smtClean="0"/>
               <a:t>2026-02-18</a:t>
             </a:fld>
@@ -866,7 +1226,7 @@
           <a:bodyPr/>
           <a:lstStyle/>
           <a:p>
-            <a:fld id="{743CF668-C101-4E7E-94E2-7030205CD9E8}" type="datetimeFigureOut">
+            <a:fld id="{88508598-67DE-4BE6-BEB8-5B4AD7D639ED}" type="datetime1">
               <a:rPr lang="en-CA" smtClean="0"/>
               <a:t>2026-02-18</a:t>
             </a:fld>
@@ -918,13 +1278,21 @@
         <p:spPr/>
         <p:txBody>
           <a:bodyPr/>
-          <a:lstStyle/>
+          <a:lstStyle>
+            <a:lvl1pPr>
+              <a:defRPr sz="1400">
+                <a:latin typeface="Courier New" panose="02070309020205020404" pitchFamily="49" charset="0"/>
+                <a:cs typeface="Courier New" panose="02070309020205020404" pitchFamily="49" charset="0"/>
+              </a:defRPr>
+            </a:lvl1pPr>
+          </a:lstStyle>
           <a:p>
             <a:fld id="{3899FC77-40C7-4C49-9A19-86BDE9B75E8A}" type="slidenum">
               <a:rPr lang="en-CA" smtClean="0"/>
+              <a:pPr/>
               <a:t>‹#›</a:t>
             </a:fld>
-            <a:endParaRPr lang="en-CA"/>
+            <a:endParaRPr lang="en-CA" sz="1400"/>
           </a:p>
         </p:txBody>
       </p:sp>
@@ -1142,7 +1510,7 @@
           <a:bodyPr/>
           <a:lstStyle/>
           <a:p>
-            <a:fld id="{743CF668-C101-4E7E-94E2-7030205CD9E8}" type="datetimeFigureOut">
+            <a:fld id="{0B6566D1-74AA-4722-8BFB-AF501A2625E3}" type="datetime1">
               <a:rPr lang="en-CA" smtClean="0"/>
               <a:t>2026-02-18</a:t>
             </a:fld>
@@ -1410,7 +1778,7 @@
           <a:bodyPr/>
           <a:lstStyle/>
           <a:p>
-            <a:fld id="{743CF668-C101-4E7E-94E2-7030205CD9E8}" type="datetimeFigureOut">
+            <a:fld id="{478E9686-7AEC-4770-8FC1-AB4CC0356AAE}" type="datetime1">
               <a:rPr lang="en-CA" smtClean="0"/>
               <a:t>2026-02-18</a:t>
             </a:fld>
@@ -1825,7 +2193,7 @@
           <a:bodyPr/>
           <a:lstStyle/>
           <a:p>
-            <a:fld id="{743CF668-C101-4E7E-94E2-7030205CD9E8}" type="datetimeFigureOut">
+            <a:fld id="{03A5280D-47D4-4DF5-B319-35410514E3CC}" type="datetime1">
               <a:rPr lang="en-CA" smtClean="0"/>
               <a:t>2026-02-18</a:t>
             </a:fld>
@@ -1967,7 +2335,7 @@
           <a:bodyPr/>
           <a:lstStyle/>
           <a:p>
-            <a:fld id="{743CF668-C101-4E7E-94E2-7030205CD9E8}" type="datetimeFigureOut">
+            <a:fld id="{0D67DC5A-B795-4EBB-9B22-113083EFA19B}" type="datetime1">
               <a:rPr lang="en-CA" smtClean="0"/>
               <a:t>2026-02-18</a:t>
             </a:fld>
@@ -2080,7 +2448,7 @@
           <a:bodyPr/>
           <a:lstStyle/>
           <a:p>
-            <a:fld id="{743CF668-C101-4E7E-94E2-7030205CD9E8}" type="datetimeFigureOut">
+            <a:fld id="{39D70E04-2DE6-4889-BBA3-32DCF18A2ACD}" type="datetime1">
               <a:rPr lang="en-CA" smtClean="0"/>
               <a:t>2026-02-18</a:t>
             </a:fld>
@@ -2393,7 +2761,7 @@
           <a:bodyPr/>
           <a:lstStyle/>
           <a:p>
-            <a:fld id="{743CF668-C101-4E7E-94E2-7030205CD9E8}" type="datetimeFigureOut">
+            <a:fld id="{64944DBB-4E79-48BF-AC5B-24508B3912E5}" type="datetime1">
               <a:rPr lang="en-CA" smtClean="0"/>
               <a:t>2026-02-18</a:t>
             </a:fld>
@@ -2682,7 +3050,7 @@
           <a:bodyPr/>
           <a:lstStyle/>
           <a:p>
-            <a:fld id="{743CF668-C101-4E7E-94E2-7030205CD9E8}" type="datetimeFigureOut">
+            <a:fld id="{95DF3298-8659-4232-B7C2-DF6F20A13C97}" type="datetime1">
               <a:rPr lang="en-CA" smtClean="0"/>
               <a:t>2026-02-18</a:t>
             </a:fld>
@@ -2925,7 +3293,7 @@
             </a:lvl1pPr>
           </a:lstStyle>
           <a:p>
-            <a:fld id="{743CF668-C101-4E7E-94E2-7030205CD9E8}" type="datetimeFigureOut">
+            <a:fld id="{615BB033-F7A7-49F1-99DC-A2B1E1BC777C}" type="datetime1">
               <a:rPr lang="en-CA" smtClean="0"/>
               <a:t>2026-02-18</a:t>
             </a:fld>
@@ -3044,6 +3412,7 @@
     <p:sldLayoutId id="2147483658" r:id="rId10"/>
     <p:sldLayoutId id="2147483659" r:id="rId11"/>
   </p:sldLayoutIdLst>
+  <p:hf hdr="0" ftr="0" dt="0"/>
   <p:txStyles>
     <p:titleStyle>
       <a:lvl1pPr algn="l" defTabSz="914400" rtl="0" eaLnBrk="1" latinLnBrk="0" hangingPunct="1">
@@ -3961,138 +4330,6 @@
           </a:p>
         </p:txBody>
       </p:sp>
-      <p:sp>
-        <p:nvSpPr>
-          <p:cNvPr id="8" name="Slide Number Placeholder 1">
-            <a:extLst>
-              <a:ext uri="{FF2B5EF4-FFF2-40B4-BE49-F238E27FC236}">
-                <a16:creationId xmlns:a16="http://schemas.microsoft.com/office/drawing/2014/main" id="{85354569-99E2-1605-7A40-A5203823AE33}"/>
-              </a:ext>
-            </a:extLst>
-          </p:cNvPr>
-          <p:cNvSpPr>
-            <a:spLocks noGrp="1"/>
-          </p:cNvSpPr>
-          <p:nvPr/>
-        </p:nvSpPr>
-        <p:spPr>
-          <a:xfrm>
-            <a:off x="9342377" y="6444929"/>
-            <a:ext cx="2743200" cy="365125"/>
-          </a:xfrm>
-          <a:prstGeom prst="rect">
-            <a:avLst/>
-          </a:prstGeom>
-        </p:spPr>
-        <p:txBody>
-          <a:bodyPr vert="horz" lIns="91440" tIns="45720" rIns="91440" bIns="45720" rtlCol="0" anchor="ctr"/>
-          <a:lstStyle>
-            <a:defPPr>
-              <a:defRPr lang="en-US"/>
-            </a:defPPr>
-            <a:lvl1pPr marL="0" algn="r" defTabSz="914400" rtl="0" eaLnBrk="1" latinLnBrk="0" hangingPunct="1">
-              <a:defRPr sz="1200" kern="1200">
-                <a:solidFill>
-                  <a:schemeClr val="tx1">
-                    <a:tint val="82000"/>
-                  </a:schemeClr>
-                </a:solidFill>
-                <a:latin typeface="+mn-lt"/>
-                <a:ea typeface="+mn-ea"/>
-                <a:cs typeface="+mn-cs"/>
-              </a:defRPr>
-            </a:lvl1pPr>
-            <a:lvl2pPr marL="457200" algn="l" defTabSz="914400" rtl="0" eaLnBrk="1" latinLnBrk="0" hangingPunct="1">
-              <a:defRPr sz="1800" kern="1200">
-                <a:solidFill>
-                  <a:schemeClr val="tx1"/>
-                </a:solidFill>
-                <a:latin typeface="+mn-lt"/>
-                <a:ea typeface="+mn-ea"/>
-                <a:cs typeface="+mn-cs"/>
-              </a:defRPr>
-            </a:lvl2pPr>
-            <a:lvl3pPr marL="914400" algn="l" defTabSz="914400" rtl="0" eaLnBrk="1" latinLnBrk="0" hangingPunct="1">
-              <a:defRPr sz="1800" kern="1200">
-                <a:solidFill>
-                  <a:schemeClr val="tx1"/>
-                </a:solidFill>
-                <a:latin typeface="+mn-lt"/>
-                <a:ea typeface="+mn-ea"/>
-                <a:cs typeface="+mn-cs"/>
-              </a:defRPr>
-            </a:lvl3pPr>
-            <a:lvl4pPr marL="1371600" algn="l" defTabSz="914400" rtl="0" eaLnBrk="1" latinLnBrk="0" hangingPunct="1">
-              <a:defRPr sz="1800" kern="1200">
-                <a:solidFill>
-                  <a:schemeClr val="tx1"/>
-                </a:solidFill>
-                <a:latin typeface="+mn-lt"/>
-                <a:ea typeface="+mn-ea"/>
-                <a:cs typeface="+mn-cs"/>
-              </a:defRPr>
-            </a:lvl4pPr>
-            <a:lvl5pPr marL="1828800" algn="l" defTabSz="914400" rtl="0" eaLnBrk="1" latinLnBrk="0" hangingPunct="1">
-              <a:defRPr sz="1800" kern="1200">
-                <a:solidFill>
-                  <a:schemeClr val="tx1"/>
-                </a:solidFill>
-                <a:latin typeface="+mn-lt"/>
-                <a:ea typeface="+mn-ea"/>
-                <a:cs typeface="+mn-cs"/>
-              </a:defRPr>
-            </a:lvl5pPr>
-            <a:lvl6pPr marL="2286000" algn="l" defTabSz="914400" rtl="0" eaLnBrk="1" latinLnBrk="0" hangingPunct="1">
-              <a:defRPr sz="1800" kern="1200">
-                <a:solidFill>
-                  <a:schemeClr val="tx1"/>
-                </a:solidFill>
-                <a:latin typeface="+mn-lt"/>
-                <a:ea typeface="+mn-ea"/>
-                <a:cs typeface="+mn-cs"/>
-              </a:defRPr>
-            </a:lvl6pPr>
-            <a:lvl7pPr marL="2743200" algn="l" defTabSz="914400" rtl="0" eaLnBrk="1" latinLnBrk="0" hangingPunct="1">
-              <a:defRPr sz="1800" kern="1200">
-                <a:solidFill>
-                  <a:schemeClr val="tx1"/>
-                </a:solidFill>
-                <a:latin typeface="+mn-lt"/>
-                <a:ea typeface="+mn-ea"/>
-                <a:cs typeface="+mn-cs"/>
-              </a:defRPr>
-            </a:lvl7pPr>
-            <a:lvl8pPr marL="3200400" algn="l" defTabSz="914400" rtl="0" eaLnBrk="1" latinLnBrk="0" hangingPunct="1">
-              <a:defRPr sz="1800" kern="1200">
-                <a:solidFill>
-                  <a:schemeClr val="tx1"/>
-                </a:solidFill>
-                <a:latin typeface="+mn-lt"/>
-                <a:ea typeface="+mn-ea"/>
-                <a:cs typeface="+mn-cs"/>
-              </a:defRPr>
-            </a:lvl8pPr>
-            <a:lvl9pPr marL="3657600" algn="l" defTabSz="914400" rtl="0" eaLnBrk="1" latinLnBrk="0" hangingPunct="1">
-              <a:defRPr sz="1800" kern="1200">
-                <a:solidFill>
-                  <a:schemeClr val="tx1"/>
-                </a:solidFill>
-                <a:latin typeface="+mn-lt"/>
-                <a:ea typeface="+mn-ea"/>
-                <a:cs typeface="+mn-cs"/>
-              </a:defRPr>
-            </a:lvl9pPr>
-          </a:lstStyle>
-          <a:p>
-            <a:fld id="{67270207-DBFD-445B-A728-4AD6C90BB02C}" type="slidenum">
-              <a:rPr lang="en-US" smtClean="0"/>
-              <a:pPr/>
-              <a:t>1</a:t>
-            </a:fld>
-            <a:endParaRPr lang="en-US"/>
-          </a:p>
-        </p:txBody>
-      </p:sp>
       <p:pic>
         <p:nvPicPr>
           <p:cNvPr id="9" name="Picture 8">
@@ -4165,6 +4402,46 @@
           </a:prstGeom>
         </p:spPr>
       </p:pic>
+      <p:sp>
+        <p:nvSpPr>
+          <p:cNvPr id="14" name="Slide Number Placeholder 13">
+            <a:extLst>
+              <a:ext uri="{FF2B5EF4-FFF2-40B4-BE49-F238E27FC236}">
+                <a16:creationId xmlns:a16="http://schemas.microsoft.com/office/drawing/2014/main" id="{DF5741F7-B930-FEB1-2686-BEC1482FA26B}"/>
+              </a:ext>
+            </a:extLst>
+          </p:cNvPr>
+          <p:cNvSpPr>
+            <a:spLocks noGrp="1"/>
+          </p:cNvSpPr>
+          <p:nvPr>
+            <p:ph type="sldNum" sz="quarter" idx="12"/>
+          </p:nvPr>
+        </p:nvSpPr>
+        <p:spPr>
+          <a:xfrm>
+            <a:off x="9411321" y="6492875"/>
+            <a:ext cx="2743200" cy="365125"/>
+          </a:xfrm>
+        </p:spPr>
+        <p:txBody>
+          <a:bodyPr/>
+          <a:lstStyle/>
+          <a:p>
+            <a:fld id="{3899FC77-40C7-4C49-9A19-86BDE9B75E8A}" type="slidenum">
+              <a:rPr lang="en-CA" smtClean="0">
+                <a:latin typeface="Courier New" panose="02070309020205020404" pitchFamily="49" charset="0"/>
+                <a:cs typeface="Courier New" panose="02070309020205020404" pitchFamily="49" charset="0"/>
+              </a:rPr>
+              <a:t>1</a:t>
+            </a:fld>
+            <a:endParaRPr lang="en-CA">
+              <a:latin typeface="Courier New" panose="02070309020205020404" pitchFamily="49" charset="0"/>
+              <a:cs typeface="Courier New" panose="02070309020205020404" pitchFamily="49" charset="0"/>
+            </a:endParaRPr>
+          </a:p>
+        </p:txBody>
+      </p:sp>
     </p:spTree>
     <p:extLst>
       <p:ext uri="{BB962C8B-B14F-4D97-AF65-F5344CB8AC3E}">
@@ -4215,6 +4492,1553 @@
         </p:nvSpPr>
         <p:spPr>
           <a:xfrm>
+            <a:off x="845609" y="372998"/>
+            <a:ext cx="4704799" cy="649225"/>
+          </a:xfrm>
+          <a:prstGeom prst="roundRect">
+            <a:avLst/>
+          </a:prstGeom>
+          <a:solidFill>
+            <a:srgbClr val="0162B3"/>
+          </a:solidFill>
+          <a:ln>
+            <a:solidFill>
+              <a:srgbClr val="0162B3"/>
+            </a:solidFill>
+          </a:ln>
+        </p:spPr>
+        <p:style>
+          <a:lnRef idx="2">
+            <a:schemeClr val="accent1">
+              <a:shade val="50000"/>
+            </a:schemeClr>
+          </a:lnRef>
+          <a:fillRef idx="1">
+            <a:schemeClr val="accent1"/>
+          </a:fillRef>
+          <a:effectRef idx="0">
+            <a:schemeClr val="accent1"/>
+          </a:effectRef>
+          <a:fontRef idx="minor">
+            <a:schemeClr val="lt1"/>
+          </a:fontRef>
+        </p:style>
+        <p:txBody>
+          <a:bodyPr rtlCol="0" anchor="ctr"/>
+          <a:lstStyle>
+            <a:defPPr>
+              <a:defRPr lang="en-US"/>
+            </a:defPPr>
+            <a:lvl1pPr marL="0" algn="l" defTabSz="914400" rtl="0" eaLnBrk="1" latinLnBrk="0" hangingPunct="1">
+              <a:defRPr sz="1800" kern="1200">
+                <a:solidFill>
+                  <a:schemeClr val="lt1"/>
+                </a:solidFill>
+                <a:latin typeface="+mn-lt"/>
+                <a:ea typeface="+mn-ea"/>
+                <a:cs typeface="+mn-cs"/>
+              </a:defRPr>
+            </a:lvl1pPr>
+            <a:lvl2pPr marL="457200" algn="l" defTabSz="914400" rtl="0" eaLnBrk="1" latinLnBrk="0" hangingPunct="1">
+              <a:defRPr sz="1800" kern="1200">
+                <a:solidFill>
+                  <a:schemeClr val="lt1"/>
+                </a:solidFill>
+                <a:latin typeface="+mn-lt"/>
+                <a:ea typeface="+mn-ea"/>
+                <a:cs typeface="+mn-cs"/>
+              </a:defRPr>
+            </a:lvl2pPr>
+            <a:lvl3pPr marL="914400" algn="l" defTabSz="914400" rtl="0" eaLnBrk="1" latinLnBrk="0" hangingPunct="1">
+              <a:defRPr sz="1800" kern="1200">
+                <a:solidFill>
+                  <a:schemeClr val="lt1"/>
+                </a:solidFill>
+                <a:latin typeface="+mn-lt"/>
+                <a:ea typeface="+mn-ea"/>
+                <a:cs typeface="+mn-cs"/>
+              </a:defRPr>
+            </a:lvl3pPr>
+            <a:lvl4pPr marL="1371600" algn="l" defTabSz="914400" rtl="0" eaLnBrk="1" latinLnBrk="0" hangingPunct="1">
+              <a:defRPr sz="1800" kern="1200">
+                <a:solidFill>
+                  <a:schemeClr val="lt1"/>
+                </a:solidFill>
+                <a:latin typeface="+mn-lt"/>
+                <a:ea typeface="+mn-ea"/>
+                <a:cs typeface="+mn-cs"/>
+              </a:defRPr>
+            </a:lvl4pPr>
+            <a:lvl5pPr marL="1828800" algn="l" defTabSz="914400" rtl="0" eaLnBrk="1" latinLnBrk="0" hangingPunct="1">
+              <a:defRPr sz="1800" kern="1200">
+                <a:solidFill>
+                  <a:schemeClr val="lt1"/>
+                </a:solidFill>
+                <a:latin typeface="+mn-lt"/>
+                <a:ea typeface="+mn-ea"/>
+                <a:cs typeface="+mn-cs"/>
+              </a:defRPr>
+            </a:lvl5pPr>
+            <a:lvl6pPr marL="2286000" algn="l" defTabSz="914400" rtl="0" eaLnBrk="1" latinLnBrk="0" hangingPunct="1">
+              <a:defRPr sz="1800" kern="1200">
+                <a:solidFill>
+                  <a:schemeClr val="lt1"/>
+                </a:solidFill>
+                <a:latin typeface="+mn-lt"/>
+                <a:ea typeface="+mn-ea"/>
+                <a:cs typeface="+mn-cs"/>
+              </a:defRPr>
+            </a:lvl6pPr>
+            <a:lvl7pPr marL="2743200" algn="l" defTabSz="914400" rtl="0" eaLnBrk="1" latinLnBrk="0" hangingPunct="1">
+              <a:defRPr sz="1800" kern="1200">
+                <a:solidFill>
+                  <a:schemeClr val="lt1"/>
+                </a:solidFill>
+                <a:latin typeface="+mn-lt"/>
+                <a:ea typeface="+mn-ea"/>
+                <a:cs typeface="+mn-cs"/>
+              </a:defRPr>
+            </a:lvl7pPr>
+            <a:lvl8pPr marL="3200400" algn="l" defTabSz="914400" rtl="0" eaLnBrk="1" latinLnBrk="0" hangingPunct="1">
+              <a:defRPr sz="1800" kern="1200">
+                <a:solidFill>
+                  <a:schemeClr val="lt1"/>
+                </a:solidFill>
+                <a:latin typeface="+mn-lt"/>
+                <a:ea typeface="+mn-ea"/>
+                <a:cs typeface="+mn-cs"/>
+              </a:defRPr>
+            </a:lvl8pPr>
+            <a:lvl9pPr marL="3657600" algn="l" defTabSz="914400" rtl="0" eaLnBrk="1" latinLnBrk="0" hangingPunct="1">
+              <a:defRPr sz="1800" kern="1200">
+                <a:solidFill>
+                  <a:schemeClr val="lt1"/>
+                </a:solidFill>
+                <a:latin typeface="+mn-lt"/>
+                <a:ea typeface="+mn-ea"/>
+                <a:cs typeface="+mn-cs"/>
+              </a:defRPr>
+            </a:lvl9pPr>
+          </a:lstStyle>
+          <a:p>
+            <a:pPr algn="ctr"/>
+            <a:endParaRPr lang="en-CA"/>
+          </a:p>
+        </p:txBody>
+      </p:sp>
+      <mc:AlternateContent xmlns:mc="http://schemas.openxmlformats.org/markup-compatibility/2006">
+        <mc:Choice xmlns:a14="http://schemas.microsoft.com/office/drawing/2010/main" Requires="a14">
+          <p:sp>
+            <p:nvSpPr>
+              <p:cNvPr id="5" name="TextBox 4">
+                <a:extLst>
+                  <a:ext uri="{FF2B5EF4-FFF2-40B4-BE49-F238E27FC236}">
+                    <a16:creationId xmlns:a16="http://schemas.microsoft.com/office/drawing/2014/main" id="{04816639-416F-378A-9CD6-0190AB9F607C}"/>
+                  </a:ext>
+                </a:extLst>
+              </p:cNvPr>
+              <p:cNvSpPr txBox="1"/>
+              <p:nvPr/>
+            </p:nvSpPr>
+            <p:spPr>
+              <a:xfrm>
+                <a:off x="845609" y="1437005"/>
+                <a:ext cx="6863291" cy="2893100"/>
+              </a:xfrm>
+              <a:prstGeom prst="rect">
+                <a:avLst/>
+              </a:prstGeom>
+              <a:noFill/>
+            </p:spPr>
+            <p:txBody>
+              <a:bodyPr wrap="square" rtlCol="0">
+                <a:spAutoFit/>
+              </a:bodyPr>
+              <a:lstStyle/>
+              <a:p>
+                <a:pPr algn="just">
+                  <a:spcAft>
+                    <a:spcPts val="1200"/>
+                  </a:spcAft>
+                </a:pPr>
+                <a:r>
+                  <a:rPr lang="en-US" b="1">
+                    <a:latin typeface="Georgia Pro" panose="02040502050405020303" pitchFamily="18" charset="0"/>
+                  </a:rPr>
+                  <a:t>Foldseek</a:t>
+                </a:r>
+                <a:r>
+                  <a:rPr lang="en-US">
+                    <a:latin typeface="Georgia Pro" panose="02040502050405020303" pitchFamily="18" charset="0"/>
+                  </a:rPr>
+                  <a:t>, a structure search algorithm, depends on </a:t>
+                </a:r>
+                <a:r>
+                  <a:rPr lang="en-US" b="1">
+                    <a:latin typeface="Georgia Pro" panose="02040502050405020303" pitchFamily="18" charset="0"/>
+                  </a:rPr>
+                  <a:t>3Di</a:t>
+                </a:r>
+                <a:r>
+                  <a:rPr lang="en-US">
+                    <a:latin typeface="Georgia Pro" panose="02040502050405020303" pitchFamily="18" charset="0"/>
+                  </a:rPr>
+                  <a:t>, a method for representing 3D folded protein structures as one-dimensional sequences of a 20-letter code.</a:t>
+                </a:r>
+                <a:r>
+                  <a:rPr lang="en-US" baseline="30000">
+                    <a:latin typeface="Georgia Pro" panose="02040502050405020303" pitchFamily="18" charset="0"/>
+                  </a:rPr>
+                  <a:t>1</a:t>
+                </a:r>
+                <a:endParaRPr lang="en-US">
+                  <a:latin typeface="Georgia Pro" panose="02040502050405020303" pitchFamily="18" charset="0"/>
+                  <a:cs typeface="Courier New" panose="02070309020205020404" pitchFamily="49" charset="0"/>
+                </a:endParaRPr>
+              </a:p>
+              <a:p>
+                <a:pPr algn="just">
+                  <a:spcAft>
+                    <a:spcPts val="1200"/>
+                  </a:spcAft>
+                </a:pPr>
+                <a:r>
+                  <a:rPr lang="en-US">
+                    <a:latin typeface="Georgia Pro" panose="02040502050405020303" pitchFamily="18" charset="0"/>
+                    <a:cs typeface="Courier New" panose="02070309020205020404" pitchFamily="49" charset="0"/>
+                  </a:rPr>
+                  <a:t>Each character in the 20-letter code is represented in the latent space between an autoencoder and decoder neural network.</a:t>
+                </a:r>
+              </a:p>
+              <a:p>
+                <a:pPr algn="just">
+                  <a:spcAft>
+                    <a:spcPts val="1200"/>
+                  </a:spcAft>
+                </a:pPr>
+                <a:r>
+                  <a:rPr lang="en-US">
+                    <a:latin typeface="Georgia Pro" panose="02040502050405020303" pitchFamily="18" charset="0"/>
+                    <a:cs typeface="Courier New" panose="02070309020205020404" pitchFamily="49" charset="0"/>
+                  </a:rPr>
+                  <a:t>The autoencoder receives as input a 10-dimensional feature vector, where the features encapsulate the spatial relatinship between two nearest spatial neighbor residues, </a:t>
+                </a:r>
+                <a14:m>
+                  <m:oMath xmlns:m="http://schemas.openxmlformats.org/officeDocument/2006/math">
+                    <m:r>
+                      <a:rPr lang="en-US" b="0" i="1" smtClean="0">
+                        <a:latin typeface="Cambria Math" panose="02040503050406030204" pitchFamily="18" charset="0"/>
+                        <a:cs typeface="Courier New" panose="02070309020205020404" pitchFamily="49" charset="0"/>
+                      </a:rPr>
+                      <m:t>𝑖</m:t>
+                    </m:r>
+                  </m:oMath>
+                </a14:m>
+                <a:r>
+                  <a:rPr lang="en-US">
+                    <a:latin typeface="Georgia Pro" panose="02040502050405020303" pitchFamily="18" charset="0"/>
+                    <a:cs typeface="Courier New" panose="02070309020205020404" pitchFamily="49" charset="0"/>
+                  </a:rPr>
+                  <a:t> and </a:t>
+                </a:r>
+                <a14:m>
+                  <m:oMath xmlns:m="http://schemas.openxmlformats.org/officeDocument/2006/math">
+                    <m:r>
+                      <a:rPr lang="en-US" b="0" i="1" smtClean="0">
+                        <a:latin typeface="Cambria Math" panose="02040503050406030204" pitchFamily="18" charset="0"/>
+                        <a:cs typeface="Courier New" panose="02070309020205020404" pitchFamily="49" charset="0"/>
+                      </a:rPr>
+                      <m:t>𝑗</m:t>
+                    </m:r>
+                  </m:oMath>
+                </a14:m>
+                <a:r>
+                  <a:rPr lang="en-US">
+                    <a:latin typeface="Georgia Pro" panose="02040502050405020303" pitchFamily="18" charset="0"/>
+                    <a:cs typeface="Courier New" panose="02070309020205020404" pitchFamily="49" charset="0"/>
+                  </a:rPr>
+                  <a:t>, in the 3D structure.</a:t>
+                </a:r>
+              </a:p>
+            </p:txBody>
+          </p:sp>
+        </mc:Choice>
+        <mc:Fallback>
+          <p:sp>
+            <p:nvSpPr>
+              <p:cNvPr id="5" name="TextBox 4">
+                <a:extLst>
+                  <a:ext uri="{FF2B5EF4-FFF2-40B4-BE49-F238E27FC236}">
+                    <a16:creationId xmlns:a16="http://schemas.microsoft.com/office/drawing/2014/main" id="{04816639-416F-378A-9CD6-0190AB9F607C}"/>
+                  </a:ext>
+                </a:extLst>
+              </p:cNvPr>
+              <p:cNvSpPr txBox="1">
+                <a:spLocks noRot="1" noChangeAspect="1" noMove="1" noResize="1" noEditPoints="1" noAdjustHandles="1" noChangeArrowheads="1" noChangeShapeType="1" noTextEdit="1"/>
+              </p:cNvSpPr>
+              <p:nvPr/>
+            </p:nvSpPr>
+            <p:spPr>
+              <a:xfrm>
+                <a:off x="845609" y="1437005"/>
+                <a:ext cx="6863291" cy="2893100"/>
+              </a:xfrm>
+              <a:prstGeom prst="rect">
+                <a:avLst/>
+              </a:prstGeom>
+              <a:blipFill>
+                <a:blip r:embed="rId2"/>
+                <a:stretch>
+                  <a:fillRect l="-799" t="-1266" r="-710" b="-2532"/>
+                </a:stretch>
+              </a:blipFill>
+            </p:spPr>
+            <p:txBody>
+              <a:bodyPr/>
+              <a:lstStyle/>
+              <a:p>
+                <a:r>
+                  <a:rPr lang="en-CA">
+                    <a:noFill/>
+                  </a:rPr>
+                  <a:t> </a:t>
+                </a:r>
+              </a:p>
+            </p:txBody>
+          </p:sp>
+        </mc:Fallback>
+      </mc:AlternateContent>
+      <p:sp>
+        <p:nvSpPr>
+          <p:cNvPr id="6" name="TextBox 5">
+            <a:extLst>
+              <a:ext uri="{FF2B5EF4-FFF2-40B4-BE49-F238E27FC236}">
+                <a16:creationId xmlns:a16="http://schemas.microsoft.com/office/drawing/2014/main" id="{D8F04AFD-2ACE-842C-9BD9-ECC48CC83FE5}"/>
+              </a:ext>
+            </a:extLst>
+          </p:cNvPr>
+          <p:cNvSpPr txBox="1"/>
+          <p:nvPr/>
+        </p:nvSpPr>
+        <p:spPr>
+          <a:xfrm>
+            <a:off x="987552" y="485512"/>
+            <a:ext cx="3538728" cy="461665"/>
+          </a:xfrm>
+          <a:prstGeom prst="rect">
+            <a:avLst/>
+          </a:prstGeom>
+          <a:noFill/>
+        </p:spPr>
+        <p:txBody>
+          <a:bodyPr wrap="square" rtlCol="0">
+            <a:spAutoFit/>
+          </a:bodyPr>
+          <a:lstStyle/>
+          <a:p>
+            <a:r>
+              <a:rPr lang="en-US" sz="2400" b="1">
+                <a:solidFill>
+                  <a:schemeClr val="bg1"/>
+                </a:solidFill>
+                <a:latin typeface="Georgia Pro" panose="02040502050405020303" pitchFamily="18" charset="0"/>
+              </a:rPr>
+              <a:t>Background</a:t>
+            </a:r>
+          </a:p>
+        </p:txBody>
+      </p:sp>
+      <p:pic>
+        <p:nvPicPr>
+          <p:cNvPr id="3" name="Picture 2">
+            <a:extLst>
+              <a:ext uri="{FF2B5EF4-FFF2-40B4-BE49-F238E27FC236}">
+                <a16:creationId xmlns:a16="http://schemas.microsoft.com/office/drawing/2014/main" id="{893D8A36-3BEF-0B0F-88D9-198D07053458}"/>
+              </a:ext>
+            </a:extLst>
+          </p:cNvPr>
+          <p:cNvPicPr>
+            <a:picLocks noChangeAspect="1"/>
+          </p:cNvPicPr>
+          <p:nvPr/>
+        </p:nvPicPr>
+        <p:blipFill>
+          <a:blip r:embed="rId3"/>
+          <a:stretch>
+            <a:fillRect/>
+          </a:stretch>
+        </p:blipFill>
+        <p:spPr>
+          <a:xfrm>
+            <a:off x="7965143" y="1285875"/>
+            <a:ext cx="3740193" cy="4305300"/>
+          </a:xfrm>
+          <a:prstGeom prst="rect">
+            <a:avLst/>
+          </a:prstGeom>
+        </p:spPr>
+      </p:pic>
+      <p:sp>
+        <p:nvSpPr>
+          <p:cNvPr id="7" name="TextBox 6">
+            <a:extLst>
+              <a:ext uri="{FF2B5EF4-FFF2-40B4-BE49-F238E27FC236}">
+                <a16:creationId xmlns:a16="http://schemas.microsoft.com/office/drawing/2014/main" id="{3B20CF7E-876A-A8A2-F053-557327004AF5}"/>
+              </a:ext>
+            </a:extLst>
+          </p:cNvPr>
+          <p:cNvSpPr txBox="1"/>
+          <p:nvPr/>
+        </p:nvSpPr>
+        <p:spPr>
+          <a:xfrm>
+            <a:off x="8162036" y="5705475"/>
+            <a:ext cx="3543300" cy="523220"/>
+          </a:xfrm>
+          <a:prstGeom prst="rect">
+            <a:avLst/>
+          </a:prstGeom>
+          <a:noFill/>
+        </p:spPr>
+        <p:txBody>
+          <a:bodyPr wrap="square" rtlCol="0">
+            <a:spAutoFit/>
+          </a:bodyPr>
+          <a:lstStyle/>
+          <a:p>
+            <a:r>
+              <a:rPr lang="en-US" sz="1400">
+                <a:solidFill>
+                  <a:schemeClr val="bg1">
+                    <a:lumMod val="75000"/>
+                  </a:schemeClr>
+                </a:solidFill>
+                <a:latin typeface="Georgia Pro" panose="02040502050405020303" pitchFamily="18" charset="0"/>
+              </a:rPr>
+              <a:t>Adapted from Barrio-Hernendez et al. 2023.</a:t>
+            </a:r>
+            <a:r>
+              <a:rPr lang="en-US" sz="1400" baseline="30000">
+                <a:solidFill>
+                  <a:schemeClr val="bg1">
+                    <a:lumMod val="75000"/>
+                  </a:schemeClr>
+                </a:solidFill>
+                <a:latin typeface="Georgia Pro" panose="02040502050405020303" pitchFamily="18" charset="0"/>
+              </a:rPr>
+              <a:t>1</a:t>
+            </a:r>
+            <a:endParaRPr lang="en-CA" sz="1400">
+              <a:solidFill>
+                <a:schemeClr val="bg1">
+                  <a:lumMod val="75000"/>
+                </a:schemeClr>
+              </a:solidFill>
+              <a:latin typeface="Georgia Pro" panose="02040502050405020303" pitchFamily="18" charset="0"/>
+            </a:endParaRPr>
+          </a:p>
+        </p:txBody>
+      </p:sp>
+      <p:sp>
+        <p:nvSpPr>
+          <p:cNvPr id="8" name="Slide Number Placeholder 7">
+            <a:extLst>
+              <a:ext uri="{FF2B5EF4-FFF2-40B4-BE49-F238E27FC236}">
+                <a16:creationId xmlns:a16="http://schemas.microsoft.com/office/drawing/2014/main" id="{6B07C51B-63F3-FEA2-5137-35C3AF8281F4}"/>
+              </a:ext>
+            </a:extLst>
+          </p:cNvPr>
+          <p:cNvSpPr>
+            <a:spLocks noGrp="1"/>
+          </p:cNvSpPr>
+          <p:nvPr>
+            <p:ph type="sldNum" sz="quarter" idx="12"/>
+          </p:nvPr>
+        </p:nvSpPr>
+        <p:spPr/>
+        <p:txBody>
+          <a:bodyPr/>
+          <a:lstStyle/>
+          <a:p>
+            <a:fld id="{3899FC77-40C7-4C49-9A19-86BDE9B75E8A}" type="slidenum">
+              <a:rPr lang="en-CA" sz="1400" smtClean="0">
+                <a:latin typeface="Courier New" panose="02070309020205020404" pitchFamily="49" charset="0"/>
+                <a:cs typeface="Courier New" panose="02070309020205020404" pitchFamily="49" charset="0"/>
+              </a:rPr>
+              <a:t>2</a:t>
+            </a:fld>
+            <a:endParaRPr lang="en-CA" sz="1400">
+              <a:latin typeface="Courier New" panose="02070309020205020404" pitchFamily="49" charset="0"/>
+              <a:cs typeface="Courier New" panose="02070309020205020404" pitchFamily="49" charset="0"/>
+            </a:endParaRPr>
+          </a:p>
+        </p:txBody>
+      </p:sp>
+      <mc:AlternateContent xmlns:mc="http://schemas.openxmlformats.org/markup-compatibility/2006">
+        <mc:Choice xmlns:a14="http://schemas.microsoft.com/office/drawing/2010/main" Requires="a14">
+          <p:sp>
+            <p:nvSpPr>
+              <p:cNvPr id="9" name="TextBox 8">
+                <a:extLst>
+                  <a:ext uri="{FF2B5EF4-FFF2-40B4-BE49-F238E27FC236}">
+                    <a16:creationId xmlns:a16="http://schemas.microsoft.com/office/drawing/2014/main" id="{0A097EA0-0839-740D-BBC5-BA05C224566A}"/>
+                  </a:ext>
+                </a:extLst>
+              </p:cNvPr>
+              <p:cNvSpPr txBox="1"/>
+              <p:nvPr/>
+            </p:nvSpPr>
+            <p:spPr>
+              <a:xfrm>
+                <a:off x="3271626" y="5191111"/>
+                <a:ext cx="1646131" cy="381515"/>
+              </a:xfrm>
+              <a:prstGeom prst="rect">
+                <a:avLst/>
+              </a:prstGeom>
+              <a:noFill/>
+            </p:spPr>
+            <p:txBody>
+              <a:bodyPr wrap="square" rtlCol="0">
+                <a:spAutoFit/>
+              </a:bodyPr>
+              <a:lstStyle/>
+              <a:p>
+                <a:pPr/>
+                <a14:m>
+                  <m:oMathPara xmlns:m="http://schemas.openxmlformats.org/officeDocument/2006/math">
+                    <m:oMathParaPr>
+                      <m:jc m:val="left"/>
+                    </m:oMathParaPr>
+                    <m:oMath xmlns:m="http://schemas.openxmlformats.org/officeDocument/2006/math">
+                      <m:r>
+                        <m:rPr>
+                          <m:sty m:val="p"/>
+                        </m:rPr>
+                        <a:rPr lang="en-US" smtClean="0">
+                          <a:latin typeface="Cambria Math" panose="02040503050406030204" pitchFamily="18" charset="0"/>
+                        </a:rPr>
+                        <m:t>c</m:t>
+                      </m:r>
+                      <m:r>
+                        <m:rPr>
+                          <m:sty m:val="p"/>
+                        </m:rPr>
+                        <a:rPr lang="en-US" b="0" i="0" smtClean="0">
+                          <a:latin typeface="Cambria Math" panose="02040503050406030204" pitchFamily="18" charset="0"/>
+                        </a:rPr>
+                        <m:t>os</m:t>
+                      </m:r>
+                      <m:r>
+                        <a:rPr lang="en-US" b="0" i="1" smtClean="0">
+                          <a:latin typeface="Cambria Math" panose="02040503050406030204" pitchFamily="18" charset="0"/>
+                        </a:rPr>
+                        <m:t>⁡(</m:t>
+                      </m:r>
+                      <m:sSub>
+                        <m:sSubPr>
+                          <m:ctrlPr>
+                            <a:rPr lang="en-US" b="0" i="1" smtClean="0">
+                              <a:latin typeface="Cambria Math" panose="02040503050406030204" pitchFamily="18" charset="0"/>
+                            </a:rPr>
+                          </m:ctrlPr>
+                        </m:sSubPr>
+                        <m:e>
+                          <m:r>
+                            <m:rPr>
+                              <m:sty m:val="p"/>
+                            </m:rPr>
+                            <a:rPr lang="el-GR" b="0" i="1" smtClean="0">
+                              <a:latin typeface="Cambria Math" panose="02040503050406030204" pitchFamily="18" charset="0"/>
+                            </a:rPr>
+                            <m:t>θ</m:t>
+                          </m:r>
+                        </m:e>
+                        <m:sub>
+                          <m:r>
+                            <a:rPr lang="en-US" b="0" i="1" smtClean="0">
+                              <a:latin typeface="Cambria Math" panose="02040503050406030204" pitchFamily="18" charset="0"/>
+                            </a:rPr>
+                            <m:t>𝑢</m:t>
+                          </m:r>
+                          <m:r>
+                            <a:rPr lang="en-US" b="0" i="1" smtClean="0">
+                              <a:latin typeface="Cambria Math" panose="02040503050406030204" pitchFamily="18" charset="0"/>
+                            </a:rPr>
+                            <m:t>1,</m:t>
+                          </m:r>
+                          <m:r>
+                            <a:rPr lang="en-US" b="0" i="1" smtClean="0">
+                              <a:latin typeface="Cambria Math" panose="02040503050406030204" pitchFamily="18" charset="0"/>
+                            </a:rPr>
+                            <m:t>𝑢</m:t>
+                          </m:r>
+                          <m:r>
+                            <a:rPr lang="en-US" b="0" i="1" smtClean="0">
+                              <a:latin typeface="Cambria Math" panose="02040503050406030204" pitchFamily="18" charset="0"/>
+                            </a:rPr>
+                            <m:t>2</m:t>
+                          </m:r>
+                        </m:sub>
+                      </m:sSub>
+                      <m:r>
+                        <a:rPr lang="en-US" b="0" i="1" smtClean="0">
+                          <a:latin typeface="Cambria Math" panose="02040503050406030204" pitchFamily="18" charset="0"/>
+                        </a:rPr>
+                        <m:t>)</m:t>
+                      </m:r>
+                    </m:oMath>
+                  </m:oMathPara>
+                </a14:m>
+                <a:endParaRPr lang="en-CA"/>
+              </a:p>
+            </p:txBody>
+          </p:sp>
+        </mc:Choice>
+        <mc:Fallback>
+          <p:sp>
+            <p:nvSpPr>
+              <p:cNvPr id="9" name="TextBox 8">
+                <a:extLst>
+                  <a:ext uri="{FF2B5EF4-FFF2-40B4-BE49-F238E27FC236}">
+                    <a16:creationId xmlns:a16="http://schemas.microsoft.com/office/drawing/2014/main" id="{0A097EA0-0839-740D-BBC5-BA05C224566A}"/>
+                  </a:ext>
+                </a:extLst>
+              </p:cNvPr>
+              <p:cNvSpPr txBox="1">
+                <a:spLocks noRot="1" noChangeAspect="1" noMove="1" noResize="1" noEditPoints="1" noAdjustHandles="1" noChangeArrowheads="1" noChangeShapeType="1" noTextEdit="1"/>
+              </p:cNvSpPr>
+              <p:nvPr/>
+            </p:nvSpPr>
+            <p:spPr>
+              <a:xfrm>
+                <a:off x="3271626" y="5191111"/>
+                <a:ext cx="1646131" cy="381515"/>
+              </a:xfrm>
+              <a:prstGeom prst="rect">
+                <a:avLst/>
+              </a:prstGeom>
+              <a:blipFill>
+                <a:blip r:embed="rId4"/>
+                <a:stretch>
+                  <a:fillRect b="-11290"/>
+                </a:stretch>
+              </a:blipFill>
+            </p:spPr>
+            <p:txBody>
+              <a:bodyPr/>
+              <a:lstStyle/>
+              <a:p>
+                <a:r>
+                  <a:rPr lang="en-CA">
+                    <a:noFill/>
+                  </a:rPr>
+                  <a:t> </a:t>
+                </a:r>
+              </a:p>
+            </p:txBody>
+          </p:sp>
+        </mc:Fallback>
+      </mc:AlternateContent>
+      <p:grpSp>
+        <p:nvGrpSpPr>
+          <p:cNvPr id="26" name="Group 25">
+            <a:extLst>
+              <a:ext uri="{FF2B5EF4-FFF2-40B4-BE49-F238E27FC236}">
+                <a16:creationId xmlns:a16="http://schemas.microsoft.com/office/drawing/2014/main" id="{F89102A7-DEB7-10AC-BC47-305C94A38F0D}"/>
+              </a:ext>
+            </a:extLst>
+          </p:cNvPr>
+          <p:cNvGrpSpPr/>
+          <p:nvPr/>
+        </p:nvGrpSpPr>
+        <p:grpSpPr>
+          <a:xfrm>
+            <a:off x="845609" y="4497110"/>
+            <a:ext cx="2247900" cy="1859240"/>
+            <a:chOff x="3429000" y="4701580"/>
+            <a:chExt cx="2247900" cy="1859240"/>
+          </a:xfrm>
+        </p:grpSpPr>
+        <p:grpSp>
+          <p:nvGrpSpPr>
+            <p:cNvPr id="24" name="Group 23">
+              <a:extLst>
+                <a:ext uri="{FF2B5EF4-FFF2-40B4-BE49-F238E27FC236}">
+                  <a16:creationId xmlns:a16="http://schemas.microsoft.com/office/drawing/2014/main" id="{830FEDEF-A6D4-B643-28F3-BD73A8B86D28}"/>
+                </a:ext>
+              </a:extLst>
+            </p:cNvPr>
+            <p:cNvGrpSpPr/>
+            <p:nvPr/>
+          </p:nvGrpSpPr>
+          <p:grpSpPr>
+            <a:xfrm>
+              <a:off x="3513709" y="4728253"/>
+              <a:ext cx="2096337" cy="1765086"/>
+              <a:chOff x="3772468" y="4478224"/>
+              <a:chExt cx="2096337" cy="1765086"/>
+            </a:xfrm>
+          </p:grpSpPr>
+          <p:cxnSp>
+            <p:nvCxnSpPr>
+              <p:cNvPr id="11" name="Straight Arrow Connector 10">
+                <a:extLst>
+                  <a:ext uri="{FF2B5EF4-FFF2-40B4-BE49-F238E27FC236}">
+                    <a16:creationId xmlns:a16="http://schemas.microsoft.com/office/drawing/2014/main" id="{75B8B62C-C308-1240-FE4A-5E9301A9EB87}"/>
+                  </a:ext>
+                </a:extLst>
+              </p:cNvPr>
+              <p:cNvCxnSpPr/>
+              <p:nvPr/>
+            </p:nvCxnSpPr>
+            <p:spPr>
+              <a:xfrm flipV="1">
+                <a:off x="4277254" y="4838756"/>
+                <a:ext cx="790575" cy="781050"/>
+              </a:xfrm>
+              <a:prstGeom prst="straightConnector1">
+                <a:avLst/>
+              </a:prstGeom>
+              <a:ln>
+                <a:solidFill>
+                  <a:schemeClr val="tx1"/>
+                </a:solidFill>
+                <a:tailEnd type="triangle"/>
+              </a:ln>
+            </p:spPr>
+            <p:style>
+              <a:lnRef idx="2">
+                <a:schemeClr val="accent1"/>
+              </a:lnRef>
+              <a:fillRef idx="0">
+                <a:schemeClr val="accent1"/>
+              </a:fillRef>
+              <a:effectRef idx="1">
+                <a:schemeClr val="accent1"/>
+              </a:effectRef>
+              <a:fontRef idx="minor">
+                <a:schemeClr val="tx1"/>
+              </a:fontRef>
+            </p:style>
+          </p:cxnSp>
+          <p:cxnSp>
+            <p:nvCxnSpPr>
+              <p:cNvPr id="12" name="Straight Arrow Connector 11">
+                <a:extLst>
+                  <a:ext uri="{FF2B5EF4-FFF2-40B4-BE49-F238E27FC236}">
+                    <a16:creationId xmlns:a16="http://schemas.microsoft.com/office/drawing/2014/main" id="{0BEEFF29-395D-EA53-5368-C2D138D71E05}"/>
+                  </a:ext>
+                </a:extLst>
+              </p:cNvPr>
+              <p:cNvCxnSpPr>
+                <a:cxnSpLocks/>
+              </p:cNvCxnSpPr>
+              <p:nvPr/>
+            </p:nvCxnSpPr>
+            <p:spPr>
+              <a:xfrm>
+                <a:off x="4277254" y="5619806"/>
+                <a:ext cx="1024256" cy="247594"/>
+              </a:xfrm>
+              <a:prstGeom prst="straightConnector1">
+                <a:avLst/>
+              </a:prstGeom>
+              <a:ln>
+                <a:solidFill>
+                  <a:schemeClr val="tx1"/>
+                </a:solidFill>
+                <a:tailEnd type="triangle"/>
+              </a:ln>
+            </p:spPr>
+            <p:style>
+              <a:lnRef idx="2">
+                <a:schemeClr val="accent1"/>
+              </a:lnRef>
+              <a:fillRef idx="0">
+                <a:schemeClr val="accent1"/>
+              </a:fillRef>
+              <a:effectRef idx="1">
+                <a:schemeClr val="accent1"/>
+              </a:effectRef>
+              <a:fontRef idx="minor">
+                <a:schemeClr val="tx1"/>
+              </a:fontRef>
+            </p:style>
+          </p:cxnSp>
+          <p:sp>
+            <p:nvSpPr>
+              <p:cNvPr id="18" name="TextBox 17">
+                <a:extLst>
+                  <a:ext uri="{FF2B5EF4-FFF2-40B4-BE49-F238E27FC236}">
+                    <a16:creationId xmlns:a16="http://schemas.microsoft.com/office/drawing/2014/main" id="{B23771E7-024D-B87A-5196-AD3B6935B3E8}"/>
+                  </a:ext>
+                </a:extLst>
+              </p:cNvPr>
+              <p:cNvSpPr txBox="1"/>
+              <p:nvPr/>
+            </p:nvSpPr>
+            <p:spPr>
+              <a:xfrm>
+                <a:off x="4455371" y="5351411"/>
+                <a:ext cx="434340" cy="369332"/>
+              </a:xfrm>
+              <a:prstGeom prst="rect">
+                <a:avLst/>
+              </a:prstGeom>
+              <a:noFill/>
+            </p:spPr>
+            <p:txBody>
+              <a:bodyPr wrap="square" rtlCol="0">
+                <a:spAutoFit/>
+              </a:bodyPr>
+              <a:lstStyle/>
+              <a:p>
+                <a:r>
+                  <a:rPr lang="el-GR">
+                    <a:latin typeface="Cambria Math" panose="02040503050406030204" pitchFamily="18" charset="0"/>
+                    <a:ea typeface="Cambria Math" panose="02040503050406030204" pitchFamily="18" charset="0"/>
+                  </a:rPr>
+                  <a:t>θ</a:t>
+                </a:r>
+                <a:endParaRPr lang="en-CA">
+                  <a:latin typeface="Cambria Math" panose="02040503050406030204" pitchFamily="18" charset="0"/>
+                  <a:ea typeface="Cambria Math" panose="02040503050406030204" pitchFamily="18" charset="0"/>
+                </a:endParaRPr>
+              </a:p>
+            </p:txBody>
+          </p:sp>
+          <mc:AlternateContent xmlns:mc="http://schemas.openxmlformats.org/markup-compatibility/2006">
+            <mc:Choice xmlns:a14="http://schemas.microsoft.com/office/drawing/2010/main" Requires="a14">
+              <p:sp>
+                <p:nvSpPr>
+                  <p:cNvPr id="19" name="TextBox 18">
+                    <a:extLst>
+                      <a:ext uri="{FF2B5EF4-FFF2-40B4-BE49-F238E27FC236}">
+                        <a16:creationId xmlns:a16="http://schemas.microsoft.com/office/drawing/2014/main" id="{B1625727-0CDF-3232-4C8C-95B4A4D84218}"/>
+                      </a:ext>
+                    </a:extLst>
+                  </p:cNvPr>
+                  <p:cNvSpPr txBox="1"/>
+                  <p:nvPr/>
+                </p:nvSpPr>
+                <p:spPr>
+                  <a:xfrm>
+                    <a:off x="4294081" y="4776220"/>
+                    <a:ext cx="495301" cy="369332"/>
+                  </a:xfrm>
+                  <a:prstGeom prst="rect">
+                    <a:avLst/>
+                  </a:prstGeom>
+                  <a:noFill/>
+                </p:spPr>
+                <p:txBody>
+                  <a:bodyPr wrap="square" rtlCol="0">
+                    <a:spAutoFit/>
+                  </a:bodyPr>
+                  <a:lstStyle/>
+                  <a:p>
+                    <a14:m>
+                      <m:oMathPara xmlns:m="http://schemas.openxmlformats.org/officeDocument/2006/math">
+                        <m:oMathParaPr>
+                          <m:jc m:val="centerGroup"/>
+                        </m:oMathParaPr>
+                        <m:oMath xmlns:m="http://schemas.openxmlformats.org/officeDocument/2006/math">
+                          <m:r>
+                            <a:rPr lang="en-US" i="1" smtClean="0">
+                              <a:latin typeface="Cambria Math" panose="02040503050406030204" pitchFamily="18" charset="0"/>
+                              <a:ea typeface="Cambria Math" panose="02040503050406030204" pitchFamily="18" charset="0"/>
+                            </a:rPr>
+                            <m:t>𝑢</m:t>
+                          </m:r>
+                          <m:r>
+                            <a:rPr lang="en-US" i="1">
+                              <a:latin typeface="Cambria Math" panose="02040503050406030204" pitchFamily="18" charset="0"/>
+                              <a:ea typeface="Cambria Math" panose="02040503050406030204" pitchFamily="18" charset="0"/>
+                            </a:rPr>
+                            <m:t>1</m:t>
+                          </m:r>
+                        </m:oMath>
+                      </m:oMathPara>
+                    </a14:m>
+                    <a:endParaRPr lang="en-CA">
+                      <a:latin typeface="Cambria Math" panose="02040503050406030204" pitchFamily="18" charset="0"/>
+                      <a:ea typeface="Cambria Math" panose="02040503050406030204" pitchFamily="18" charset="0"/>
+                    </a:endParaRPr>
+                  </a:p>
+                </p:txBody>
+              </p:sp>
+            </mc:Choice>
+            <mc:Fallback>
+              <p:sp>
+                <p:nvSpPr>
+                  <p:cNvPr id="19" name="TextBox 18">
+                    <a:extLst>
+                      <a:ext uri="{FF2B5EF4-FFF2-40B4-BE49-F238E27FC236}">
+                        <a16:creationId xmlns:a16="http://schemas.microsoft.com/office/drawing/2014/main" id="{B1625727-0CDF-3232-4C8C-95B4A4D84218}"/>
+                      </a:ext>
+                    </a:extLst>
+                  </p:cNvPr>
+                  <p:cNvSpPr txBox="1">
+                    <a:spLocks noRot="1" noChangeAspect="1" noMove="1" noResize="1" noEditPoints="1" noAdjustHandles="1" noChangeArrowheads="1" noChangeShapeType="1" noTextEdit="1"/>
+                  </p:cNvSpPr>
+                  <p:nvPr/>
+                </p:nvSpPr>
+                <p:spPr>
+                  <a:xfrm>
+                    <a:off x="4294081" y="4776220"/>
+                    <a:ext cx="495301" cy="369332"/>
+                  </a:xfrm>
+                  <a:prstGeom prst="rect">
+                    <a:avLst/>
+                  </a:prstGeom>
+                  <a:blipFill>
+                    <a:blip r:embed="rId5"/>
+                    <a:stretch>
+                      <a:fillRect/>
+                    </a:stretch>
+                  </a:blipFill>
+                </p:spPr>
+                <p:txBody>
+                  <a:bodyPr/>
+                  <a:lstStyle/>
+                  <a:p>
+                    <a:r>
+                      <a:rPr lang="en-CA">
+                        <a:noFill/>
+                      </a:rPr>
+                      <a:t> </a:t>
+                    </a:r>
+                  </a:p>
+                </p:txBody>
+              </p:sp>
+            </mc:Fallback>
+          </mc:AlternateContent>
+          <mc:AlternateContent xmlns:mc="http://schemas.openxmlformats.org/markup-compatibility/2006">
+            <mc:Choice xmlns:a14="http://schemas.microsoft.com/office/drawing/2010/main" Requires="a14">
+              <p:sp>
+                <p:nvSpPr>
+                  <p:cNvPr id="20" name="TextBox 19">
+                    <a:extLst>
+                      <a:ext uri="{FF2B5EF4-FFF2-40B4-BE49-F238E27FC236}">
+                        <a16:creationId xmlns:a16="http://schemas.microsoft.com/office/drawing/2014/main" id="{9F7317A6-2337-8614-16AB-86123AA2E5FB}"/>
+                      </a:ext>
+                    </a:extLst>
+                  </p:cNvPr>
+                  <p:cNvSpPr txBox="1"/>
+                  <p:nvPr/>
+                </p:nvSpPr>
+                <p:spPr>
+                  <a:xfrm>
+                    <a:off x="4395891" y="5873978"/>
+                    <a:ext cx="495301" cy="369332"/>
+                  </a:xfrm>
+                  <a:prstGeom prst="rect">
+                    <a:avLst/>
+                  </a:prstGeom>
+                  <a:noFill/>
+                </p:spPr>
+                <p:txBody>
+                  <a:bodyPr wrap="square" rtlCol="0">
+                    <a:spAutoFit/>
+                  </a:bodyPr>
+                  <a:lstStyle/>
+                  <a:p>
+                    <a14:m>
+                      <m:oMathPara xmlns:m="http://schemas.openxmlformats.org/officeDocument/2006/math">
+                        <m:oMathParaPr>
+                          <m:jc m:val="centerGroup"/>
+                        </m:oMathParaPr>
+                        <m:oMath xmlns:m="http://schemas.openxmlformats.org/officeDocument/2006/math">
+                          <m:r>
+                            <a:rPr lang="en-US" i="1" smtClean="0">
+                              <a:latin typeface="Cambria Math" panose="02040503050406030204" pitchFamily="18" charset="0"/>
+                              <a:ea typeface="Cambria Math" panose="02040503050406030204" pitchFamily="18" charset="0"/>
+                            </a:rPr>
+                            <m:t>𝑢</m:t>
+                          </m:r>
+                          <m:r>
+                            <a:rPr lang="en-US" b="0" i="1" smtClean="0">
+                              <a:latin typeface="Cambria Math" panose="02040503050406030204" pitchFamily="18" charset="0"/>
+                              <a:ea typeface="Cambria Math" panose="02040503050406030204" pitchFamily="18" charset="0"/>
+                            </a:rPr>
+                            <m:t>2</m:t>
+                          </m:r>
+                        </m:oMath>
+                      </m:oMathPara>
+                    </a14:m>
+                    <a:endParaRPr lang="en-CA">
+                      <a:latin typeface="Cambria Math" panose="02040503050406030204" pitchFamily="18" charset="0"/>
+                      <a:ea typeface="Cambria Math" panose="02040503050406030204" pitchFamily="18" charset="0"/>
+                    </a:endParaRPr>
+                  </a:p>
+                </p:txBody>
+              </p:sp>
+            </mc:Choice>
+            <mc:Fallback>
+              <p:sp>
+                <p:nvSpPr>
+                  <p:cNvPr id="20" name="TextBox 19">
+                    <a:extLst>
+                      <a:ext uri="{FF2B5EF4-FFF2-40B4-BE49-F238E27FC236}">
+                        <a16:creationId xmlns:a16="http://schemas.microsoft.com/office/drawing/2014/main" id="{9F7317A6-2337-8614-16AB-86123AA2E5FB}"/>
+                      </a:ext>
+                    </a:extLst>
+                  </p:cNvPr>
+                  <p:cNvSpPr txBox="1">
+                    <a:spLocks noRot="1" noChangeAspect="1" noMove="1" noResize="1" noEditPoints="1" noAdjustHandles="1" noChangeArrowheads="1" noChangeShapeType="1" noTextEdit="1"/>
+                  </p:cNvSpPr>
+                  <p:nvPr/>
+                </p:nvSpPr>
+                <p:spPr>
+                  <a:xfrm>
+                    <a:off x="4395891" y="5873978"/>
+                    <a:ext cx="495301" cy="369332"/>
+                  </a:xfrm>
+                  <a:prstGeom prst="rect">
+                    <a:avLst/>
+                  </a:prstGeom>
+                  <a:blipFill>
+                    <a:blip r:embed="rId6"/>
+                    <a:stretch>
+                      <a:fillRect/>
+                    </a:stretch>
+                  </a:blipFill>
+                </p:spPr>
+                <p:txBody>
+                  <a:bodyPr/>
+                  <a:lstStyle/>
+                  <a:p>
+                    <a:r>
+                      <a:rPr lang="en-CA">
+                        <a:noFill/>
+                      </a:rPr>
+                      <a:t> </a:t>
+                    </a:r>
+                  </a:p>
+                </p:txBody>
+              </p:sp>
+            </mc:Fallback>
+          </mc:AlternateContent>
+          <mc:AlternateContent xmlns:mc="http://schemas.openxmlformats.org/markup-compatibility/2006">
+            <mc:Choice xmlns:a14="http://schemas.microsoft.com/office/drawing/2010/main" Requires="a14">
+              <p:sp>
+                <p:nvSpPr>
+                  <p:cNvPr id="21" name="TextBox 20">
+                    <a:extLst>
+                      <a:ext uri="{FF2B5EF4-FFF2-40B4-BE49-F238E27FC236}">
+                        <a16:creationId xmlns:a16="http://schemas.microsoft.com/office/drawing/2014/main" id="{75933132-7A80-DBF7-9E50-D8A8701C5480}"/>
+                      </a:ext>
+                    </a:extLst>
+                  </p:cNvPr>
+                  <p:cNvSpPr txBox="1"/>
+                  <p:nvPr/>
+                </p:nvSpPr>
+                <p:spPr>
+                  <a:xfrm>
+                    <a:off x="3772468" y="5536077"/>
+                    <a:ext cx="495301" cy="381515"/>
+                  </a:xfrm>
+                  <a:prstGeom prst="rect">
+                    <a:avLst/>
+                  </a:prstGeom>
+                  <a:noFill/>
+                </p:spPr>
+                <p:txBody>
+                  <a:bodyPr wrap="square" rtlCol="0">
+                    <a:spAutoFit/>
+                  </a:bodyPr>
+                  <a:lstStyle/>
+                  <a:p>
+                    <a14:m>
+                      <m:oMathPara xmlns:m="http://schemas.openxmlformats.org/officeDocument/2006/math">
+                        <m:oMathParaPr>
+                          <m:jc m:val="centerGroup"/>
+                        </m:oMathParaPr>
+                        <m:oMath xmlns:m="http://schemas.openxmlformats.org/officeDocument/2006/math">
+                          <m:sSub>
+                            <m:sSubPr>
+                              <m:ctrlPr>
+                                <a:rPr lang="en-US" b="0" i="1" smtClean="0">
+                                  <a:latin typeface="Cambria Math" panose="02040503050406030204" pitchFamily="18" charset="0"/>
+                                  <a:ea typeface="Cambria Math" panose="02040503050406030204" pitchFamily="18" charset="0"/>
+                                </a:rPr>
+                              </m:ctrlPr>
+                            </m:sSubPr>
+                            <m:e>
+                              <m:r>
+                                <a:rPr lang="en-US" b="0" i="1" smtClean="0">
+                                  <a:latin typeface="Cambria Math" panose="02040503050406030204" pitchFamily="18" charset="0"/>
+                                  <a:ea typeface="Cambria Math" panose="02040503050406030204" pitchFamily="18" charset="0"/>
+                                </a:rPr>
+                                <m:t>𝐶</m:t>
+                              </m:r>
+                            </m:e>
+                            <m:sub>
+                              <m:r>
+                                <m:rPr>
+                                  <m:sty m:val="p"/>
+                                </m:rPr>
+                                <a:rPr lang="el-GR" b="0" i="1" smtClean="0">
+                                  <a:latin typeface="Cambria Math" panose="02040503050406030204" pitchFamily="18" charset="0"/>
+                                  <a:ea typeface="Cambria Math" panose="02040503050406030204" pitchFamily="18" charset="0"/>
+                                </a:rPr>
+                                <m:t>α</m:t>
+                              </m:r>
+                              <m:r>
+                                <a:rPr lang="en-US" b="0" i="1" smtClean="0">
+                                  <a:latin typeface="Cambria Math" panose="02040503050406030204" pitchFamily="18" charset="0"/>
+                                  <a:ea typeface="Cambria Math" panose="02040503050406030204" pitchFamily="18" charset="0"/>
+                                </a:rPr>
+                                <m:t>,</m:t>
+                              </m:r>
+                              <m:r>
+                                <a:rPr lang="en-US" b="0" i="1" smtClean="0">
+                                  <a:latin typeface="Cambria Math" panose="02040503050406030204" pitchFamily="18" charset="0"/>
+                                  <a:ea typeface="Cambria Math" panose="02040503050406030204" pitchFamily="18" charset="0"/>
+                                </a:rPr>
+                                <m:t>𝑖</m:t>
+                              </m:r>
+                            </m:sub>
+                          </m:sSub>
+                        </m:oMath>
+                      </m:oMathPara>
+                    </a14:m>
+                    <a:endParaRPr lang="en-CA">
+                      <a:latin typeface="Cambria Math" panose="02040503050406030204" pitchFamily="18" charset="0"/>
+                      <a:ea typeface="Cambria Math" panose="02040503050406030204" pitchFamily="18" charset="0"/>
+                    </a:endParaRPr>
+                  </a:p>
+                </p:txBody>
+              </p:sp>
+            </mc:Choice>
+            <mc:Fallback>
+              <p:sp>
+                <p:nvSpPr>
+                  <p:cNvPr id="21" name="TextBox 20">
+                    <a:extLst>
+                      <a:ext uri="{FF2B5EF4-FFF2-40B4-BE49-F238E27FC236}">
+                        <a16:creationId xmlns:a16="http://schemas.microsoft.com/office/drawing/2014/main" id="{75933132-7A80-DBF7-9E50-D8A8701C5480}"/>
+                      </a:ext>
+                    </a:extLst>
+                  </p:cNvPr>
+                  <p:cNvSpPr txBox="1">
+                    <a:spLocks noRot="1" noChangeAspect="1" noMove="1" noResize="1" noEditPoints="1" noAdjustHandles="1" noChangeArrowheads="1" noChangeShapeType="1" noTextEdit="1"/>
+                  </p:cNvSpPr>
+                  <p:nvPr/>
+                </p:nvSpPr>
+                <p:spPr>
+                  <a:xfrm>
+                    <a:off x="3772468" y="5536077"/>
+                    <a:ext cx="495301" cy="381515"/>
+                  </a:xfrm>
+                  <a:prstGeom prst="rect">
+                    <a:avLst/>
+                  </a:prstGeom>
+                  <a:blipFill>
+                    <a:blip r:embed="rId7"/>
+                    <a:stretch>
+                      <a:fillRect/>
+                    </a:stretch>
+                  </a:blipFill>
+                </p:spPr>
+                <p:txBody>
+                  <a:bodyPr/>
+                  <a:lstStyle/>
+                  <a:p>
+                    <a:r>
+                      <a:rPr lang="en-CA">
+                        <a:noFill/>
+                      </a:rPr>
+                      <a:t> </a:t>
+                    </a:r>
+                  </a:p>
+                </p:txBody>
+              </p:sp>
+            </mc:Fallback>
+          </mc:AlternateContent>
+          <mc:AlternateContent xmlns:mc="http://schemas.openxmlformats.org/markup-compatibility/2006">
+            <mc:Choice xmlns:a14="http://schemas.microsoft.com/office/drawing/2010/main" Requires="a14">
+              <p:sp>
+                <p:nvSpPr>
+                  <p:cNvPr id="22" name="TextBox 21">
+                    <a:extLst>
+                      <a:ext uri="{FF2B5EF4-FFF2-40B4-BE49-F238E27FC236}">
+                        <a16:creationId xmlns:a16="http://schemas.microsoft.com/office/drawing/2014/main" id="{95876399-88BE-485D-B7CD-64F3FAADD2DE}"/>
+                      </a:ext>
+                    </a:extLst>
+                  </p:cNvPr>
+                  <p:cNvSpPr txBox="1"/>
+                  <p:nvPr/>
+                </p:nvSpPr>
+                <p:spPr>
+                  <a:xfrm>
+                    <a:off x="5045625" y="4478224"/>
+                    <a:ext cx="495301" cy="381515"/>
+                  </a:xfrm>
+                  <a:prstGeom prst="rect">
+                    <a:avLst/>
+                  </a:prstGeom>
+                  <a:noFill/>
+                </p:spPr>
+                <p:txBody>
+                  <a:bodyPr wrap="square" rtlCol="0">
+                    <a:spAutoFit/>
+                  </a:bodyPr>
+                  <a:lstStyle/>
+                  <a:p>
+                    <a14:m>
+                      <m:oMathPara xmlns:m="http://schemas.openxmlformats.org/officeDocument/2006/math">
+                        <m:oMathParaPr>
+                          <m:jc m:val="centerGroup"/>
+                        </m:oMathParaPr>
+                        <m:oMath xmlns:m="http://schemas.openxmlformats.org/officeDocument/2006/math">
+                          <m:sSub>
+                            <m:sSubPr>
+                              <m:ctrlPr>
+                                <a:rPr lang="en-US" b="0" i="1" smtClean="0">
+                                  <a:latin typeface="Cambria Math" panose="02040503050406030204" pitchFamily="18" charset="0"/>
+                                  <a:ea typeface="Cambria Math" panose="02040503050406030204" pitchFamily="18" charset="0"/>
+                                </a:rPr>
+                              </m:ctrlPr>
+                            </m:sSubPr>
+                            <m:e>
+                              <m:r>
+                                <a:rPr lang="en-US" b="0" i="1" smtClean="0">
+                                  <a:latin typeface="Cambria Math" panose="02040503050406030204" pitchFamily="18" charset="0"/>
+                                  <a:ea typeface="Cambria Math" panose="02040503050406030204" pitchFamily="18" charset="0"/>
+                                </a:rPr>
+                                <m:t>𝐶</m:t>
+                              </m:r>
+                            </m:e>
+                            <m:sub>
+                              <m:r>
+                                <m:rPr>
+                                  <m:sty m:val="p"/>
+                                </m:rPr>
+                                <a:rPr lang="el-GR" b="0" i="1" smtClean="0">
+                                  <a:latin typeface="Cambria Math" panose="02040503050406030204" pitchFamily="18" charset="0"/>
+                                  <a:ea typeface="Cambria Math" panose="02040503050406030204" pitchFamily="18" charset="0"/>
+                                </a:rPr>
+                                <m:t>α</m:t>
+                              </m:r>
+                              <m:r>
+                                <a:rPr lang="en-US" b="0" i="1" smtClean="0">
+                                  <a:latin typeface="Cambria Math" panose="02040503050406030204" pitchFamily="18" charset="0"/>
+                                  <a:ea typeface="Cambria Math" panose="02040503050406030204" pitchFamily="18" charset="0"/>
+                                </a:rPr>
+                                <m:t>,</m:t>
+                              </m:r>
+                              <m:r>
+                                <a:rPr lang="en-US" b="0" i="1" smtClean="0">
+                                  <a:latin typeface="Cambria Math" panose="02040503050406030204" pitchFamily="18" charset="0"/>
+                                  <a:ea typeface="Cambria Math" panose="02040503050406030204" pitchFamily="18" charset="0"/>
+                                </a:rPr>
+                                <m:t>𝑖</m:t>
+                              </m:r>
+                              <m:r>
+                                <a:rPr lang="en-US" b="0" i="1" smtClean="0">
+                                  <a:latin typeface="Cambria Math" panose="02040503050406030204" pitchFamily="18" charset="0"/>
+                                  <a:ea typeface="Cambria Math" panose="02040503050406030204" pitchFamily="18" charset="0"/>
+                                </a:rPr>
+                                <m:t>−1</m:t>
+                              </m:r>
+                            </m:sub>
+                          </m:sSub>
+                        </m:oMath>
+                      </m:oMathPara>
+                    </a14:m>
+                    <a:endParaRPr lang="en-CA">
+                      <a:latin typeface="Cambria Math" panose="02040503050406030204" pitchFamily="18" charset="0"/>
+                      <a:ea typeface="Cambria Math" panose="02040503050406030204" pitchFamily="18" charset="0"/>
+                    </a:endParaRPr>
+                  </a:p>
+                </p:txBody>
+              </p:sp>
+            </mc:Choice>
+            <mc:Fallback>
+              <p:sp>
+                <p:nvSpPr>
+                  <p:cNvPr id="22" name="TextBox 21">
+                    <a:extLst>
+                      <a:ext uri="{FF2B5EF4-FFF2-40B4-BE49-F238E27FC236}">
+                        <a16:creationId xmlns:a16="http://schemas.microsoft.com/office/drawing/2014/main" id="{95876399-88BE-485D-B7CD-64F3FAADD2DE}"/>
+                      </a:ext>
+                    </a:extLst>
+                  </p:cNvPr>
+                  <p:cNvSpPr txBox="1">
+                    <a:spLocks noRot="1" noChangeAspect="1" noMove="1" noResize="1" noEditPoints="1" noAdjustHandles="1" noChangeArrowheads="1" noChangeShapeType="1" noTextEdit="1"/>
+                  </p:cNvSpPr>
+                  <p:nvPr/>
+                </p:nvSpPr>
+                <p:spPr>
+                  <a:xfrm>
+                    <a:off x="5045625" y="4478224"/>
+                    <a:ext cx="495301" cy="381515"/>
+                  </a:xfrm>
+                  <a:prstGeom prst="rect">
+                    <a:avLst/>
+                  </a:prstGeom>
+                  <a:blipFill>
+                    <a:blip r:embed="rId8"/>
+                    <a:stretch>
+                      <a:fillRect r="-39024"/>
+                    </a:stretch>
+                  </a:blipFill>
+                </p:spPr>
+                <p:txBody>
+                  <a:bodyPr/>
+                  <a:lstStyle/>
+                  <a:p>
+                    <a:r>
+                      <a:rPr lang="en-CA">
+                        <a:noFill/>
+                      </a:rPr>
+                      <a:t> </a:t>
+                    </a:r>
+                  </a:p>
+                </p:txBody>
+              </p:sp>
+            </mc:Fallback>
+          </mc:AlternateContent>
+          <mc:AlternateContent xmlns:mc="http://schemas.openxmlformats.org/markup-compatibility/2006">
+            <mc:Choice xmlns:a14="http://schemas.microsoft.com/office/drawing/2010/main" Requires="a14">
+              <p:sp>
+                <p:nvSpPr>
+                  <p:cNvPr id="23" name="TextBox 22">
+                    <a:extLst>
+                      <a:ext uri="{FF2B5EF4-FFF2-40B4-BE49-F238E27FC236}">
+                        <a16:creationId xmlns:a16="http://schemas.microsoft.com/office/drawing/2014/main" id="{12199813-2201-34AF-6C91-87BAF70F9204}"/>
+                      </a:ext>
+                    </a:extLst>
+                  </p:cNvPr>
+                  <p:cNvSpPr txBox="1"/>
+                  <p:nvPr/>
+                </p:nvSpPr>
+                <p:spPr>
+                  <a:xfrm>
+                    <a:off x="5373504" y="5764384"/>
+                    <a:ext cx="495301" cy="391646"/>
+                  </a:xfrm>
+                  <a:prstGeom prst="rect">
+                    <a:avLst/>
+                  </a:prstGeom>
+                  <a:noFill/>
+                </p:spPr>
+                <p:txBody>
+                  <a:bodyPr wrap="square" rtlCol="0">
+                    <a:spAutoFit/>
+                  </a:bodyPr>
+                  <a:lstStyle/>
+                  <a:p>
+                    <a14:m>
+                      <m:oMathPara xmlns:m="http://schemas.openxmlformats.org/officeDocument/2006/math">
+                        <m:oMathParaPr>
+                          <m:jc m:val="centerGroup"/>
+                        </m:oMathParaPr>
+                        <m:oMath xmlns:m="http://schemas.openxmlformats.org/officeDocument/2006/math">
+                          <m:sSub>
+                            <m:sSubPr>
+                              <m:ctrlPr>
+                                <a:rPr lang="en-US" b="0" i="1" smtClean="0">
+                                  <a:latin typeface="Cambria Math" panose="02040503050406030204" pitchFamily="18" charset="0"/>
+                                  <a:ea typeface="Cambria Math" panose="02040503050406030204" pitchFamily="18" charset="0"/>
+                                </a:rPr>
+                              </m:ctrlPr>
+                            </m:sSubPr>
+                            <m:e>
+                              <m:r>
+                                <a:rPr lang="en-US" b="0" i="1" smtClean="0">
+                                  <a:latin typeface="Cambria Math" panose="02040503050406030204" pitchFamily="18" charset="0"/>
+                                  <a:ea typeface="Cambria Math" panose="02040503050406030204" pitchFamily="18" charset="0"/>
+                                </a:rPr>
+                                <m:t>𝐶</m:t>
+                              </m:r>
+                            </m:e>
+                            <m:sub>
+                              <m:r>
+                                <m:rPr>
+                                  <m:sty m:val="p"/>
+                                </m:rPr>
+                                <a:rPr lang="el-GR" b="0" i="1" smtClean="0">
+                                  <a:latin typeface="Cambria Math" panose="02040503050406030204" pitchFamily="18" charset="0"/>
+                                  <a:ea typeface="Cambria Math" panose="02040503050406030204" pitchFamily="18" charset="0"/>
+                                </a:rPr>
+                                <m:t>α</m:t>
+                              </m:r>
+                              <m:r>
+                                <a:rPr lang="en-US" b="0" i="1" smtClean="0">
+                                  <a:latin typeface="Cambria Math" panose="02040503050406030204" pitchFamily="18" charset="0"/>
+                                  <a:ea typeface="Cambria Math" panose="02040503050406030204" pitchFamily="18" charset="0"/>
+                                </a:rPr>
+                                <m:t>,</m:t>
+                              </m:r>
+                              <m:r>
+                                <a:rPr lang="en-US" b="0" i="1" smtClean="0">
+                                  <a:latin typeface="Cambria Math" panose="02040503050406030204" pitchFamily="18" charset="0"/>
+                                  <a:ea typeface="Cambria Math" panose="02040503050406030204" pitchFamily="18" charset="0"/>
+                                </a:rPr>
+                                <m:t>𝑗</m:t>
+                              </m:r>
+                            </m:sub>
+                          </m:sSub>
+                        </m:oMath>
+                      </m:oMathPara>
+                    </a14:m>
+                    <a:endParaRPr lang="en-CA">
+                      <a:latin typeface="Cambria Math" panose="02040503050406030204" pitchFamily="18" charset="0"/>
+                      <a:ea typeface="Cambria Math" panose="02040503050406030204" pitchFamily="18" charset="0"/>
+                    </a:endParaRPr>
+                  </a:p>
+                </p:txBody>
+              </p:sp>
+            </mc:Choice>
+            <mc:Fallback>
+              <p:sp>
+                <p:nvSpPr>
+                  <p:cNvPr id="23" name="TextBox 22">
+                    <a:extLst>
+                      <a:ext uri="{FF2B5EF4-FFF2-40B4-BE49-F238E27FC236}">
+                        <a16:creationId xmlns:a16="http://schemas.microsoft.com/office/drawing/2014/main" id="{12199813-2201-34AF-6C91-87BAF70F9204}"/>
+                      </a:ext>
+                    </a:extLst>
+                  </p:cNvPr>
+                  <p:cNvSpPr txBox="1">
+                    <a:spLocks noRot="1" noChangeAspect="1" noMove="1" noResize="1" noEditPoints="1" noAdjustHandles="1" noChangeArrowheads="1" noChangeShapeType="1" noTextEdit="1"/>
+                  </p:cNvSpPr>
+                  <p:nvPr/>
+                </p:nvSpPr>
+                <p:spPr>
+                  <a:xfrm>
+                    <a:off x="5373504" y="5764384"/>
+                    <a:ext cx="495301" cy="391646"/>
+                  </a:xfrm>
+                  <a:prstGeom prst="rect">
+                    <a:avLst/>
+                  </a:prstGeom>
+                  <a:blipFill>
+                    <a:blip r:embed="rId9"/>
+                    <a:stretch>
+                      <a:fillRect r="-4938" b="-7813"/>
+                    </a:stretch>
+                  </a:blipFill>
+                </p:spPr>
+                <p:txBody>
+                  <a:bodyPr/>
+                  <a:lstStyle/>
+                  <a:p>
+                    <a:r>
+                      <a:rPr lang="en-CA">
+                        <a:noFill/>
+                      </a:rPr>
+                      <a:t> </a:t>
+                    </a:r>
+                  </a:p>
+                </p:txBody>
+              </p:sp>
+            </mc:Fallback>
+          </mc:AlternateContent>
+        </p:grpSp>
+        <p:sp>
+          <p:nvSpPr>
+            <p:cNvPr id="25" name="Rectangle 24">
+              <a:extLst>
+                <a:ext uri="{FF2B5EF4-FFF2-40B4-BE49-F238E27FC236}">
+                  <a16:creationId xmlns:a16="http://schemas.microsoft.com/office/drawing/2014/main" id="{891993D5-1B5D-0713-39F3-1AAFED2EED4B}"/>
+                </a:ext>
+              </a:extLst>
+            </p:cNvPr>
+            <p:cNvSpPr/>
+            <p:nvPr/>
+          </p:nvSpPr>
+          <p:spPr>
+            <a:xfrm>
+              <a:off x="3429000" y="4701580"/>
+              <a:ext cx="2247900" cy="1859240"/>
+            </a:xfrm>
+            <a:prstGeom prst="rect">
+              <a:avLst/>
+            </a:prstGeom>
+            <a:noFill/>
+            <a:ln>
+              <a:solidFill>
+                <a:schemeClr val="tx1">
+                  <a:lumMod val="75000"/>
+                  <a:lumOff val="25000"/>
+                </a:schemeClr>
+              </a:solidFill>
+            </a:ln>
+          </p:spPr>
+          <p:style>
+            <a:lnRef idx="2">
+              <a:schemeClr val="accent1">
+                <a:shade val="15000"/>
+              </a:schemeClr>
+            </a:lnRef>
+            <a:fillRef idx="1">
+              <a:schemeClr val="accent1"/>
+            </a:fillRef>
+            <a:effectRef idx="0">
+              <a:schemeClr val="accent1"/>
+            </a:effectRef>
+            <a:fontRef idx="minor">
+              <a:schemeClr val="lt1"/>
+            </a:fontRef>
+          </p:style>
+          <p:txBody>
+            <a:bodyPr rtlCol="0" anchor="ctr"/>
+            <a:lstStyle/>
+            <a:p>
+              <a:pPr algn="ctr"/>
+              <a:endParaRPr lang="en-CA"/>
+            </a:p>
+          </p:txBody>
+        </p:sp>
+      </p:grpSp>
+    </p:spTree>
+    <p:extLst>
+      <p:ext uri="{BB962C8B-B14F-4D97-AF65-F5344CB8AC3E}">
+        <p14:creationId xmlns:p14="http://schemas.microsoft.com/office/powerpoint/2010/main" val="3390092444"/>
+      </p:ext>
+    </p:extLst>
+  </p:cSld>
+  <p:clrMapOvr>
+    <a:masterClrMapping/>
+  </p:clrMapOvr>
+</p:sld>
+</file>
+
+<file path=ppt/slides/slide3.xml><?xml version="1.0" encoding="utf-8"?>
+<p:sld xmlns:a="http://schemas.openxmlformats.org/drawingml/2006/main" xmlns:r="http://schemas.openxmlformats.org/officeDocument/2006/relationships" xmlns:p="http://schemas.openxmlformats.org/presentationml/2006/main">
+  <p:cSld>
+    <p:spTree>
+      <p:nvGrpSpPr>
+        <p:cNvPr id="1" name=""/>
+        <p:cNvGrpSpPr/>
+        <p:nvPr/>
+      </p:nvGrpSpPr>
+      <p:grpSpPr>
+        <a:xfrm>
+          <a:off x="0" y="0"/>
+          <a:ext cx="0" cy="0"/>
+          <a:chOff x="0" y="0"/>
+          <a:chExt cx="0" cy="0"/>
+        </a:xfrm>
+      </p:grpSpPr>
+      <p:sp>
+        <p:nvSpPr>
+          <p:cNvPr id="4" name="Rectangle: Rounded Corners 3">
+            <a:extLst>
+              <a:ext uri="{FF2B5EF4-FFF2-40B4-BE49-F238E27FC236}">
+                <a16:creationId xmlns:a16="http://schemas.microsoft.com/office/drawing/2014/main" id="{35506A4A-AC64-A85A-503D-AF2771A2918A}"/>
+              </a:ext>
+            </a:extLst>
+          </p:cNvPr>
+          <p:cNvSpPr/>
+          <p:nvPr/>
+        </p:nvSpPr>
+        <p:spPr>
+          <a:xfrm>
             <a:off x="845609" y="649223"/>
             <a:ext cx="4704799" cy="649225"/>
           </a:xfrm>
@@ -4354,7 +6178,7 @@
           <p:cNvPr id="5" name="TextBox 4">
             <a:extLst>
               <a:ext uri="{FF2B5EF4-FFF2-40B4-BE49-F238E27FC236}">
-                <a16:creationId xmlns:a16="http://schemas.microsoft.com/office/drawing/2014/main" id="{04816639-416F-378A-9CD6-0190AB9F607C}"/>
+                <a16:creationId xmlns:a16="http://schemas.microsoft.com/office/drawing/2014/main" id="{DE4D71F2-ED93-AC2A-E919-57A0E4E48C2A}"/>
               </a:ext>
             </a:extLst>
           </p:cNvPr>
@@ -4363,8 +6187,8 @@
         </p:nvSpPr>
         <p:spPr>
           <a:xfrm>
-            <a:off x="768096" y="2011680"/>
-            <a:ext cx="9272016" cy="400110"/>
+            <a:off x="845609" y="1808480"/>
+            <a:ext cx="7739591" cy="3077766"/>
           </a:xfrm>
           <a:prstGeom prst="rect">
             <a:avLst/>
@@ -4377,22 +6201,84 @@
           </a:bodyPr>
           <a:lstStyle/>
           <a:p>
-            <a:pPr>
+            <a:pPr algn="just">
               <a:spcAft>
                 <a:spcPts val="1200"/>
               </a:spcAft>
             </a:pPr>
             <a:r>
-              <a:rPr lang="en-US" sz="2000">
+              <a:rPr lang="en-US" b="1">
                 <a:latin typeface="Georgia Pro" panose="02040502050405020303" pitchFamily="18" charset="0"/>
+                <a:cs typeface="Courier New" panose="02070309020205020404" pitchFamily="49" charset="0"/>
               </a:rPr>
-              <a:t>txt</a:t>
-            </a:r>
-            <a:endParaRPr lang="en-US" sz="1600">
-              <a:latin typeface="Courier New" panose="02070309020205020404" pitchFamily="49" charset="0"/>
+              <a:t>Foldseek cluster</a:t>
+            </a:r>
+            <a:r>
+              <a:rPr lang="en-US">
+                <a:latin typeface="Georgia Pro" panose="02040502050405020303" pitchFamily="18" charset="0"/>
+                <a:cs typeface="Courier New" panose="02070309020205020404" pitchFamily="49" charset="0"/>
+              </a:rPr>
+              <a:t>, a clustering algorithm, leverages both amino acid sequence and structural homology in grouping proteins together.</a:t>
+            </a:r>
+          </a:p>
+          <a:p>
+            <a:pPr algn="just">
+              <a:spcAft>
+                <a:spcPts val="1200"/>
+              </a:spcAft>
+            </a:pPr>
+            <a:endParaRPr lang="en-US">
+              <a:latin typeface="Georgia Pro" panose="02040502050405020303" pitchFamily="18" charset="0"/>
               <a:cs typeface="Courier New" panose="02070309020205020404" pitchFamily="49" charset="0"/>
             </a:endParaRPr>
           </a:p>
+          <a:p>
+            <a:pPr algn="just">
+              <a:spcAft>
+                <a:spcPts val="1200"/>
+              </a:spcAft>
+            </a:pPr>
+            <a:endParaRPr lang="en-US">
+              <a:latin typeface="Georgia Pro" panose="02040502050405020303" pitchFamily="18" charset="0"/>
+              <a:cs typeface="Courier New" panose="02070309020205020404" pitchFamily="49" charset="0"/>
+            </a:endParaRPr>
+          </a:p>
+          <a:p>
+            <a:pPr algn="just">
+              <a:spcAft>
+                <a:spcPts val="1200"/>
+              </a:spcAft>
+            </a:pPr>
+            <a:r>
+              <a:rPr lang="en-US">
+                <a:latin typeface="Georgia Pro" panose="02040502050405020303" pitchFamily="18" charset="0"/>
+                <a:cs typeface="Courier New" panose="02070309020205020404" pitchFamily="49" charset="0"/>
+              </a:rPr>
+              <a:t>takes these 3Di sequences as input and groups proteins in accordance with their structural homology.</a:t>
+            </a:r>
+          </a:p>
+          <a:p>
+            <a:pPr algn="just">
+              <a:spcAft>
+                <a:spcPts val="1200"/>
+              </a:spcAft>
+            </a:pPr>
+            <a:endParaRPr lang="en-US">
+              <a:latin typeface="Georgia Pro" panose="02040502050405020303" pitchFamily="18" charset="0"/>
+              <a:cs typeface="Courier New" panose="02070309020205020404" pitchFamily="49" charset="0"/>
+            </a:endParaRPr>
+          </a:p>
+          <a:p>
+            <a:pPr algn="just">
+              <a:spcAft>
+                <a:spcPts val="1200"/>
+              </a:spcAft>
+            </a:pPr>
+            <a:endParaRPr lang="en-US">
+              <a:latin typeface="Georgia Pro" panose="02040502050405020303" pitchFamily="18" charset="0"/>
+              <a:cs typeface="Courier New" panose="02070309020205020404" pitchFamily="49" charset="0"/>
+            </a:endParaRPr>
+          </a:p>
         </p:txBody>
       </p:sp>
       <p:sp>
@@ -4400,7 +6286,7 @@
           <p:cNvPr id="6" name="TextBox 5">
             <a:extLst>
               <a:ext uri="{FF2B5EF4-FFF2-40B4-BE49-F238E27FC236}">
-                <a16:creationId xmlns:a16="http://schemas.microsoft.com/office/drawing/2014/main" id="{D8F04AFD-2ACE-842C-9BD9-ECC48CC83FE5}"/>
+                <a16:creationId xmlns:a16="http://schemas.microsoft.com/office/drawing/2014/main" id="{2B49862E-67BD-690C-AE3D-A8F06A304190}"/>
               </a:ext>
             </a:extLst>
           </p:cNvPr>
@@ -4435,10 +6321,39 @@
           </a:p>
         </p:txBody>
       </p:sp>
+      <p:sp>
+        <p:nvSpPr>
+          <p:cNvPr id="7" name="Slide Number Placeholder 6">
+            <a:extLst>
+              <a:ext uri="{FF2B5EF4-FFF2-40B4-BE49-F238E27FC236}">
+                <a16:creationId xmlns:a16="http://schemas.microsoft.com/office/drawing/2014/main" id="{B47A362C-0F5D-C533-4AB1-071B7F7AAD02}"/>
+              </a:ext>
+            </a:extLst>
+          </p:cNvPr>
+          <p:cNvSpPr>
+            <a:spLocks noGrp="1"/>
+          </p:cNvSpPr>
+          <p:nvPr>
+            <p:ph type="sldNum" sz="quarter" idx="12"/>
+          </p:nvPr>
+        </p:nvSpPr>
+        <p:spPr/>
+        <p:txBody>
+          <a:bodyPr/>
+          <a:lstStyle/>
+          <a:p>
+            <a:fld id="{3899FC77-40C7-4C49-9A19-86BDE9B75E8A}" type="slidenum">
+              <a:rPr lang="en-CA" smtClean="0"/>
+              <a:t>3</a:t>
+            </a:fld>
+            <a:endParaRPr lang="en-CA"/>
+          </a:p>
+        </p:txBody>
+      </p:sp>
     </p:spTree>
     <p:extLst>
       <p:ext uri="{BB962C8B-B14F-4D97-AF65-F5344CB8AC3E}">
-        <p14:creationId xmlns:p14="http://schemas.microsoft.com/office/powerpoint/2010/main" val="3390092444"/>
+        <p14:creationId xmlns:p14="http://schemas.microsoft.com/office/powerpoint/2010/main" val="1446358046"/>
       </p:ext>
     </p:extLst>
   </p:cSld>
@@ -4448,7 +6363,7 @@
 </p:sld>
 </file>
 
-<file path=ppt/slides/slide3.xml><?xml version="1.0" encoding="utf-8"?>
+<file path=ppt/slides/slide4.xml><?xml version="1.0" encoding="utf-8"?>
 <p:sld xmlns:a="http://schemas.openxmlformats.org/drawingml/2006/main" xmlns:r="http://schemas.openxmlformats.org/officeDocument/2006/relationships" xmlns:p="http://schemas.openxmlformats.org/presentationml/2006/main">
   <p:cSld>
     <p:spTree>
@@ -4687,7 +6602,7 @@
                 <a:latin typeface="Georgia Pro" panose="02040502050405020303" pitchFamily="18" charset="0"/>
                 <a:cs typeface="Courier New" panose="02070309020205020404" pitchFamily="49" charset="0"/>
               </a:rPr>
-              <a:t>Based on the structural homology, can hypothesise about previously uncharacterised functions re: the human proteins?</a:t>
+              <a:t>Based on the structural homology, can we hypothesise about previously uncharacterised functions of the human proteins?</a:t>
             </a:r>
             <a:endParaRPr lang="en-US" sz="2400">
               <a:latin typeface="Courier New" panose="02070309020205020404" pitchFamily="49" charset="0"/>
@@ -4741,10 +6656,331 @@
           </a:p>
         </p:txBody>
       </p:sp>
+      <p:sp>
+        <p:nvSpPr>
+          <p:cNvPr id="7" name="Slide Number Placeholder 6">
+            <a:extLst>
+              <a:ext uri="{FF2B5EF4-FFF2-40B4-BE49-F238E27FC236}">
+                <a16:creationId xmlns:a16="http://schemas.microsoft.com/office/drawing/2014/main" id="{ED2CB2A2-9134-88C1-0B43-B74BA4835289}"/>
+              </a:ext>
+            </a:extLst>
+          </p:cNvPr>
+          <p:cNvSpPr>
+            <a:spLocks noGrp="1"/>
+          </p:cNvSpPr>
+          <p:nvPr>
+            <p:ph type="sldNum" sz="quarter" idx="12"/>
+          </p:nvPr>
+        </p:nvSpPr>
+        <p:spPr/>
+        <p:txBody>
+          <a:bodyPr/>
+          <a:lstStyle/>
+          <a:p>
+            <a:fld id="{3899FC77-40C7-4C49-9A19-86BDE9B75E8A}" type="slidenum">
+              <a:rPr lang="en-CA" smtClean="0"/>
+              <a:t>4</a:t>
+            </a:fld>
+            <a:endParaRPr lang="en-CA"/>
+          </a:p>
+        </p:txBody>
+      </p:sp>
     </p:spTree>
     <p:extLst>
       <p:ext uri="{BB962C8B-B14F-4D97-AF65-F5344CB8AC3E}">
         <p14:creationId xmlns:p14="http://schemas.microsoft.com/office/powerpoint/2010/main" val="720809617"/>
+      </p:ext>
+    </p:extLst>
+  </p:cSld>
+  <p:clrMapOvr>
+    <a:masterClrMapping/>
+  </p:clrMapOvr>
+</p:sld>
+</file>
+
+<file path=ppt/slides/slide5.xml><?xml version="1.0" encoding="utf-8"?>
+<p:sld xmlns:a="http://schemas.openxmlformats.org/drawingml/2006/main" xmlns:r="http://schemas.openxmlformats.org/officeDocument/2006/relationships" xmlns:p="http://schemas.openxmlformats.org/presentationml/2006/main">
+  <p:cSld>
+    <p:spTree>
+      <p:nvGrpSpPr>
+        <p:cNvPr id="1" name=""/>
+        <p:cNvGrpSpPr/>
+        <p:nvPr/>
+      </p:nvGrpSpPr>
+      <p:grpSpPr>
+        <a:xfrm>
+          <a:off x="0" y="0"/>
+          <a:ext cx="0" cy="0"/>
+          <a:chOff x="0" y="0"/>
+          <a:chExt cx="0" cy="0"/>
+        </a:xfrm>
+      </p:grpSpPr>
+      <p:sp>
+        <p:nvSpPr>
+          <p:cNvPr id="5" name="Rectangle: Rounded Corners 4">
+            <a:extLst>
+              <a:ext uri="{FF2B5EF4-FFF2-40B4-BE49-F238E27FC236}">
+                <a16:creationId xmlns:a16="http://schemas.microsoft.com/office/drawing/2014/main" id="{5A67C029-F809-4563-FEDC-0FE2666AD68F}"/>
+              </a:ext>
+            </a:extLst>
+          </p:cNvPr>
+          <p:cNvSpPr/>
+          <p:nvPr/>
+        </p:nvSpPr>
+        <p:spPr>
+          <a:xfrm>
+            <a:off x="845609" y="649223"/>
+            <a:ext cx="4704799" cy="649225"/>
+          </a:xfrm>
+          <a:prstGeom prst="roundRect">
+            <a:avLst/>
+          </a:prstGeom>
+          <a:solidFill>
+            <a:srgbClr val="0162B3"/>
+          </a:solidFill>
+          <a:ln>
+            <a:solidFill>
+              <a:srgbClr val="0162B3"/>
+            </a:solidFill>
+          </a:ln>
+        </p:spPr>
+        <p:style>
+          <a:lnRef idx="2">
+            <a:schemeClr val="accent1">
+              <a:shade val="50000"/>
+            </a:schemeClr>
+          </a:lnRef>
+          <a:fillRef idx="1">
+            <a:schemeClr val="accent1"/>
+          </a:fillRef>
+          <a:effectRef idx="0">
+            <a:schemeClr val="accent1"/>
+          </a:effectRef>
+          <a:fontRef idx="minor">
+            <a:schemeClr val="lt1"/>
+          </a:fontRef>
+        </p:style>
+        <p:txBody>
+          <a:bodyPr rtlCol="0" anchor="ctr"/>
+          <a:lstStyle>
+            <a:defPPr>
+              <a:defRPr lang="en-US"/>
+            </a:defPPr>
+            <a:lvl1pPr marL="0" algn="l" defTabSz="914400" rtl="0" eaLnBrk="1" latinLnBrk="0" hangingPunct="1">
+              <a:defRPr sz="1800" kern="1200">
+                <a:solidFill>
+                  <a:schemeClr val="lt1"/>
+                </a:solidFill>
+                <a:latin typeface="+mn-lt"/>
+                <a:ea typeface="+mn-ea"/>
+                <a:cs typeface="+mn-cs"/>
+              </a:defRPr>
+            </a:lvl1pPr>
+            <a:lvl2pPr marL="457200" algn="l" defTabSz="914400" rtl="0" eaLnBrk="1" latinLnBrk="0" hangingPunct="1">
+              <a:defRPr sz="1800" kern="1200">
+                <a:solidFill>
+                  <a:schemeClr val="lt1"/>
+                </a:solidFill>
+                <a:latin typeface="+mn-lt"/>
+                <a:ea typeface="+mn-ea"/>
+                <a:cs typeface="+mn-cs"/>
+              </a:defRPr>
+            </a:lvl2pPr>
+            <a:lvl3pPr marL="914400" algn="l" defTabSz="914400" rtl="0" eaLnBrk="1" latinLnBrk="0" hangingPunct="1">
+              <a:defRPr sz="1800" kern="1200">
+                <a:solidFill>
+                  <a:schemeClr val="lt1"/>
+                </a:solidFill>
+                <a:latin typeface="+mn-lt"/>
+                <a:ea typeface="+mn-ea"/>
+                <a:cs typeface="+mn-cs"/>
+              </a:defRPr>
+            </a:lvl3pPr>
+            <a:lvl4pPr marL="1371600" algn="l" defTabSz="914400" rtl="0" eaLnBrk="1" latinLnBrk="0" hangingPunct="1">
+              <a:defRPr sz="1800" kern="1200">
+                <a:solidFill>
+                  <a:schemeClr val="lt1"/>
+                </a:solidFill>
+                <a:latin typeface="+mn-lt"/>
+                <a:ea typeface="+mn-ea"/>
+                <a:cs typeface="+mn-cs"/>
+              </a:defRPr>
+            </a:lvl4pPr>
+            <a:lvl5pPr marL="1828800" algn="l" defTabSz="914400" rtl="0" eaLnBrk="1" latinLnBrk="0" hangingPunct="1">
+              <a:defRPr sz="1800" kern="1200">
+                <a:solidFill>
+                  <a:schemeClr val="lt1"/>
+                </a:solidFill>
+                <a:latin typeface="+mn-lt"/>
+                <a:ea typeface="+mn-ea"/>
+                <a:cs typeface="+mn-cs"/>
+              </a:defRPr>
+            </a:lvl5pPr>
+            <a:lvl6pPr marL="2286000" algn="l" defTabSz="914400" rtl="0" eaLnBrk="1" latinLnBrk="0" hangingPunct="1">
+              <a:defRPr sz="1800" kern="1200">
+                <a:solidFill>
+                  <a:schemeClr val="lt1"/>
+                </a:solidFill>
+                <a:latin typeface="+mn-lt"/>
+                <a:ea typeface="+mn-ea"/>
+                <a:cs typeface="+mn-cs"/>
+              </a:defRPr>
+            </a:lvl6pPr>
+            <a:lvl7pPr marL="2743200" algn="l" defTabSz="914400" rtl="0" eaLnBrk="1" latinLnBrk="0" hangingPunct="1">
+              <a:defRPr sz="1800" kern="1200">
+                <a:solidFill>
+                  <a:schemeClr val="lt1"/>
+                </a:solidFill>
+                <a:latin typeface="+mn-lt"/>
+                <a:ea typeface="+mn-ea"/>
+                <a:cs typeface="+mn-cs"/>
+              </a:defRPr>
+            </a:lvl7pPr>
+            <a:lvl8pPr marL="3200400" algn="l" defTabSz="914400" rtl="0" eaLnBrk="1" latinLnBrk="0" hangingPunct="1">
+              <a:defRPr sz="1800" kern="1200">
+                <a:solidFill>
+                  <a:schemeClr val="lt1"/>
+                </a:solidFill>
+                <a:latin typeface="+mn-lt"/>
+                <a:ea typeface="+mn-ea"/>
+                <a:cs typeface="+mn-cs"/>
+              </a:defRPr>
+            </a:lvl8pPr>
+            <a:lvl9pPr marL="3657600" algn="l" defTabSz="914400" rtl="0" eaLnBrk="1" latinLnBrk="0" hangingPunct="1">
+              <a:defRPr sz="1800" kern="1200">
+                <a:solidFill>
+                  <a:schemeClr val="lt1"/>
+                </a:solidFill>
+                <a:latin typeface="+mn-lt"/>
+                <a:ea typeface="+mn-ea"/>
+                <a:cs typeface="+mn-cs"/>
+              </a:defRPr>
+            </a:lvl9pPr>
+          </a:lstStyle>
+          <a:p>
+            <a:pPr algn="ctr"/>
+            <a:endParaRPr lang="en-CA"/>
+          </a:p>
+        </p:txBody>
+      </p:sp>
+      <p:sp>
+        <p:nvSpPr>
+          <p:cNvPr id="6" name="TextBox 5">
+            <a:extLst>
+              <a:ext uri="{FF2B5EF4-FFF2-40B4-BE49-F238E27FC236}">
+                <a16:creationId xmlns:a16="http://schemas.microsoft.com/office/drawing/2014/main" id="{984295EC-59E3-A151-A598-185D8DFFA3C9}"/>
+              </a:ext>
+            </a:extLst>
+          </p:cNvPr>
+          <p:cNvSpPr txBox="1"/>
+          <p:nvPr/>
+        </p:nvSpPr>
+        <p:spPr>
+          <a:xfrm>
+            <a:off x="987552" y="761737"/>
+            <a:ext cx="3538728" cy="461665"/>
+          </a:xfrm>
+          <a:prstGeom prst="rect">
+            <a:avLst/>
+          </a:prstGeom>
+          <a:noFill/>
+        </p:spPr>
+        <p:txBody>
+          <a:bodyPr wrap="square" rtlCol="0">
+            <a:spAutoFit/>
+          </a:bodyPr>
+          <a:lstStyle/>
+          <a:p>
+            <a:r>
+              <a:rPr lang="en-US" sz="2400" b="1">
+                <a:solidFill>
+                  <a:schemeClr val="bg1"/>
+                </a:solidFill>
+                <a:latin typeface="Georgia Pro" panose="02040502050405020303" pitchFamily="18" charset="0"/>
+              </a:rPr>
+              <a:t>References</a:t>
+            </a:r>
+          </a:p>
+        </p:txBody>
+      </p:sp>
+      <p:sp>
+        <p:nvSpPr>
+          <p:cNvPr id="7" name="Slide Number Placeholder 6">
+            <a:extLst>
+              <a:ext uri="{FF2B5EF4-FFF2-40B4-BE49-F238E27FC236}">
+                <a16:creationId xmlns:a16="http://schemas.microsoft.com/office/drawing/2014/main" id="{4AA63B0A-77DC-F94E-1603-6415DC566DB9}"/>
+              </a:ext>
+            </a:extLst>
+          </p:cNvPr>
+          <p:cNvSpPr>
+            <a:spLocks noGrp="1"/>
+          </p:cNvSpPr>
+          <p:nvPr>
+            <p:ph type="sldNum" sz="quarter" idx="12"/>
+          </p:nvPr>
+        </p:nvSpPr>
+        <p:spPr/>
+        <p:txBody>
+          <a:bodyPr/>
+          <a:lstStyle/>
+          <a:p>
+            <a:fld id="{3899FC77-40C7-4C49-9A19-86BDE9B75E8A}" type="slidenum">
+              <a:rPr lang="en-CA" smtClean="0"/>
+              <a:pPr/>
+              <a:t>5</a:t>
+            </a:fld>
+            <a:endParaRPr lang="en-CA" sz="1400"/>
+          </a:p>
+        </p:txBody>
+      </p:sp>
+      <p:sp>
+        <p:nvSpPr>
+          <p:cNvPr id="8" name="TextBox 7">
+            <a:extLst>
+              <a:ext uri="{FF2B5EF4-FFF2-40B4-BE49-F238E27FC236}">
+                <a16:creationId xmlns:a16="http://schemas.microsoft.com/office/drawing/2014/main" id="{34546AC0-D7B2-E9C1-C7EF-931782FA7585}"/>
+              </a:ext>
+            </a:extLst>
+          </p:cNvPr>
+          <p:cNvSpPr txBox="1"/>
+          <p:nvPr/>
+        </p:nvSpPr>
+        <p:spPr>
+          <a:xfrm>
+            <a:off x="768096" y="2011680"/>
+            <a:ext cx="9272016" cy="646331"/>
+          </a:xfrm>
+          <a:prstGeom prst="rect">
+            <a:avLst/>
+          </a:prstGeom>
+          <a:noFill/>
+        </p:spPr>
+        <p:txBody>
+          <a:bodyPr wrap="square" rtlCol="0">
+            <a:spAutoFit/>
+          </a:bodyPr>
+          <a:lstStyle/>
+          <a:p>
+            <a:pPr marL="342900" lvl="0" indent="-342900">
+              <a:spcAft>
+                <a:spcPts val="600"/>
+              </a:spcAft>
+              <a:buFont typeface="+mj-lt"/>
+              <a:buAutoNum type="arabicPeriod"/>
+            </a:pPr>
+            <a:r>
+              <a:rPr lang="en-CA">
+                <a:latin typeface="Georgia Pro" panose="02040502050405020303" pitchFamily="18" charset="0"/>
+              </a:rPr>
+              <a:t>Van Kempen M, et al. Fast and accurate protein structure search with Foldseek. Nat Biotechnol. 2024;42:243-246. DOI: 10.1038/s41587-023-01773-0</a:t>
+            </a:r>
+          </a:p>
+        </p:txBody>
+      </p:sp>
+    </p:spTree>
+    <p:extLst>
+      <p:ext uri="{BB962C8B-B14F-4D97-AF65-F5344CB8AC3E}">
+        <p14:creationId xmlns:p14="http://schemas.microsoft.com/office/powerpoint/2010/main" val="3665506129"/>
       </p:ext>
     </p:extLst>
   </p:cSld>
@@ -5067,4 +7303,319 @@
     </a:ext>
   </a:extLst>
 </a:theme>
+</file>
+
+<file path=ppt/theme/theme2.xml><?xml version="1.0" encoding="utf-8"?>
+<a:theme xmlns:a="http://schemas.openxmlformats.org/drawingml/2006/main" name="Office Theme">
+  <a:themeElements>
+    <a:clrScheme name="Office">
+      <a:dk1>
+        <a:sysClr val="windowText" lastClr="000000"/>
+      </a:dk1>
+      <a:lt1>
+        <a:sysClr val="window" lastClr="FFFFFF"/>
+      </a:lt1>
+      <a:dk2>
+        <a:srgbClr val="0E2841"/>
+      </a:dk2>
+      <a:lt2>
+        <a:srgbClr val="E8E8E8"/>
+      </a:lt2>
+      <a:accent1>
+        <a:srgbClr val="156082"/>
+      </a:accent1>
+      <a:accent2>
+        <a:srgbClr val="E97132"/>
+      </a:accent2>
+      <a:accent3>
+        <a:srgbClr val="196B24"/>
+      </a:accent3>
+      <a:accent4>
+        <a:srgbClr val="0F9ED5"/>
+      </a:accent4>
+      <a:accent5>
+        <a:srgbClr val="A02B93"/>
+      </a:accent5>
+      <a:accent6>
+        <a:srgbClr val="4EA72E"/>
+      </a:accent6>
+      <a:hlink>
+        <a:srgbClr val="467886"/>
+      </a:hlink>
+      <a:folHlink>
+        <a:srgbClr val="96607D"/>
+      </a:folHlink>
+    </a:clrScheme>
+    <a:fontScheme name="Office">
+      <a:majorFont>
+        <a:latin typeface="Aptos Display" panose="02110004020202020204"/>
+        <a:ea typeface=""/>
+        <a:cs typeface=""/>
+        <a:font script="Jpan" typeface="游ゴシック Light"/>
+        <a:font script="Hang" typeface="맑은 고딕"/>
+        <a:font script="Hans" typeface="等线 Light"/>
+        <a:font script="Hant" typeface="新細明體"/>
+        <a:font script="Arab" typeface="Times New Roman"/>
+        <a:font script="Hebr" typeface="Times New Roman"/>
+        <a:font script="Thai" typeface="Angsana New"/>
+        <a:font script="Ethi" typeface="Nyala"/>
+        <a:font script="Beng" typeface="Vrinda"/>
+        <a:font script="Gujr" typeface="Shruti"/>
+        <a:font script="Khmr" typeface="MoolBoran"/>
+        <a:font script="Knda" typeface="Tunga"/>
+        <a:font script="Guru" typeface="Raavi"/>
+        <a:font script="Cans" typeface="Euphemia"/>
+        <a:font script="Cher" typeface="Plantagenet Cherokee"/>
+        <a:font script="Yiii" typeface="Microsoft Yi Baiti"/>
+        <a:font script="Tibt" typeface="Microsoft Himalaya"/>
+        <a:font script="Thaa" typeface="MV Boli"/>
+        <a:font script="Deva" typeface="Mangal"/>
+        <a:font script="Telu" typeface="Gautami"/>
+        <a:font script="Taml" typeface="Latha"/>
+        <a:font script="Syrc" typeface="Estrangelo Edessa"/>
+        <a:font script="Orya" typeface="Kalinga"/>
+        <a:font script="Mlym" typeface="Kartika"/>
+        <a:font script="Laoo" typeface="DokChampa"/>
+        <a:font script="Sinh" typeface="Iskoola Pota"/>
+        <a:font script="Mong" typeface="Mongolian Baiti"/>
+        <a:font script="Viet" typeface="Times New Roman"/>
+        <a:font script="Uigh" typeface="Microsoft Uighur"/>
+        <a:font script="Geor" typeface="Sylfaen"/>
+        <a:font script="Armn" typeface="Arial"/>
+        <a:font script="Bugi" typeface="Leelawadee UI"/>
+        <a:font script="Bopo" typeface="Microsoft JhengHei"/>
+        <a:font script="Java" typeface="Javanese Text"/>
+        <a:font script="Lisu" typeface="Segoe UI"/>
+        <a:font script="Mymr" typeface="Myanmar Text"/>
+        <a:font script="Nkoo" typeface="Ebrima"/>
+        <a:font script="Olck" typeface="Nirmala UI"/>
+        <a:font script="Osma" typeface="Ebrima"/>
+        <a:font script="Phag" typeface="Phagspa"/>
+        <a:font script="Syrn" typeface="Estrangelo Edessa"/>
+        <a:font script="Syrj" typeface="Estrangelo Edessa"/>
+        <a:font script="Syre" typeface="Estrangelo Edessa"/>
+        <a:font script="Sora" typeface="Nirmala UI"/>
+        <a:font script="Tale" typeface="Microsoft Tai Le"/>
+        <a:font script="Talu" typeface="Microsoft New Tai Lue"/>
+        <a:font script="Tfng" typeface="Ebrima"/>
+      </a:majorFont>
+      <a:minorFont>
+        <a:latin typeface="Aptos" panose="02110004020202020204"/>
+        <a:ea typeface=""/>
+        <a:cs typeface=""/>
+        <a:font script="Jpan" typeface="游ゴシック"/>
+        <a:font script="Hang" typeface="맑은 고딕"/>
+        <a:font script="Hans" typeface="等线"/>
+        <a:font script="Hant" typeface="新細明體"/>
+        <a:font script="Arab" typeface="Arial"/>
+        <a:font script="Hebr" typeface="Arial"/>
+        <a:font script="Thai" typeface="Cordia New"/>
+        <a:font script="Ethi" typeface="Nyala"/>
+        <a:font script="Beng" typeface="Vrinda"/>
+        <a:font script="Gujr" typeface="Shruti"/>
+        <a:font script="Khmr" typeface="DaunPenh"/>
+        <a:font script="Knda" typeface="Tunga"/>
+        <a:font script="Guru" typeface="Raavi"/>
+        <a:font script="Cans" typeface="Euphemia"/>
+        <a:font script="Cher" typeface="Plantagenet Cherokee"/>
+        <a:font script="Yiii" typeface="Microsoft Yi Baiti"/>
+        <a:font script="Tibt" typeface="Microsoft Himalaya"/>
+        <a:font script="Thaa" typeface="MV Boli"/>
+        <a:font script="Deva" typeface="Mangal"/>
+        <a:font script="Telu" typeface="Gautami"/>
+        <a:font script="Taml" typeface="Latha"/>
+        <a:font script="Syrc" typeface="Estrangelo Edessa"/>
+        <a:font script="Orya" typeface="Kalinga"/>
+        <a:font script="Mlym" typeface="Kartika"/>
+        <a:font script="Laoo" typeface="DokChampa"/>
+        <a:font script="Sinh" typeface="Iskoola Pota"/>
+        <a:font script="Mong" typeface="Mongolian Baiti"/>
+        <a:font script="Viet" typeface="Arial"/>
+        <a:font script="Uigh" typeface="Microsoft Uighur"/>
+        <a:font script="Geor" typeface="Sylfaen"/>
+        <a:font script="Armn" typeface="Arial"/>
+        <a:font script="Bugi" typeface="Leelawadee UI"/>
+        <a:font script="Bopo" typeface="Microsoft JhengHei"/>
+        <a:font script="Java" typeface="Javanese Text"/>
+        <a:font script="Lisu" typeface="Segoe UI"/>
+        <a:font script="Mymr" typeface="Myanmar Text"/>
+        <a:font script="Nkoo" typeface="Ebrima"/>
+        <a:font script="Olck" typeface="Nirmala UI"/>
+        <a:font script="Osma" typeface="Ebrima"/>
+        <a:font script="Phag" typeface="Phagspa"/>
+        <a:font script="Syrn" typeface="Estrangelo Edessa"/>
+        <a:font script="Syrj" typeface="Estrangelo Edessa"/>
+        <a:font script="Syre" typeface="Estrangelo Edessa"/>
+        <a:font script="Sora" typeface="Nirmala UI"/>
+        <a:font script="Tale" typeface="Microsoft Tai Le"/>
+        <a:font script="Talu" typeface="Microsoft New Tai Lue"/>
+        <a:font script="Tfng" typeface="Ebrima"/>
+      </a:minorFont>
+    </a:fontScheme>
+    <a:fmtScheme name="Office">
+      <a:fillStyleLst>
+        <a:solidFill>
+          <a:schemeClr val="phClr"/>
+        </a:solidFill>
+        <a:gradFill rotWithShape="1">
+          <a:gsLst>
+            <a:gs pos="0">
+              <a:schemeClr val="phClr">
+                <a:lumMod val="110000"/>
+                <a:satMod val="105000"/>
+                <a:tint val="67000"/>
+              </a:schemeClr>
+            </a:gs>
+            <a:gs pos="50000">
+              <a:schemeClr val="phClr">
+                <a:lumMod val="105000"/>
+                <a:satMod val="103000"/>
+                <a:tint val="73000"/>
+              </a:schemeClr>
+            </a:gs>
+            <a:gs pos="100000">
+              <a:schemeClr val="phClr">
+                <a:lumMod val="105000"/>
+                <a:satMod val="109000"/>
+                <a:tint val="81000"/>
+              </a:schemeClr>
+            </a:gs>
+          </a:gsLst>
+          <a:lin ang="5400000" scaled="0"/>
+        </a:gradFill>
+        <a:gradFill rotWithShape="1">
+          <a:gsLst>
+            <a:gs pos="0">
+              <a:schemeClr val="phClr">
+                <a:satMod val="103000"/>
+                <a:lumMod val="102000"/>
+                <a:tint val="94000"/>
+              </a:schemeClr>
+            </a:gs>
+            <a:gs pos="50000">
+              <a:schemeClr val="phClr">
+                <a:satMod val="110000"/>
+                <a:lumMod val="100000"/>
+                <a:shade val="100000"/>
+              </a:schemeClr>
+            </a:gs>
+            <a:gs pos="100000">
+              <a:schemeClr val="phClr">
+                <a:lumMod val="99000"/>
+                <a:satMod val="120000"/>
+                <a:shade val="78000"/>
+              </a:schemeClr>
+            </a:gs>
+          </a:gsLst>
+          <a:lin ang="5400000" scaled="0"/>
+        </a:gradFill>
+      </a:fillStyleLst>
+      <a:lnStyleLst>
+        <a:ln w="12700" cap="flat" cmpd="sng" algn="ctr">
+          <a:solidFill>
+            <a:schemeClr val="phClr"/>
+          </a:solidFill>
+          <a:prstDash val="solid"/>
+          <a:miter lim="800000"/>
+        </a:ln>
+        <a:ln w="19050" cap="flat" cmpd="sng" algn="ctr">
+          <a:solidFill>
+            <a:schemeClr val="phClr"/>
+          </a:solidFill>
+          <a:prstDash val="solid"/>
+          <a:miter lim="800000"/>
+        </a:ln>
+        <a:ln w="25400" cap="flat" cmpd="sng" algn="ctr">
+          <a:solidFill>
+            <a:schemeClr val="phClr"/>
+          </a:solidFill>
+          <a:prstDash val="solid"/>
+          <a:miter lim="800000"/>
+        </a:ln>
+      </a:lnStyleLst>
+      <a:effectStyleLst>
+        <a:effectStyle>
+          <a:effectLst/>
+        </a:effectStyle>
+        <a:effectStyle>
+          <a:effectLst/>
+        </a:effectStyle>
+        <a:effectStyle>
+          <a:effectLst>
+            <a:outerShdw blurRad="57150" dist="19050" dir="5400000" algn="ctr" rotWithShape="0">
+              <a:srgbClr val="000000">
+                <a:alpha val="63000"/>
+              </a:srgbClr>
+            </a:outerShdw>
+          </a:effectLst>
+        </a:effectStyle>
+      </a:effectStyleLst>
+      <a:bgFillStyleLst>
+        <a:solidFill>
+          <a:schemeClr val="phClr"/>
+        </a:solidFill>
+        <a:solidFill>
+          <a:schemeClr val="phClr">
+            <a:tint val="95000"/>
+            <a:satMod val="170000"/>
+          </a:schemeClr>
+        </a:solidFill>
+        <a:gradFill rotWithShape="1">
+          <a:gsLst>
+            <a:gs pos="0">
+              <a:schemeClr val="phClr">
+                <a:tint val="93000"/>
+                <a:satMod val="150000"/>
+                <a:shade val="98000"/>
+                <a:lumMod val="102000"/>
+              </a:schemeClr>
+            </a:gs>
+            <a:gs pos="50000">
+              <a:schemeClr val="phClr">
+                <a:tint val="98000"/>
+                <a:satMod val="130000"/>
+                <a:shade val="90000"/>
+                <a:lumMod val="103000"/>
+              </a:schemeClr>
+            </a:gs>
+            <a:gs pos="100000">
+              <a:schemeClr val="phClr">
+                <a:shade val="63000"/>
+                <a:satMod val="120000"/>
+              </a:schemeClr>
+            </a:gs>
+          </a:gsLst>
+          <a:lin ang="5400000" scaled="0"/>
+        </a:gradFill>
+      </a:bgFillStyleLst>
+    </a:fmtScheme>
+  </a:themeElements>
+  <a:objectDefaults>
+    <a:lnDef>
+      <a:spPr/>
+      <a:bodyPr/>
+      <a:lstStyle/>
+      <a:style>
+        <a:lnRef idx="2">
+          <a:schemeClr val="accent1"/>
+        </a:lnRef>
+        <a:fillRef idx="0">
+          <a:schemeClr val="accent1"/>
+        </a:fillRef>
+        <a:effectRef idx="1">
+          <a:schemeClr val="accent1"/>
+        </a:effectRef>
+        <a:fontRef idx="minor">
+          <a:schemeClr val="tx1"/>
+        </a:fontRef>
+      </a:style>
+    </a:lnDef>
+  </a:objectDefaults>
+  <a:extraClrSchemeLst/>
+  <a:extLst>
+    <a:ext uri="{05A4C25C-085E-4340-85A3-A5531E510DB2}">
+      <thm15:themeFamily xmlns:thm15="http://schemas.microsoft.com/office/thememl/2012/main" name="Office Theme" id="{2E142A2C-CD16-42D6-873A-C26D2A0506FA}" vid="{1BDDFF52-6CD6-40A5-AB3C-68EB2F1E4D0A}"/>
+    </a:ext>
+  </a:extLst>
+</a:theme>
 </file>
</xml_diff>

<commit_message>
Filtered for unique protein matches before running additional filtering criteria and regenerated plots. Wrote out intermediate datasets.
</commit_message>
<xml_diff>
--- a/vis/reports/2026-02-18_projectUpdate_1.pptx
+++ b/vis/reports/2026-02-18_projectUpdate_1.pptx
@@ -5,14 +5,17 @@
     <p:sldMasterId id="2147483648" r:id="rId1"/>
   </p:sldMasterIdLst>
   <p:notesMasterIdLst>
-    <p:notesMasterId r:id="rId7"/>
+    <p:notesMasterId r:id="rId10"/>
   </p:notesMasterIdLst>
   <p:sldIdLst>
     <p:sldId id="256" r:id="rId2"/>
     <p:sldId id="258" r:id="rId3"/>
     <p:sldId id="259" r:id="rId4"/>
     <p:sldId id="257" r:id="rId5"/>
-    <p:sldId id="260" r:id="rId6"/>
+    <p:sldId id="262" r:id="rId6"/>
+    <p:sldId id="261" r:id="rId7"/>
+    <p:sldId id="263" r:id="rId8"/>
+    <p:sldId id="260" r:id="rId9"/>
   </p:sldIdLst>
   <p:sldSz cx="12192000" cy="6858000"/>
   <p:notesSz cx="6858000" cy="9144000"/>
@@ -462,6 +465,94 @@
     </a:lvl9pPr>
   </p:notesStyle>
 </p:notesMaster>
+</file>
+
+<file path=ppt/notesSlides/notesSlide1.xml><?xml version="1.0" encoding="utf-8"?>
+<p:notes xmlns:a="http://schemas.openxmlformats.org/drawingml/2006/main" xmlns:r="http://schemas.openxmlformats.org/officeDocument/2006/relationships" xmlns:p="http://schemas.openxmlformats.org/presentationml/2006/main">
+  <p:cSld>
+    <p:spTree>
+      <p:nvGrpSpPr>
+        <p:cNvPr id="1" name=""/>
+        <p:cNvGrpSpPr/>
+        <p:nvPr/>
+      </p:nvGrpSpPr>
+      <p:grpSpPr>
+        <a:xfrm>
+          <a:off x="0" y="0"/>
+          <a:ext cx="0" cy="0"/>
+          <a:chOff x="0" y="0"/>
+          <a:chExt cx="0" cy="0"/>
+        </a:xfrm>
+      </p:grpSpPr>
+      <p:sp>
+        <p:nvSpPr>
+          <p:cNvPr id="2" name="Slide Image Placeholder 1"/>
+          <p:cNvSpPr>
+            <a:spLocks noGrp="1" noRot="1" noChangeAspect="1"/>
+          </p:cNvSpPr>
+          <p:nvPr>
+            <p:ph type="sldImg"/>
+          </p:nvPr>
+        </p:nvSpPr>
+        <p:spPr/>
+      </p:sp>
+      <p:sp>
+        <p:nvSpPr>
+          <p:cNvPr id="3" name="Notes Placeholder 2"/>
+          <p:cNvSpPr>
+            <a:spLocks noGrp="1"/>
+          </p:cNvSpPr>
+          <p:nvPr>
+            <p:ph type="body" idx="1"/>
+          </p:nvPr>
+        </p:nvSpPr>
+        <p:spPr/>
+        <p:txBody>
+          <a:bodyPr/>
+          <a:lstStyle/>
+          <a:p>
+            <a:r>
+              <a:rPr lang="en-US"/>
+              <a:t>NOTE: I likely will not go through this slide, as Vinicius should cover this all in greater depth.</a:t>
+            </a:r>
+            <a:endParaRPr lang="en-CA"/>
+          </a:p>
+        </p:txBody>
+      </p:sp>
+      <p:sp>
+        <p:nvSpPr>
+          <p:cNvPr id="4" name="Slide Number Placeholder 3"/>
+          <p:cNvSpPr>
+            <a:spLocks noGrp="1"/>
+          </p:cNvSpPr>
+          <p:nvPr>
+            <p:ph type="sldNum" sz="quarter" idx="5"/>
+          </p:nvPr>
+        </p:nvSpPr>
+        <p:spPr/>
+        <p:txBody>
+          <a:bodyPr/>
+          <a:lstStyle/>
+          <a:p>
+            <a:fld id="{B0C7A837-00D9-4D65-B917-5078A695B722}" type="slidenum">
+              <a:rPr lang="en-CA" smtClean="0"/>
+              <a:t>5</a:t>
+            </a:fld>
+            <a:endParaRPr lang="en-CA"/>
+          </a:p>
+        </p:txBody>
+      </p:sp>
+    </p:spTree>
+    <p:extLst>
+      <p:ext uri="{BB962C8B-B14F-4D97-AF65-F5344CB8AC3E}">
+        <p14:creationId xmlns:p14="http://schemas.microsoft.com/office/powerpoint/2010/main" val="1326702412"/>
+      </p:ext>
+    </p:extLst>
+  </p:cSld>
+  <p:clrMapOvr>
+    <a:masterClrMapping/>
+  </p:clrMapOvr>
+</p:notes>
 </file>
 
 <file path=ppt/slideLayouts/slideLayout1.xml><?xml version="1.0" encoding="utf-8"?>
@@ -7231,6 +7322,1349 @@
           <p:cNvPr id="5" name="Rectangle: Rounded Corners 4">
             <a:extLst>
               <a:ext uri="{FF2B5EF4-FFF2-40B4-BE49-F238E27FC236}">
+                <a16:creationId xmlns:a16="http://schemas.microsoft.com/office/drawing/2014/main" id="{22FF9267-68B8-3BE3-A98A-747856E0EF47}"/>
+              </a:ext>
+            </a:extLst>
+          </p:cNvPr>
+          <p:cNvSpPr/>
+          <p:nvPr/>
+        </p:nvSpPr>
+        <p:spPr>
+          <a:xfrm>
+            <a:off x="366637" y="275480"/>
+            <a:ext cx="7917391" cy="726006"/>
+          </a:xfrm>
+          <a:prstGeom prst="roundRect">
+            <a:avLst/>
+          </a:prstGeom>
+          <a:solidFill>
+            <a:srgbClr val="0162B3"/>
+          </a:solidFill>
+          <a:ln>
+            <a:solidFill>
+              <a:srgbClr val="0162B3"/>
+            </a:solidFill>
+          </a:ln>
+        </p:spPr>
+        <p:style>
+          <a:lnRef idx="2">
+            <a:schemeClr val="accent1">
+              <a:shade val="50000"/>
+            </a:schemeClr>
+          </a:lnRef>
+          <a:fillRef idx="1">
+            <a:schemeClr val="accent1"/>
+          </a:fillRef>
+          <a:effectRef idx="0">
+            <a:schemeClr val="accent1"/>
+          </a:effectRef>
+          <a:fontRef idx="minor">
+            <a:schemeClr val="lt1"/>
+          </a:fontRef>
+        </p:style>
+        <p:txBody>
+          <a:bodyPr rtlCol="0" anchor="ctr"/>
+          <a:lstStyle>
+            <a:defPPr>
+              <a:defRPr lang="en-US"/>
+            </a:defPPr>
+            <a:lvl1pPr marL="0" algn="l" defTabSz="914400" rtl="0" eaLnBrk="1" latinLnBrk="0" hangingPunct="1">
+              <a:defRPr sz="1800" kern="1200">
+                <a:solidFill>
+                  <a:schemeClr val="lt1"/>
+                </a:solidFill>
+                <a:latin typeface="+mn-lt"/>
+                <a:ea typeface="+mn-ea"/>
+                <a:cs typeface="+mn-cs"/>
+              </a:defRPr>
+            </a:lvl1pPr>
+            <a:lvl2pPr marL="457200" algn="l" defTabSz="914400" rtl="0" eaLnBrk="1" latinLnBrk="0" hangingPunct="1">
+              <a:defRPr sz="1800" kern="1200">
+                <a:solidFill>
+                  <a:schemeClr val="lt1"/>
+                </a:solidFill>
+                <a:latin typeface="+mn-lt"/>
+                <a:ea typeface="+mn-ea"/>
+                <a:cs typeface="+mn-cs"/>
+              </a:defRPr>
+            </a:lvl2pPr>
+            <a:lvl3pPr marL="914400" algn="l" defTabSz="914400" rtl="0" eaLnBrk="1" latinLnBrk="0" hangingPunct="1">
+              <a:defRPr sz="1800" kern="1200">
+                <a:solidFill>
+                  <a:schemeClr val="lt1"/>
+                </a:solidFill>
+                <a:latin typeface="+mn-lt"/>
+                <a:ea typeface="+mn-ea"/>
+                <a:cs typeface="+mn-cs"/>
+              </a:defRPr>
+            </a:lvl3pPr>
+            <a:lvl4pPr marL="1371600" algn="l" defTabSz="914400" rtl="0" eaLnBrk="1" latinLnBrk="0" hangingPunct="1">
+              <a:defRPr sz="1800" kern="1200">
+                <a:solidFill>
+                  <a:schemeClr val="lt1"/>
+                </a:solidFill>
+                <a:latin typeface="+mn-lt"/>
+                <a:ea typeface="+mn-ea"/>
+                <a:cs typeface="+mn-cs"/>
+              </a:defRPr>
+            </a:lvl4pPr>
+            <a:lvl5pPr marL="1828800" algn="l" defTabSz="914400" rtl="0" eaLnBrk="1" latinLnBrk="0" hangingPunct="1">
+              <a:defRPr sz="1800" kern="1200">
+                <a:solidFill>
+                  <a:schemeClr val="lt1"/>
+                </a:solidFill>
+                <a:latin typeface="+mn-lt"/>
+                <a:ea typeface="+mn-ea"/>
+                <a:cs typeface="+mn-cs"/>
+              </a:defRPr>
+            </a:lvl5pPr>
+            <a:lvl6pPr marL="2286000" algn="l" defTabSz="914400" rtl="0" eaLnBrk="1" latinLnBrk="0" hangingPunct="1">
+              <a:defRPr sz="1800" kern="1200">
+                <a:solidFill>
+                  <a:schemeClr val="lt1"/>
+                </a:solidFill>
+                <a:latin typeface="+mn-lt"/>
+                <a:ea typeface="+mn-ea"/>
+                <a:cs typeface="+mn-cs"/>
+              </a:defRPr>
+            </a:lvl6pPr>
+            <a:lvl7pPr marL="2743200" algn="l" defTabSz="914400" rtl="0" eaLnBrk="1" latinLnBrk="0" hangingPunct="1">
+              <a:defRPr sz="1800" kern="1200">
+                <a:solidFill>
+                  <a:schemeClr val="lt1"/>
+                </a:solidFill>
+                <a:latin typeface="+mn-lt"/>
+                <a:ea typeface="+mn-ea"/>
+                <a:cs typeface="+mn-cs"/>
+              </a:defRPr>
+            </a:lvl7pPr>
+            <a:lvl8pPr marL="3200400" algn="l" defTabSz="914400" rtl="0" eaLnBrk="1" latinLnBrk="0" hangingPunct="1">
+              <a:defRPr sz="1800" kern="1200">
+                <a:solidFill>
+                  <a:schemeClr val="lt1"/>
+                </a:solidFill>
+                <a:latin typeface="+mn-lt"/>
+                <a:ea typeface="+mn-ea"/>
+                <a:cs typeface="+mn-cs"/>
+              </a:defRPr>
+            </a:lvl8pPr>
+            <a:lvl9pPr marL="3657600" algn="l" defTabSz="914400" rtl="0" eaLnBrk="1" latinLnBrk="0" hangingPunct="1">
+              <a:defRPr sz="1800" kern="1200">
+                <a:solidFill>
+                  <a:schemeClr val="lt1"/>
+                </a:solidFill>
+                <a:latin typeface="+mn-lt"/>
+                <a:ea typeface="+mn-ea"/>
+                <a:cs typeface="+mn-cs"/>
+              </a:defRPr>
+            </a:lvl9pPr>
+          </a:lstStyle>
+          <a:p>
+            <a:pPr algn="ctr"/>
+            <a:endParaRPr lang="en-CA"/>
+          </a:p>
+        </p:txBody>
+      </p:sp>
+      <p:sp>
+        <p:nvSpPr>
+          <p:cNvPr id="6" name="TextBox 5">
+            <a:extLst>
+              <a:ext uri="{FF2B5EF4-FFF2-40B4-BE49-F238E27FC236}">
+                <a16:creationId xmlns:a16="http://schemas.microsoft.com/office/drawing/2014/main" id="{43E2D577-1E20-E537-D9AC-C4C42D92B93B}"/>
+              </a:ext>
+            </a:extLst>
+          </p:cNvPr>
+          <p:cNvSpPr txBox="1"/>
+          <p:nvPr/>
+        </p:nvSpPr>
+        <p:spPr>
+          <a:xfrm>
+            <a:off x="508580" y="311794"/>
+            <a:ext cx="7561362" cy="584775"/>
+          </a:xfrm>
+          <a:prstGeom prst="rect">
+            <a:avLst/>
+          </a:prstGeom>
+          <a:noFill/>
+        </p:spPr>
+        <p:txBody>
+          <a:bodyPr wrap="square" rtlCol="0">
+            <a:spAutoFit/>
+          </a:bodyPr>
+          <a:lstStyle/>
+          <a:p>
+            <a:r>
+              <a:rPr lang="en-US" sz="3200" b="1">
+                <a:solidFill>
+                  <a:schemeClr val="bg1"/>
+                </a:solidFill>
+                <a:latin typeface="Georgia Pro" panose="02040502050405020303" pitchFamily="18" charset="0"/>
+              </a:rPr>
+              <a:t>A Jain pipeline summary</a:t>
+            </a:r>
+          </a:p>
+        </p:txBody>
+      </p:sp>
+      <p:pic>
+        <p:nvPicPr>
+          <p:cNvPr id="8" name="Picture 7">
+            <a:extLst>
+              <a:ext uri="{FF2B5EF4-FFF2-40B4-BE49-F238E27FC236}">
+                <a16:creationId xmlns:a16="http://schemas.microsoft.com/office/drawing/2014/main" id="{BA26950E-4CDF-CC4F-D749-BD292832C9F2}"/>
+              </a:ext>
+            </a:extLst>
+          </p:cNvPr>
+          <p:cNvPicPr>
+            <a:picLocks noChangeAspect="1"/>
+          </p:cNvPicPr>
+          <p:nvPr/>
+        </p:nvPicPr>
+        <p:blipFill>
+          <a:blip r:embed="rId3">
+            <a:extLst>
+              <a:ext uri="{28A0092B-C50C-407E-A947-70E740481C1C}">
+                <a14:useLocalDpi xmlns:a14="http://schemas.microsoft.com/office/drawing/2010/main" val="0"/>
+              </a:ext>
+            </a:extLst>
+          </a:blip>
+          <a:stretch>
+            <a:fillRect/>
+          </a:stretch>
+        </p:blipFill>
+        <p:spPr>
+          <a:xfrm>
+            <a:off x="8284029" y="1338941"/>
+            <a:ext cx="2090059" cy="2090059"/>
+          </a:xfrm>
+          <a:prstGeom prst="ellipse">
+            <a:avLst/>
+          </a:prstGeom>
+        </p:spPr>
+      </p:pic>
+      <p:sp>
+        <p:nvSpPr>
+          <p:cNvPr id="9" name="TextBox 8">
+            <a:extLst>
+              <a:ext uri="{FF2B5EF4-FFF2-40B4-BE49-F238E27FC236}">
+                <a16:creationId xmlns:a16="http://schemas.microsoft.com/office/drawing/2014/main" id="{A49DD760-25A1-952C-6013-6AC669564AF2}"/>
+              </a:ext>
+            </a:extLst>
+          </p:cNvPr>
+          <p:cNvSpPr txBox="1"/>
+          <p:nvPr/>
+        </p:nvSpPr>
+        <p:spPr>
+          <a:xfrm>
+            <a:off x="8284028" y="3429000"/>
+            <a:ext cx="2090059" cy="1231106"/>
+          </a:xfrm>
+          <a:prstGeom prst="rect">
+            <a:avLst/>
+          </a:prstGeom>
+          <a:noFill/>
+        </p:spPr>
+        <p:txBody>
+          <a:bodyPr wrap="square" rtlCol="0">
+            <a:spAutoFit/>
+          </a:bodyPr>
+          <a:lstStyle/>
+          <a:p>
+            <a:r>
+              <a:rPr lang="en-US">
+                <a:latin typeface="Georgia Pro" panose="02040502050405020303" pitchFamily="18" charset="0"/>
+              </a:rPr>
+              <a:t>Anjali Jain</a:t>
+            </a:r>
+          </a:p>
+          <a:p>
+            <a:r>
+              <a:rPr lang="en-US" sz="1400">
+                <a:latin typeface="Courier New" panose="02070309020205020404" pitchFamily="49" charset="0"/>
+                <a:cs typeface="Courier New" panose="02070309020205020404" pitchFamily="49" charset="0"/>
+              </a:rPr>
+              <a:t>Bioinformatician at the Centre for Computational Medicine (CCM)</a:t>
+            </a:r>
+            <a:endParaRPr lang="en-CA" sz="1400">
+              <a:latin typeface="Courier New" panose="02070309020205020404" pitchFamily="49" charset="0"/>
+              <a:cs typeface="Courier New" panose="02070309020205020404" pitchFamily="49" charset="0"/>
+            </a:endParaRPr>
+          </a:p>
+        </p:txBody>
+      </p:sp>
+      <p:sp>
+        <p:nvSpPr>
+          <p:cNvPr id="10" name="TextBox 9">
+            <a:extLst>
+              <a:ext uri="{FF2B5EF4-FFF2-40B4-BE49-F238E27FC236}">
+                <a16:creationId xmlns:a16="http://schemas.microsoft.com/office/drawing/2014/main" id="{4F53D6E2-018F-F240-F1D8-DA0C26A5859D}"/>
+              </a:ext>
+            </a:extLst>
+          </p:cNvPr>
+          <p:cNvSpPr txBox="1"/>
+          <p:nvPr/>
+        </p:nvSpPr>
+        <p:spPr>
+          <a:xfrm>
+            <a:off x="2996183" y="5564666"/>
+            <a:ext cx="3564709" cy="923330"/>
+          </a:xfrm>
+          <a:prstGeom prst="rect">
+            <a:avLst/>
+          </a:prstGeom>
+          <a:noFill/>
+          <a:ln>
+            <a:solidFill>
+              <a:schemeClr val="tx1">
+                <a:lumMod val="85000"/>
+                <a:lumOff val="15000"/>
+              </a:schemeClr>
+            </a:solidFill>
+          </a:ln>
+        </p:spPr>
+        <p:txBody>
+          <a:bodyPr wrap="square" rtlCol="0">
+            <a:spAutoFit/>
+          </a:bodyPr>
+          <a:lstStyle/>
+          <a:p>
+            <a:pPr algn="ctr">
+              <a:spcAft>
+                <a:spcPts val="1200"/>
+              </a:spcAft>
+            </a:pPr>
+            <a:r>
+              <a:rPr lang="en-CA">
+                <a:latin typeface="Verdana Pro" panose="020B0604030504040204" pitchFamily="34" charset="0"/>
+              </a:rPr>
+              <a:t>UniprotKB annotations for DefenseFinder </a:t>
+            </a:r>
+            <a:r>
+              <a:rPr lang="en-CA">
+                <a:latin typeface="Verdana Pro" panose="020B0604030504040204" pitchFamily="34" charset="0"/>
+                <a:sym typeface="Wingdings" panose="05000000000000000000" pitchFamily="2" charset="2"/>
+              </a:rPr>
+              <a:t> </a:t>
+            </a:r>
+            <a:r>
+              <a:rPr lang="en-CA" i="1">
+                <a:latin typeface="Verdana Pro" panose="020B0604030504040204" pitchFamily="34" charset="0"/>
+                <a:sym typeface="Wingdings" panose="05000000000000000000" pitchFamily="2" charset="2"/>
+              </a:rPr>
+              <a:t>H. sapiens</a:t>
+            </a:r>
+            <a:r>
+              <a:rPr lang="en-CA">
+                <a:latin typeface="Verdana Pro" panose="020B0604030504040204" pitchFamily="34" charset="0"/>
+                <a:sym typeface="Wingdings" panose="05000000000000000000" pitchFamily="2" charset="2"/>
+              </a:rPr>
+              <a:t> protein pairs</a:t>
+            </a:r>
+            <a:endParaRPr lang="en-CA">
+              <a:latin typeface="Verdana Pro" panose="020B0604030504040204" pitchFamily="34" charset="0"/>
+            </a:endParaRPr>
+          </a:p>
+        </p:txBody>
+      </p:sp>
+      <p:sp>
+        <p:nvSpPr>
+          <p:cNvPr id="11" name="TextBox 10">
+            <a:extLst>
+              <a:ext uri="{FF2B5EF4-FFF2-40B4-BE49-F238E27FC236}">
+                <a16:creationId xmlns:a16="http://schemas.microsoft.com/office/drawing/2014/main" id="{F344B9A0-65AB-D3B9-0DF4-A1F03444D005}"/>
+              </a:ext>
+            </a:extLst>
+          </p:cNvPr>
+          <p:cNvSpPr txBox="1"/>
+          <p:nvPr/>
+        </p:nvSpPr>
+        <p:spPr>
+          <a:xfrm>
+            <a:off x="2615184" y="1463533"/>
+            <a:ext cx="4224528" cy="369332"/>
+          </a:xfrm>
+          <a:prstGeom prst="rect">
+            <a:avLst/>
+          </a:prstGeom>
+          <a:noFill/>
+          <a:ln>
+            <a:solidFill>
+              <a:schemeClr val="tx1">
+                <a:lumMod val="85000"/>
+                <a:lumOff val="15000"/>
+              </a:schemeClr>
+            </a:solidFill>
+          </a:ln>
+        </p:spPr>
+        <p:txBody>
+          <a:bodyPr wrap="square" rtlCol="0">
+            <a:spAutoFit/>
+          </a:bodyPr>
+          <a:lstStyle/>
+          <a:p>
+            <a:pPr algn="ctr"/>
+            <a:r>
+              <a:rPr lang="en-US">
+                <a:latin typeface="Verdana Pro" panose="020B0604030504040204" pitchFamily="34" charset="0"/>
+              </a:rPr>
+              <a:t>DefenseFinder RefSeq IDs</a:t>
+            </a:r>
+            <a:endParaRPr lang="en-CA">
+              <a:latin typeface="Verdana Pro" panose="020B0604030504040204" pitchFamily="34" charset="0"/>
+            </a:endParaRPr>
+          </a:p>
+        </p:txBody>
+      </p:sp>
+      <p:sp>
+        <p:nvSpPr>
+          <p:cNvPr id="12" name="TextBox 11">
+            <a:extLst>
+              <a:ext uri="{FF2B5EF4-FFF2-40B4-BE49-F238E27FC236}">
+                <a16:creationId xmlns:a16="http://schemas.microsoft.com/office/drawing/2014/main" id="{D08F9F3B-E774-A0F7-D09E-D950DB7C73A8}"/>
+              </a:ext>
+            </a:extLst>
+          </p:cNvPr>
+          <p:cNvSpPr txBox="1"/>
+          <p:nvPr/>
+        </p:nvSpPr>
+        <p:spPr>
+          <a:xfrm>
+            <a:off x="2889504" y="2204139"/>
+            <a:ext cx="3675888" cy="369332"/>
+          </a:xfrm>
+          <a:prstGeom prst="rect">
+            <a:avLst/>
+          </a:prstGeom>
+          <a:noFill/>
+          <a:ln>
+            <a:solidFill>
+              <a:schemeClr val="tx1">
+                <a:lumMod val="85000"/>
+                <a:lumOff val="15000"/>
+              </a:schemeClr>
+            </a:solidFill>
+          </a:ln>
+        </p:spPr>
+        <p:txBody>
+          <a:bodyPr wrap="square" rtlCol="0">
+            <a:spAutoFit/>
+          </a:bodyPr>
+          <a:lstStyle/>
+          <a:p>
+            <a:pPr algn="ctr"/>
+            <a:r>
+              <a:rPr lang="en-US">
+                <a:latin typeface="Verdana Pro" panose="020B0604030504040204" pitchFamily="34" charset="0"/>
+              </a:rPr>
+              <a:t>DefenseFinder UniProt IDs</a:t>
+            </a:r>
+            <a:endParaRPr lang="en-CA">
+              <a:latin typeface="Verdana Pro" panose="020B0604030504040204" pitchFamily="34" charset="0"/>
+            </a:endParaRPr>
+          </a:p>
+        </p:txBody>
+      </p:sp>
+      <p:sp>
+        <p:nvSpPr>
+          <p:cNvPr id="13" name="TextBox 12">
+            <a:extLst>
+              <a:ext uri="{FF2B5EF4-FFF2-40B4-BE49-F238E27FC236}">
+                <a16:creationId xmlns:a16="http://schemas.microsoft.com/office/drawing/2014/main" id="{1FBEBDC6-CB78-10C7-35E8-F914B31880F6}"/>
+              </a:ext>
+            </a:extLst>
+          </p:cNvPr>
+          <p:cNvSpPr txBox="1"/>
+          <p:nvPr/>
+        </p:nvSpPr>
+        <p:spPr>
+          <a:xfrm>
+            <a:off x="2889504" y="2950314"/>
+            <a:ext cx="3675888" cy="646331"/>
+          </a:xfrm>
+          <a:prstGeom prst="rect">
+            <a:avLst/>
+          </a:prstGeom>
+          <a:noFill/>
+          <a:ln>
+            <a:solidFill>
+              <a:schemeClr val="tx1">
+                <a:lumMod val="85000"/>
+                <a:lumOff val="15000"/>
+              </a:schemeClr>
+            </a:solidFill>
+          </a:ln>
+        </p:spPr>
+        <p:txBody>
+          <a:bodyPr wrap="square" rtlCol="0">
+            <a:spAutoFit/>
+          </a:bodyPr>
+          <a:lstStyle/>
+          <a:p>
+            <a:pPr algn="ctr"/>
+            <a:r>
+              <a:rPr lang="en-US">
+                <a:latin typeface="Verdana Pro" panose="020B0604030504040204" pitchFamily="34" charset="0"/>
+              </a:rPr>
+              <a:t>Foldseek clusters containing DefenseFinder proteins</a:t>
+            </a:r>
+            <a:endParaRPr lang="en-CA">
+              <a:latin typeface="Verdana Pro" panose="020B0604030504040204" pitchFamily="34" charset="0"/>
+            </a:endParaRPr>
+          </a:p>
+        </p:txBody>
+      </p:sp>
+      <p:sp>
+        <p:nvSpPr>
+          <p:cNvPr id="14" name="TextBox 13">
+            <a:extLst>
+              <a:ext uri="{FF2B5EF4-FFF2-40B4-BE49-F238E27FC236}">
+                <a16:creationId xmlns:a16="http://schemas.microsoft.com/office/drawing/2014/main" id="{5343C7BB-A136-63C0-C4EF-3A912685EFCA}"/>
+              </a:ext>
+            </a:extLst>
+          </p:cNvPr>
+          <p:cNvSpPr txBox="1"/>
+          <p:nvPr/>
+        </p:nvSpPr>
+        <p:spPr>
+          <a:xfrm>
+            <a:off x="2940594" y="4008642"/>
+            <a:ext cx="3675888" cy="1200329"/>
+          </a:xfrm>
+          <a:prstGeom prst="rect">
+            <a:avLst/>
+          </a:prstGeom>
+          <a:noFill/>
+          <a:ln>
+            <a:solidFill>
+              <a:schemeClr val="tx1">
+                <a:lumMod val="85000"/>
+                <a:lumOff val="15000"/>
+              </a:schemeClr>
+            </a:solidFill>
+          </a:ln>
+        </p:spPr>
+        <p:txBody>
+          <a:bodyPr wrap="square" rtlCol="0">
+            <a:spAutoFit/>
+          </a:bodyPr>
+          <a:lstStyle/>
+          <a:p>
+            <a:pPr algn="ctr"/>
+            <a:r>
+              <a:rPr lang="en-US">
+                <a:latin typeface="Verdana Pro" panose="020B0604030504040204" pitchFamily="34" charset="0"/>
+              </a:rPr>
+              <a:t>DefenseFinder proteins and their homologous </a:t>
+            </a:r>
+            <a:r>
+              <a:rPr lang="en-US" i="1">
+                <a:latin typeface="Verdana Pro" panose="020B0604030504040204" pitchFamily="34" charset="0"/>
+              </a:rPr>
+              <a:t>H. sapiens</a:t>
+            </a:r>
+            <a:r>
+              <a:rPr lang="en-US">
+                <a:latin typeface="Verdana Pro" panose="020B0604030504040204" pitchFamily="34" charset="0"/>
+              </a:rPr>
+              <a:t> proteins (based on cluster similarity)</a:t>
+            </a:r>
+          </a:p>
+        </p:txBody>
+      </p:sp>
+      <p:sp>
+        <p:nvSpPr>
+          <p:cNvPr id="15" name="Arrow: Down 14">
+            <a:extLst>
+              <a:ext uri="{FF2B5EF4-FFF2-40B4-BE49-F238E27FC236}">
+                <a16:creationId xmlns:a16="http://schemas.microsoft.com/office/drawing/2014/main" id="{4E73F904-E2A4-9FD5-295A-44564D46AC45}"/>
+              </a:ext>
+            </a:extLst>
+          </p:cNvPr>
+          <p:cNvSpPr/>
+          <p:nvPr/>
+        </p:nvSpPr>
+        <p:spPr>
+          <a:xfrm>
+            <a:off x="4636008" y="1901952"/>
+            <a:ext cx="182880" cy="247323"/>
+          </a:xfrm>
+          <a:prstGeom prst="downArrow">
+            <a:avLst/>
+          </a:prstGeom>
+          <a:solidFill>
+            <a:schemeClr val="tx1">
+              <a:lumMod val="75000"/>
+              <a:lumOff val="25000"/>
+            </a:schemeClr>
+          </a:solidFill>
+          <a:ln>
+            <a:solidFill>
+              <a:schemeClr val="tx1">
+                <a:lumMod val="75000"/>
+                <a:lumOff val="25000"/>
+              </a:schemeClr>
+            </a:solidFill>
+          </a:ln>
+        </p:spPr>
+        <p:style>
+          <a:lnRef idx="2">
+            <a:schemeClr val="accent1">
+              <a:shade val="15000"/>
+            </a:schemeClr>
+          </a:lnRef>
+          <a:fillRef idx="1">
+            <a:schemeClr val="accent1"/>
+          </a:fillRef>
+          <a:effectRef idx="0">
+            <a:schemeClr val="accent1"/>
+          </a:effectRef>
+          <a:fontRef idx="minor">
+            <a:schemeClr val="lt1"/>
+          </a:fontRef>
+        </p:style>
+        <p:txBody>
+          <a:bodyPr rtlCol="0" anchor="ctr"/>
+          <a:lstStyle/>
+          <a:p>
+            <a:pPr algn="ctr"/>
+            <a:endParaRPr lang="en-CA"/>
+          </a:p>
+        </p:txBody>
+      </p:sp>
+      <p:sp>
+        <p:nvSpPr>
+          <p:cNvPr id="16" name="Arrow: Down 15">
+            <a:extLst>
+              <a:ext uri="{FF2B5EF4-FFF2-40B4-BE49-F238E27FC236}">
+                <a16:creationId xmlns:a16="http://schemas.microsoft.com/office/drawing/2014/main" id="{EE150987-00EA-DC4E-6EF7-B33FBF33FC50}"/>
+              </a:ext>
+            </a:extLst>
+          </p:cNvPr>
+          <p:cNvSpPr/>
+          <p:nvPr/>
+        </p:nvSpPr>
+        <p:spPr>
+          <a:xfrm>
+            <a:off x="4636008" y="2655808"/>
+            <a:ext cx="182880" cy="247323"/>
+          </a:xfrm>
+          <a:prstGeom prst="downArrow">
+            <a:avLst/>
+          </a:prstGeom>
+          <a:solidFill>
+            <a:schemeClr val="tx1">
+              <a:lumMod val="75000"/>
+              <a:lumOff val="25000"/>
+            </a:schemeClr>
+          </a:solidFill>
+          <a:ln>
+            <a:solidFill>
+              <a:schemeClr val="tx1">
+                <a:lumMod val="75000"/>
+                <a:lumOff val="25000"/>
+              </a:schemeClr>
+            </a:solidFill>
+          </a:ln>
+        </p:spPr>
+        <p:style>
+          <a:lnRef idx="2">
+            <a:schemeClr val="accent1">
+              <a:shade val="15000"/>
+            </a:schemeClr>
+          </a:lnRef>
+          <a:fillRef idx="1">
+            <a:schemeClr val="accent1"/>
+          </a:fillRef>
+          <a:effectRef idx="0">
+            <a:schemeClr val="accent1"/>
+          </a:effectRef>
+          <a:fontRef idx="minor">
+            <a:schemeClr val="lt1"/>
+          </a:fontRef>
+        </p:style>
+        <p:txBody>
+          <a:bodyPr rtlCol="0" anchor="ctr"/>
+          <a:lstStyle/>
+          <a:p>
+            <a:pPr algn="ctr"/>
+            <a:endParaRPr lang="en-CA"/>
+          </a:p>
+        </p:txBody>
+      </p:sp>
+      <p:sp>
+        <p:nvSpPr>
+          <p:cNvPr id="17" name="Arrow: Down 16">
+            <a:extLst>
+              <a:ext uri="{FF2B5EF4-FFF2-40B4-BE49-F238E27FC236}">
+                <a16:creationId xmlns:a16="http://schemas.microsoft.com/office/drawing/2014/main" id="{8B021541-69C8-8059-93C6-A8E7CAE79327}"/>
+              </a:ext>
+            </a:extLst>
+          </p:cNvPr>
+          <p:cNvSpPr/>
+          <p:nvPr/>
+        </p:nvSpPr>
+        <p:spPr>
+          <a:xfrm>
+            <a:off x="4636008" y="3684928"/>
+            <a:ext cx="182880" cy="247323"/>
+          </a:xfrm>
+          <a:prstGeom prst="downArrow">
+            <a:avLst/>
+          </a:prstGeom>
+          <a:solidFill>
+            <a:schemeClr val="tx1">
+              <a:lumMod val="75000"/>
+              <a:lumOff val="25000"/>
+            </a:schemeClr>
+          </a:solidFill>
+          <a:ln>
+            <a:solidFill>
+              <a:schemeClr val="tx1">
+                <a:lumMod val="75000"/>
+                <a:lumOff val="25000"/>
+              </a:schemeClr>
+            </a:solidFill>
+          </a:ln>
+        </p:spPr>
+        <p:style>
+          <a:lnRef idx="2">
+            <a:schemeClr val="accent1">
+              <a:shade val="15000"/>
+            </a:schemeClr>
+          </a:lnRef>
+          <a:fillRef idx="1">
+            <a:schemeClr val="accent1"/>
+          </a:fillRef>
+          <a:effectRef idx="0">
+            <a:schemeClr val="accent1"/>
+          </a:effectRef>
+          <a:fontRef idx="minor">
+            <a:schemeClr val="lt1"/>
+          </a:fontRef>
+        </p:style>
+        <p:txBody>
+          <a:bodyPr rtlCol="0" anchor="ctr"/>
+          <a:lstStyle/>
+          <a:p>
+            <a:pPr algn="ctr"/>
+            <a:endParaRPr lang="en-CA"/>
+          </a:p>
+        </p:txBody>
+      </p:sp>
+      <p:sp>
+        <p:nvSpPr>
+          <p:cNvPr id="18" name="Arrow: Down 17">
+            <a:extLst>
+              <a:ext uri="{FF2B5EF4-FFF2-40B4-BE49-F238E27FC236}">
+                <a16:creationId xmlns:a16="http://schemas.microsoft.com/office/drawing/2014/main" id="{0F5CEEFD-5B19-B315-65FA-C099CD67D796}"/>
+              </a:ext>
+            </a:extLst>
+          </p:cNvPr>
+          <p:cNvSpPr/>
+          <p:nvPr/>
+        </p:nvSpPr>
+        <p:spPr>
+          <a:xfrm>
+            <a:off x="4636008" y="5270805"/>
+            <a:ext cx="182880" cy="247323"/>
+          </a:xfrm>
+          <a:prstGeom prst="downArrow">
+            <a:avLst/>
+          </a:prstGeom>
+          <a:solidFill>
+            <a:schemeClr val="tx1">
+              <a:lumMod val="75000"/>
+              <a:lumOff val="25000"/>
+            </a:schemeClr>
+          </a:solidFill>
+          <a:ln>
+            <a:solidFill>
+              <a:schemeClr val="tx1">
+                <a:lumMod val="75000"/>
+                <a:lumOff val="25000"/>
+              </a:schemeClr>
+            </a:solidFill>
+          </a:ln>
+        </p:spPr>
+        <p:style>
+          <a:lnRef idx="2">
+            <a:schemeClr val="accent1">
+              <a:shade val="15000"/>
+            </a:schemeClr>
+          </a:lnRef>
+          <a:fillRef idx="1">
+            <a:schemeClr val="accent1"/>
+          </a:fillRef>
+          <a:effectRef idx="0">
+            <a:schemeClr val="accent1"/>
+          </a:effectRef>
+          <a:fontRef idx="minor">
+            <a:schemeClr val="lt1"/>
+          </a:fontRef>
+        </p:style>
+        <p:txBody>
+          <a:bodyPr rtlCol="0" anchor="ctr"/>
+          <a:lstStyle/>
+          <a:p>
+            <a:pPr algn="ctr"/>
+            <a:endParaRPr lang="en-CA"/>
+          </a:p>
+        </p:txBody>
+      </p:sp>
+      <p:sp>
+        <p:nvSpPr>
+          <p:cNvPr id="19" name="TextBox 18">
+            <a:extLst>
+              <a:ext uri="{FF2B5EF4-FFF2-40B4-BE49-F238E27FC236}">
+                <a16:creationId xmlns:a16="http://schemas.microsoft.com/office/drawing/2014/main" id="{37C8DE71-5FFA-E044-08A1-09A25D2E58D3}"/>
+              </a:ext>
+            </a:extLst>
+          </p:cNvPr>
+          <p:cNvSpPr txBox="1"/>
+          <p:nvPr/>
+        </p:nvSpPr>
+        <p:spPr>
+          <a:xfrm>
+            <a:off x="6716630" y="5570465"/>
+            <a:ext cx="2706624" cy="954107"/>
+          </a:xfrm>
+          <a:prstGeom prst="rect">
+            <a:avLst/>
+          </a:prstGeom>
+          <a:noFill/>
+        </p:spPr>
+        <p:txBody>
+          <a:bodyPr wrap="square" rtlCol="0">
+            <a:spAutoFit/>
+          </a:bodyPr>
+          <a:lstStyle/>
+          <a:p>
+            <a:r>
+              <a:rPr lang="en-US" sz="1400">
+                <a:latin typeface="Courier New" panose="02070309020205020404" pitchFamily="49" charset="0"/>
+                <a:cs typeface="Courier New" panose="02070309020205020404" pitchFamily="49" charset="0"/>
+              </a:rPr>
+              <a:t>321,575 protein pairs for the Zorya, Vipirin, and Gasdermin bacterial immune systems</a:t>
+            </a:r>
+          </a:p>
+        </p:txBody>
+      </p:sp>
+    </p:spTree>
+    <p:extLst>
+      <p:ext uri="{BB962C8B-B14F-4D97-AF65-F5344CB8AC3E}">
+        <p14:creationId xmlns:p14="http://schemas.microsoft.com/office/powerpoint/2010/main" val="36863894"/>
+      </p:ext>
+    </p:extLst>
+  </p:cSld>
+  <p:clrMapOvr>
+    <a:masterClrMapping/>
+  </p:clrMapOvr>
+</p:sld>
+</file>
+
+<file path=ppt/slides/slide6.xml><?xml version="1.0" encoding="utf-8"?>
+<p:sld xmlns:a="http://schemas.openxmlformats.org/drawingml/2006/main" xmlns:r="http://schemas.openxmlformats.org/officeDocument/2006/relationships" xmlns:p="http://schemas.openxmlformats.org/presentationml/2006/main">
+  <p:cSld>
+    <p:spTree>
+      <p:nvGrpSpPr>
+        <p:cNvPr id="1" name=""/>
+        <p:cNvGrpSpPr/>
+        <p:nvPr/>
+      </p:nvGrpSpPr>
+      <p:grpSpPr>
+        <a:xfrm>
+          <a:off x="0" y="0"/>
+          <a:ext cx="0" cy="0"/>
+          <a:chOff x="0" y="0"/>
+          <a:chExt cx="0" cy="0"/>
+        </a:xfrm>
+      </p:grpSpPr>
+      <p:sp>
+        <p:nvSpPr>
+          <p:cNvPr id="6" name="Rectangle: Rounded Corners 5">
+            <a:extLst>
+              <a:ext uri="{FF2B5EF4-FFF2-40B4-BE49-F238E27FC236}">
+                <a16:creationId xmlns:a16="http://schemas.microsoft.com/office/drawing/2014/main" id="{915BC284-1C37-BDC1-0835-D765741632D6}"/>
+              </a:ext>
+            </a:extLst>
+          </p:cNvPr>
+          <p:cNvSpPr/>
+          <p:nvPr/>
+        </p:nvSpPr>
+        <p:spPr>
+          <a:xfrm>
+            <a:off x="366637" y="275480"/>
+            <a:ext cx="7917391" cy="1141840"/>
+          </a:xfrm>
+          <a:prstGeom prst="roundRect">
+            <a:avLst/>
+          </a:prstGeom>
+          <a:solidFill>
+            <a:srgbClr val="0162B3"/>
+          </a:solidFill>
+          <a:ln>
+            <a:solidFill>
+              <a:srgbClr val="0162B3"/>
+            </a:solidFill>
+          </a:ln>
+        </p:spPr>
+        <p:style>
+          <a:lnRef idx="2">
+            <a:schemeClr val="accent1">
+              <a:shade val="50000"/>
+            </a:schemeClr>
+          </a:lnRef>
+          <a:fillRef idx="1">
+            <a:schemeClr val="accent1"/>
+          </a:fillRef>
+          <a:effectRef idx="0">
+            <a:schemeClr val="accent1"/>
+          </a:effectRef>
+          <a:fontRef idx="minor">
+            <a:schemeClr val="lt1"/>
+          </a:fontRef>
+        </p:style>
+        <p:txBody>
+          <a:bodyPr rtlCol="0" anchor="ctr"/>
+          <a:lstStyle>
+            <a:defPPr>
+              <a:defRPr lang="en-US"/>
+            </a:defPPr>
+            <a:lvl1pPr marL="0" algn="l" defTabSz="914400" rtl="0" eaLnBrk="1" latinLnBrk="0" hangingPunct="1">
+              <a:defRPr sz="1800" kern="1200">
+                <a:solidFill>
+                  <a:schemeClr val="lt1"/>
+                </a:solidFill>
+                <a:latin typeface="+mn-lt"/>
+                <a:ea typeface="+mn-ea"/>
+                <a:cs typeface="+mn-cs"/>
+              </a:defRPr>
+            </a:lvl1pPr>
+            <a:lvl2pPr marL="457200" algn="l" defTabSz="914400" rtl="0" eaLnBrk="1" latinLnBrk="0" hangingPunct="1">
+              <a:defRPr sz="1800" kern="1200">
+                <a:solidFill>
+                  <a:schemeClr val="lt1"/>
+                </a:solidFill>
+                <a:latin typeface="+mn-lt"/>
+                <a:ea typeface="+mn-ea"/>
+                <a:cs typeface="+mn-cs"/>
+              </a:defRPr>
+            </a:lvl2pPr>
+            <a:lvl3pPr marL="914400" algn="l" defTabSz="914400" rtl="0" eaLnBrk="1" latinLnBrk="0" hangingPunct="1">
+              <a:defRPr sz="1800" kern="1200">
+                <a:solidFill>
+                  <a:schemeClr val="lt1"/>
+                </a:solidFill>
+                <a:latin typeface="+mn-lt"/>
+                <a:ea typeface="+mn-ea"/>
+                <a:cs typeface="+mn-cs"/>
+              </a:defRPr>
+            </a:lvl3pPr>
+            <a:lvl4pPr marL="1371600" algn="l" defTabSz="914400" rtl="0" eaLnBrk="1" latinLnBrk="0" hangingPunct="1">
+              <a:defRPr sz="1800" kern="1200">
+                <a:solidFill>
+                  <a:schemeClr val="lt1"/>
+                </a:solidFill>
+                <a:latin typeface="+mn-lt"/>
+                <a:ea typeface="+mn-ea"/>
+                <a:cs typeface="+mn-cs"/>
+              </a:defRPr>
+            </a:lvl4pPr>
+            <a:lvl5pPr marL="1828800" algn="l" defTabSz="914400" rtl="0" eaLnBrk="1" latinLnBrk="0" hangingPunct="1">
+              <a:defRPr sz="1800" kern="1200">
+                <a:solidFill>
+                  <a:schemeClr val="lt1"/>
+                </a:solidFill>
+                <a:latin typeface="+mn-lt"/>
+                <a:ea typeface="+mn-ea"/>
+                <a:cs typeface="+mn-cs"/>
+              </a:defRPr>
+            </a:lvl5pPr>
+            <a:lvl6pPr marL="2286000" algn="l" defTabSz="914400" rtl="0" eaLnBrk="1" latinLnBrk="0" hangingPunct="1">
+              <a:defRPr sz="1800" kern="1200">
+                <a:solidFill>
+                  <a:schemeClr val="lt1"/>
+                </a:solidFill>
+                <a:latin typeface="+mn-lt"/>
+                <a:ea typeface="+mn-ea"/>
+                <a:cs typeface="+mn-cs"/>
+              </a:defRPr>
+            </a:lvl6pPr>
+            <a:lvl7pPr marL="2743200" algn="l" defTabSz="914400" rtl="0" eaLnBrk="1" latinLnBrk="0" hangingPunct="1">
+              <a:defRPr sz="1800" kern="1200">
+                <a:solidFill>
+                  <a:schemeClr val="lt1"/>
+                </a:solidFill>
+                <a:latin typeface="+mn-lt"/>
+                <a:ea typeface="+mn-ea"/>
+                <a:cs typeface="+mn-cs"/>
+              </a:defRPr>
+            </a:lvl7pPr>
+            <a:lvl8pPr marL="3200400" algn="l" defTabSz="914400" rtl="0" eaLnBrk="1" latinLnBrk="0" hangingPunct="1">
+              <a:defRPr sz="1800" kern="1200">
+                <a:solidFill>
+                  <a:schemeClr val="lt1"/>
+                </a:solidFill>
+                <a:latin typeface="+mn-lt"/>
+                <a:ea typeface="+mn-ea"/>
+                <a:cs typeface="+mn-cs"/>
+              </a:defRPr>
+            </a:lvl8pPr>
+            <a:lvl9pPr marL="3657600" algn="l" defTabSz="914400" rtl="0" eaLnBrk="1" latinLnBrk="0" hangingPunct="1">
+              <a:defRPr sz="1800" kern="1200">
+                <a:solidFill>
+                  <a:schemeClr val="lt1"/>
+                </a:solidFill>
+                <a:latin typeface="+mn-lt"/>
+                <a:ea typeface="+mn-ea"/>
+                <a:cs typeface="+mn-cs"/>
+              </a:defRPr>
+            </a:lvl9pPr>
+          </a:lstStyle>
+          <a:p>
+            <a:pPr algn="ctr"/>
+            <a:endParaRPr lang="en-CA"/>
+          </a:p>
+        </p:txBody>
+      </p:sp>
+      <p:sp>
+        <p:nvSpPr>
+          <p:cNvPr id="7" name="TextBox 6">
+            <a:extLst>
+              <a:ext uri="{FF2B5EF4-FFF2-40B4-BE49-F238E27FC236}">
+                <a16:creationId xmlns:a16="http://schemas.microsoft.com/office/drawing/2014/main" id="{6185E96A-B47A-F8E9-37E7-32EFB0A00396}"/>
+              </a:ext>
+            </a:extLst>
+          </p:cNvPr>
+          <p:cNvSpPr txBox="1"/>
+          <p:nvPr/>
+        </p:nvSpPr>
+        <p:spPr>
+          <a:xfrm>
+            <a:off x="508580" y="311794"/>
+            <a:ext cx="7561362" cy="892552"/>
+          </a:xfrm>
+          <a:prstGeom prst="rect">
+            <a:avLst/>
+          </a:prstGeom>
+          <a:noFill/>
+        </p:spPr>
+        <p:txBody>
+          <a:bodyPr wrap="square" rtlCol="0">
+            <a:spAutoFit/>
+          </a:bodyPr>
+          <a:lstStyle/>
+          <a:p>
+            <a:r>
+              <a:rPr lang="en-US" sz="3200" b="1">
+                <a:solidFill>
+                  <a:schemeClr val="bg1"/>
+                </a:solidFill>
+                <a:latin typeface="Georgia Pro" panose="02040502050405020303" pitchFamily="18" charset="0"/>
+              </a:rPr>
+              <a:t>Filtering step 1: </a:t>
+            </a:r>
+          </a:p>
+          <a:p>
+            <a:r>
+              <a:rPr lang="en-US" sz="2000" b="1">
+                <a:solidFill>
+                  <a:schemeClr val="bg1"/>
+                </a:solidFill>
+                <a:latin typeface="Georgia Pro" panose="02040502050405020303" pitchFamily="18" charset="0"/>
+              </a:rPr>
+              <a:t>DefenseFinder,</a:t>
+            </a:r>
+            <a:r>
+              <a:rPr lang="en-US" sz="2000" b="1" i="1">
+                <a:solidFill>
+                  <a:schemeClr val="bg1"/>
+                </a:solidFill>
+                <a:latin typeface="Georgia Pro" panose="02040502050405020303" pitchFamily="18" charset="0"/>
+              </a:rPr>
+              <a:t> H. sapiens</a:t>
+            </a:r>
+            <a:r>
+              <a:rPr lang="en-US" sz="2000" b="1">
+                <a:solidFill>
+                  <a:schemeClr val="bg1"/>
+                </a:solidFill>
+                <a:latin typeface="Georgia Pro" panose="02040502050405020303" pitchFamily="18" charset="0"/>
+              </a:rPr>
+              <a:t> protein in same cluster</a:t>
+            </a:r>
+          </a:p>
+        </p:txBody>
+      </p:sp>
+    </p:spTree>
+    <p:extLst>
+      <p:ext uri="{BB962C8B-B14F-4D97-AF65-F5344CB8AC3E}">
+        <p14:creationId xmlns:p14="http://schemas.microsoft.com/office/powerpoint/2010/main" val="390266814"/>
+      </p:ext>
+    </p:extLst>
+  </p:cSld>
+  <p:clrMapOvr>
+    <a:masterClrMapping/>
+  </p:clrMapOvr>
+</p:sld>
+</file>
+
+<file path=ppt/slides/slide7.xml><?xml version="1.0" encoding="utf-8"?>
+<p:sld xmlns:a="http://schemas.openxmlformats.org/drawingml/2006/main" xmlns:r="http://schemas.openxmlformats.org/officeDocument/2006/relationships" xmlns:p="http://schemas.openxmlformats.org/presentationml/2006/main">
+  <p:cSld>
+    <p:spTree>
+      <p:nvGrpSpPr>
+        <p:cNvPr id="1" name="">
+          <a:extLst>
+            <a:ext uri="{FF2B5EF4-FFF2-40B4-BE49-F238E27FC236}">
+              <a16:creationId xmlns:a16="http://schemas.microsoft.com/office/drawing/2014/main" id="{38A148B9-1E39-44FD-5A81-F75A036CFADC}"/>
+            </a:ext>
+          </a:extLst>
+        </p:cNvPr>
+        <p:cNvGrpSpPr/>
+        <p:nvPr/>
+      </p:nvGrpSpPr>
+      <p:grpSpPr>
+        <a:xfrm>
+          <a:off x="0" y="0"/>
+          <a:ext cx="0" cy="0"/>
+          <a:chOff x="0" y="0"/>
+          <a:chExt cx="0" cy="0"/>
+        </a:xfrm>
+      </p:grpSpPr>
+      <p:sp>
+        <p:nvSpPr>
+          <p:cNvPr id="6" name="Rectangle: Rounded Corners 5">
+            <a:extLst>
+              <a:ext uri="{FF2B5EF4-FFF2-40B4-BE49-F238E27FC236}">
+                <a16:creationId xmlns:a16="http://schemas.microsoft.com/office/drawing/2014/main" id="{252B5D1A-A0D2-E302-B4E4-D1C34592AD2F}"/>
+              </a:ext>
+            </a:extLst>
+          </p:cNvPr>
+          <p:cNvSpPr/>
+          <p:nvPr/>
+        </p:nvSpPr>
+        <p:spPr>
+          <a:xfrm>
+            <a:off x="366637" y="275480"/>
+            <a:ext cx="7917391" cy="1141840"/>
+          </a:xfrm>
+          <a:prstGeom prst="roundRect">
+            <a:avLst/>
+          </a:prstGeom>
+          <a:solidFill>
+            <a:srgbClr val="0162B3"/>
+          </a:solidFill>
+          <a:ln>
+            <a:solidFill>
+              <a:srgbClr val="0162B3"/>
+            </a:solidFill>
+          </a:ln>
+        </p:spPr>
+        <p:style>
+          <a:lnRef idx="2">
+            <a:schemeClr val="accent1">
+              <a:shade val="50000"/>
+            </a:schemeClr>
+          </a:lnRef>
+          <a:fillRef idx="1">
+            <a:schemeClr val="accent1"/>
+          </a:fillRef>
+          <a:effectRef idx="0">
+            <a:schemeClr val="accent1"/>
+          </a:effectRef>
+          <a:fontRef idx="minor">
+            <a:schemeClr val="lt1"/>
+          </a:fontRef>
+        </p:style>
+        <p:txBody>
+          <a:bodyPr rtlCol="0" anchor="ctr"/>
+          <a:lstStyle>
+            <a:defPPr>
+              <a:defRPr lang="en-US"/>
+            </a:defPPr>
+            <a:lvl1pPr marL="0" algn="l" defTabSz="914400" rtl="0" eaLnBrk="1" latinLnBrk="0" hangingPunct="1">
+              <a:defRPr sz="1800" kern="1200">
+                <a:solidFill>
+                  <a:schemeClr val="lt1"/>
+                </a:solidFill>
+                <a:latin typeface="+mn-lt"/>
+                <a:ea typeface="+mn-ea"/>
+                <a:cs typeface="+mn-cs"/>
+              </a:defRPr>
+            </a:lvl1pPr>
+            <a:lvl2pPr marL="457200" algn="l" defTabSz="914400" rtl="0" eaLnBrk="1" latinLnBrk="0" hangingPunct="1">
+              <a:defRPr sz="1800" kern="1200">
+                <a:solidFill>
+                  <a:schemeClr val="lt1"/>
+                </a:solidFill>
+                <a:latin typeface="+mn-lt"/>
+                <a:ea typeface="+mn-ea"/>
+                <a:cs typeface="+mn-cs"/>
+              </a:defRPr>
+            </a:lvl2pPr>
+            <a:lvl3pPr marL="914400" algn="l" defTabSz="914400" rtl="0" eaLnBrk="1" latinLnBrk="0" hangingPunct="1">
+              <a:defRPr sz="1800" kern="1200">
+                <a:solidFill>
+                  <a:schemeClr val="lt1"/>
+                </a:solidFill>
+                <a:latin typeface="+mn-lt"/>
+                <a:ea typeface="+mn-ea"/>
+                <a:cs typeface="+mn-cs"/>
+              </a:defRPr>
+            </a:lvl3pPr>
+            <a:lvl4pPr marL="1371600" algn="l" defTabSz="914400" rtl="0" eaLnBrk="1" latinLnBrk="0" hangingPunct="1">
+              <a:defRPr sz="1800" kern="1200">
+                <a:solidFill>
+                  <a:schemeClr val="lt1"/>
+                </a:solidFill>
+                <a:latin typeface="+mn-lt"/>
+                <a:ea typeface="+mn-ea"/>
+                <a:cs typeface="+mn-cs"/>
+              </a:defRPr>
+            </a:lvl4pPr>
+            <a:lvl5pPr marL="1828800" algn="l" defTabSz="914400" rtl="0" eaLnBrk="1" latinLnBrk="0" hangingPunct="1">
+              <a:defRPr sz="1800" kern="1200">
+                <a:solidFill>
+                  <a:schemeClr val="lt1"/>
+                </a:solidFill>
+                <a:latin typeface="+mn-lt"/>
+                <a:ea typeface="+mn-ea"/>
+                <a:cs typeface="+mn-cs"/>
+              </a:defRPr>
+            </a:lvl5pPr>
+            <a:lvl6pPr marL="2286000" algn="l" defTabSz="914400" rtl="0" eaLnBrk="1" latinLnBrk="0" hangingPunct="1">
+              <a:defRPr sz="1800" kern="1200">
+                <a:solidFill>
+                  <a:schemeClr val="lt1"/>
+                </a:solidFill>
+                <a:latin typeface="+mn-lt"/>
+                <a:ea typeface="+mn-ea"/>
+                <a:cs typeface="+mn-cs"/>
+              </a:defRPr>
+            </a:lvl6pPr>
+            <a:lvl7pPr marL="2743200" algn="l" defTabSz="914400" rtl="0" eaLnBrk="1" latinLnBrk="0" hangingPunct="1">
+              <a:defRPr sz="1800" kern="1200">
+                <a:solidFill>
+                  <a:schemeClr val="lt1"/>
+                </a:solidFill>
+                <a:latin typeface="+mn-lt"/>
+                <a:ea typeface="+mn-ea"/>
+                <a:cs typeface="+mn-cs"/>
+              </a:defRPr>
+            </a:lvl7pPr>
+            <a:lvl8pPr marL="3200400" algn="l" defTabSz="914400" rtl="0" eaLnBrk="1" latinLnBrk="0" hangingPunct="1">
+              <a:defRPr sz="1800" kern="1200">
+                <a:solidFill>
+                  <a:schemeClr val="lt1"/>
+                </a:solidFill>
+                <a:latin typeface="+mn-lt"/>
+                <a:ea typeface="+mn-ea"/>
+                <a:cs typeface="+mn-cs"/>
+              </a:defRPr>
+            </a:lvl8pPr>
+            <a:lvl9pPr marL="3657600" algn="l" defTabSz="914400" rtl="0" eaLnBrk="1" latinLnBrk="0" hangingPunct="1">
+              <a:defRPr sz="1800" kern="1200">
+                <a:solidFill>
+                  <a:schemeClr val="lt1"/>
+                </a:solidFill>
+                <a:latin typeface="+mn-lt"/>
+                <a:ea typeface="+mn-ea"/>
+                <a:cs typeface="+mn-cs"/>
+              </a:defRPr>
+            </a:lvl9pPr>
+          </a:lstStyle>
+          <a:p>
+            <a:pPr algn="ctr"/>
+            <a:endParaRPr lang="en-CA"/>
+          </a:p>
+        </p:txBody>
+      </p:sp>
+      <p:sp>
+        <p:nvSpPr>
+          <p:cNvPr id="7" name="TextBox 6">
+            <a:extLst>
+              <a:ext uri="{FF2B5EF4-FFF2-40B4-BE49-F238E27FC236}">
+                <a16:creationId xmlns:a16="http://schemas.microsoft.com/office/drawing/2014/main" id="{4A62C4DE-285D-2298-41F3-C58EFC8CEA62}"/>
+              </a:ext>
+            </a:extLst>
+          </p:cNvPr>
+          <p:cNvSpPr txBox="1"/>
+          <p:nvPr/>
+        </p:nvSpPr>
+        <p:spPr>
+          <a:xfrm>
+            <a:off x="508580" y="311794"/>
+            <a:ext cx="7561362" cy="892552"/>
+          </a:xfrm>
+          <a:prstGeom prst="rect">
+            <a:avLst/>
+          </a:prstGeom>
+          <a:noFill/>
+        </p:spPr>
+        <p:txBody>
+          <a:bodyPr wrap="square" rtlCol="0">
+            <a:spAutoFit/>
+          </a:bodyPr>
+          <a:lstStyle/>
+          <a:p>
+            <a:r>
+              <a:rPr lang="en-US" sz="3200" b="1">
+                <a:solidFill>
+                  <a:schemeClr val="bg1"/>
+                </a:solidFill>
+                <a:latin typeface="Georgia Pro" panose="02040502050405020303" pitchFamily="18" charset="0"/>
+              </a:rPr>
+              <a:t>Filtering step 2: </a:t>
+            </a:r>
+          </a:p>
+          <a:p>
+            <a:r>
+              <a:rPr lang="en-US" sz="2000" b="1">
+                <a:solidFill>
+                  <a:schemeClr val="bg1"/>
+                </a:solidFill>
+                <a:latin typeface="Georgia Pro" panose="02040502050405020303" pitchFamily="18" charset="0"/>
+              </a:rPr>
+              <a:t>Sequence length difference &lt;</a:t>
+            </a:r>
+          </a:p>
+        </p:txBody>
+      </p:sp>
+    </p:spTree>
+    <p:extLst>
+      <p:ext uri="{BB962C8B-B14F-4D97-AF65-F5344CB8AC3E}">
+        <p14:creationId xmlns:p14="http://schemas.microsoft.com/office/powerpoint/2010/main" val="741902791"/>
+      </p:ext>
+    </p:extLst>
+  </p:cSld>
+  <p:clrMapOvr>
+    <a:masterClrMapping/>
+  </p:clrMapOvr>
+</p:sld>
+</file>
+
+<file path=ppt/slides/slide8.xml><?xml version="1.0" encoding="utf-8"?>
+<p:sld xmlns:a="http://schemas.openxmlformats.org/drawingml/2006/main" xmlns:r="http://schemas.openxmlformats.org/officeDocument/2006/relationships" xmlns:p="http://schemas.openxmlformats.org/presentationml/2006/main">
+  <p:cSld>
+    <p:spTree>
+      <p:nvGrpSpPr>
+        <p:cNvPr id="1" name=""/>
+        <p:cNvGrpSpPr/>
+        <p:nvPr/>
+      </p:nvGrpSpPr>
+      <p:grpSpPr>
+        <a:xfrm>
+          <a:off x="0" y="0"/>
+          <a:ext cx="0" cy="0"/>
+          <a:chOff x="0" y="0"/>
+          <a:chExt cx="0" cy="0"/>
+        </a:xfrm>
+      </p:grpSpPr>
+      <p:sp>
+        <p:nvSpPr>
+          <p:cNvPr id="5" name="Rectangle: Rounded Corners 4">
+            <a:extLst>
+              <a:ext uri="{FF2B5EF4-FFF2-40B4-BE49-F238E27FC236}">
                 <a16:creationId xmlns:a16="http://schemas.microsoft.com/office/drawing/2014/main" id="{5A67C029-F809-4563-FEDC-0FE2666AD68F}"/>
               </a:ext>
             </a:extLst>
@@ -7438,7 +8872,7 @@
             <a:fld id="{3899FC77-40C7-4C49-9A19-86BDE9B75E8A}" type="slidenum">
               <a:rPr lang="en-CA" smtClean="0"/>
               <a:pPr/>
-              <a:t>5</a:t>
+              <a:t>8</a:t>
             </a:fld>
             <a:endParaRPr lang="en-CA" sz="1400"/>
           </a:p>

</xml_diff>

<commit_message>
Added filtering step slide.
</commit_message>
<xml_diff>
--- a/vis/reports/2026-02-18_projectUpdate_1.pptx
+++ b/vis/reports/2026-02-18_projectUpdate_1.pptx
@@ -5,7 +5,7 @@
     <p:sldMasterId id="2147483648" r:id="rId1"/>
   </p:sldMasterIdLst>
   <p:notesMasterIdLst>
-    <p:notesMasterId r:id="rId10"/>
+    <p:notesMasterId r:id="rId11"/>
   </p:notesMasterIdLst>
   <p:sldIdLst>
     <p:sldId id="256" r:id="rId2"/>
@@ -14,8 +14,9 @@
     <p:sldId id="257" r:id="rId5"/>
     <p:sldId id="262" r:id="rId6"/>
     <p:sldId id="261" r:id="rId7"/>
-    <p:sldId id="263" r:id="rId8"/>
-    <p:sldId id="260" r:id="rId9"/>
+    <p:sldId id="264" r:id="rId8"/>
+    <p:sldId id="263" r:id="rId9"/>
+    <p:sldId id="260" r:id="rId10"/>
   </p:sldIdLst>
   <p:sldSz cx="12192000" cy="6858000"/>
   <p:notesSz cx="6858000" cy="9144000"/>
@@ -8193,7 +8194,7 @@
         <p:spPr>
           <a:xfrm>
             <a:off x="366637" y="275480"/>
-            <a:ext cx="7917391" cy="1141840"/>
+            <a:ext cx="7917391" cy="712072"/>
           </a:xfrm>
           <a:prstGeom prst="roundRect">
             <a:avLst/>
@@ -8341,7 +8342,7 @@
         <p:spPr>
           <a:xfrm>
             <a:off x="508580" y="311794"/>
-            <a:ext cx="7561362" cy="892552"/>
+            <a:ext cx="7561362" cy="584775"/>
           </a:xfrm>
           <a:prstGeom prst="rect">
             <a:avLst/>
@@ -8361,40 +8362,516 @@
                 </a:solidFill>
                 <a:latin typeface="Georgia Pro" panose="02040502050405020303" pitchFamily="18" charset="0"/>
               </a:rPr>
-              <a:t>Filtering step 1: </a:t>
-            </a:r>
-          </a:p>
-          <a:p>
-            <a:r>
-              <a:rPr lang="en-US" sz="2000" b="1">
-                <a:solidFill>
-                  <a:schemeClr val="bg1"/>
-                </a:solidFill>
-                <a:latin typeface="Georgia Pro" panose="02040502050405020303" pitchFamily="18" charset="0"/>
+              <a:t>Downstream prioritization</a:t>
+            </a:r>
+            <a:endParaRPr lang="en-US" sz="2000" b="1">
+              <a:solidFill>
+                <a:schemeClr val="bg1"/>
+              </a:solidFill>
+              <a:latin typeface="Georgia Pro" panose="02040502050405020303" pitchFamily="18" charset="0"/>
+            </a:endParaRPr>
+          </a:p>
+        </p:txBody>
+      </p:sp>
+      <p:sp>
+        <p:nvSpPr>
+          <p:cNvPr id="8" name="TextBox 7">
+            <a:extLst>
+              <a:ext uri="{FF2B5EF4-FFF2-40B4-BE49-F238E27FC236}">
+                <a16:creationId xmlns:a16="http://schemas.microsoft.com/office/drawing/2014/main" id="{5D6BAABF-1AAA-E264-AB5D-709BE1E3244E}"/>
+              </a:ext>
+            </a:extLst>
+          </p:cNvPr>
+          <p:cNvSpPr txBox="1"/>
+          <p:nvPr/>
+        </p:nvSpPr>
+        <p:spPr>
+          <a:xfrm>
+            <a:off x="724552" y="1239816"/>
+            <a:ext cx="3564709" cy="1000274"/>
+          </a:xfrm>
+          <a:prstGeom prst="rect">
+            <a:avLst/>
+          </a:prstGeom>
+          <a:noFill/>
+          <a:ln>
+            <a:solidFill>
+              <a:schemeClr val="tx1">
+                <a:lumMod val="85000"/>
+                <a:lumOff val="15000"/>
+              </a:schemeClr>
+            </a:solidFill>
+          </a:ln>
+        </p:spPr>
+        <p:txBody>
+          <a:bodyPr wrap="square" rtlCol="0">
+            <a:spAutoFit/>
+          </a:bodyPr>
+          <a:lstStyle/>
+          <a:p>
+            <a:pPr algn="ctr">
+              <a:spcAft>
+                <a:spcPts val="600"/>
+              </a:spcAft>
+            </a:pPr>
+            <a:r>
+              <a:rPr lang="en-CA">
+                <a:latin typeface="Verdana Pro" panose="020B0604030504040204" pitchFamily="34" charset="0"/>
               </a:rPr>
-              <a:t>DefenseFinder,</a:t>
-            </a:r>
-            <a:r>
-              <a:rPr lang="en-US" sz="2000" b="1" i="1">
-                <a:solidFill>
-                  <a:schemeClr val="bg1"/>
-                </a:solidFill>
-                <a:latin typeface="Georgia Pro" panose="02040502050405020303" pitchFamily="18" charset="0"/>
+              <a:t>321,575 </a:t>
+            </a:r>
+          </a:p>
+          <a:p>
+            <a:pPr algn="ctr"/>
+            <a:r>
+              <a:rPr lang="en-CA">
+                <a:latin typeface="Verdana Pro" panose="020B0604030504040204" pitchFamily="34" charset="0"/>
               </a:rPr>
-              <a:t> H. sapiens</a:t>
-            </a:r>
-            <a:r>
-              <a:rPr lang="en-US" sz="2000" b="1">
-                <a:solidFill>
-                  <a:schemeClr val="bg1"/>
-                </a:solidFill>
-                <a:latin typeface="Georgia Pro" panose="02040502050405020303" pitchFamily="18" charset="0"/>
+              <a:t>DefenseFinder </a:t>
+            </a:r>
+            <a:r>
+              <a:rPr lang="en-CA">
+                <a:latin typeface="Verdana Pro" panose="020B0604030504040204" pitchFamily="34" charset="0"/>
+                <a:sym typeface="Wingdings" panose="05000000000000000000" pitchFamily="2" charset="2"/>
               </a:rPr>
-              <a:t> protein in same cluster</a:t>
-            </a:r>
-          </a:p>
-        </p:txBody>
-      </p:sp>
+              <a:t> </a:t>
+            </a:r>
+            <a:r>
+              <a:rPr lang="en-CA" i="1">
+                <a:latin typeface="Verdana Pro" panose="020B0604030504040204" pitchFamily="34" charset="0"/>
+                <a:sym typeface="Wingdings" panose="05000000000000000000" pitchFamily="2" charset="2"/>
+              </a:rPr>
+              <a:t>H. sapiens</a:t>
+            </a:r>
+            <a:r>
+              <a:rPr lang="en-CA">
+                <a:latin typeface="Verdana Pro" panose="020B0604030504040204" pitchFamily="34" charset="0"/>
+                <a:sym typeface="Wingdings" panose="05000000000000000000" pitchFamily="2" charset="2"/>
+              </a:rPr>
+              <a:t> protein pairs</a:t>
+            </a:r>
+            <a:endParaRPr lang="en-CA">
+              <a:latin typeface="Verdana Pro" panose="020B0604030504040204" pitchFamily="34" charset="0"/>
+            </a:endParaRPr>
+          </a:p>
+        </p:txBody>
+      </p:sp>
+      <p:sp>
+        <p:nvSpPr>
+          <p:cNvPr id="10" name="Arrow: Down 9">
+            <a:extLst>
+              <a:ext uri="{FF2B5EF4-FFF2-40B4-BE49-F238E27FC236}">
+                <a16:creationId xmlns:a16="http://schemas.microsoft.com/office/drawing/2014/main" id="{9647F595-9119-C810-03D9-B9DF50819D27}"/>
+              </a:ext>
+            </a:extLst>
+          </p:cNvPr>
+          <p:cNvSpPr/>
+          <p:nvPr/>
+        </p:nvSpPr>
+        <p:spPr>
+          <a:xfrm>
+            <a:off x="2306775" y="2472035"/>
+            <a:ext cx="400261" cy="541305"/>
+          </a:xfrm>
+          <a:prstGeom prst="downArrow">
+            <a:avLst/>
+          </a:prstGeom>
+          <a:solidFill>
+            <a:schemeClr val="tx1">
+              <a:lumMod val="75000"/>
+              <a:lumOff val="25000"/>
+            </a:schemeClr>
+          </a:solidFill>
+          <a:ln>
+            <a:solidFill>
+              <a:schemeClr val="tx1">
+                <a:lumMod val="75000"/>
+                <a:lumOff val="25000"/>
+              </a:schemeClr>
+            </a:solidFill>
+          </a:ln>
+        </p:spPr>
+        <p:style>
+          <a:lnRef idx="2">
+            <a:schemeClr val="accent1">
+              <a:shade val="15000"/>
+            </a:schemeClr>
+          </a:lnRef>
+          <a:fillRef idx="1">
+            <a:schemeClr val="accent1"/>
+          </a:fillRef>
+          <a:effectRef idx="0">
+            <a:schemeClr val="accent1"/>
+          </a:effectRef>
+          <a:fontRef idx="minor">
+            <a:schemeClr val="lt1"/>
+          </a:fontRef>
+        </p:style>
+        <p:txBody>
+          <a:bodyPr rtlCol="0" anchor="ctr"/>
+          <a:lstStyle/>
+          <a:p>
+            <a:pPr algn="ctr"/>
+            <a:endParaRPr lang="en-CA"/>
+          </a:p>
+        </p:txBody>
+      </p:sp>
+      <p:sp>
+        <p:nvSpPr>
+          <p:cNvPr id="11" name="TextBox 10">
+            <a:extLst>
+              <a:ext uri="{FF2B5EF4-FFF2-40B4-BE49-F238E27FC236}">
+                <a16:creationId xmlns:a16="http://schemas.microsoft.com/office/drawing/2014/main" id="{92466EFA-21A0-13A8-F7E4-8964D82A62A9}"/>
+              </a:ext>
+            </a:extLst>
+          </p:cNvPr>
+          <p:cNvSpPr txBox="1"/>
+          <p:nvPr/>
+        </p:nvSpPr>
+        <p:spPr>
+          <a:xfrm>
+            <a:off x="724552" y="3301246"/>
+            <a:ext cx="3564709" cy="1000274"/>
+          </a:xfrm>
+          <a:prstGeom prst="rect">
+            <a:avLst/>
+          </a:prstGeom>
+          <a:noFill/>
+          <a:ln>
+            <a:solidFill>
+              <a:schemeClr val="tx1">
+                <a:lumMod val="85000"/>
+                <a:lumOff val="15000"/>
+              </a:schemeClr>
+            </a:solidFill>
+          </a:ln>
+        </p:spPr>
+        <p:txBody>
+          <a:bodyPr wrap="square" rtlCol="0">
+            <a:spAutoFit/>
+          </a:bodyPr>
+          <a:lstStyle/>
+          <a:p>
+            <a:pPr algn="ctr">
+              <a:spcAft>
+                <a:spcPts val="600"/>
+              </a:spcAft>
+            </a:pPr>
+            <a:r>
+              <a:rPr lang="en-CA">
+                <a:latin typeface="Verdana Pro" panose="020B0604030504040204" pitchFamily="34" charset="0"/>
+              </a:rPr>
+              <a:t>279 </a:t>
+            </a:r>
+          </a:p>
+          <a:p>
+            <a:pPr algn="ctr"/>
+            <a:r>
+              <a:rPr lang="en-CA">
+                <a:latin typeface="Verdana Pro" panose="020B0604030504040204" pitchFamily="34" charset="0"/>
+              </a:rPr>
+              <a:t>DefenseFinder </a:t>
+            </a:r>
+            <a:r>
+              <a:rPr lang="en-CA">
+                <a:latin typeface="Verdana Pro" panose="020B0604030504040204" pitchFamily="34" charset="0"/>
+                <a:sym typeface="Wingdings" panose="05000000000000000000" pitchFamily="2" charset="2"/>
+              </a:rPr>
+              <a:t> </a:t>
+            </a:r>
+            <a:r>
+              <a:rPr lang="en-CA" i="1">
+                <a:latin typeface="Verdana Pro" panose="020B0604030504040204" pitchFamily="34" charset="0"/>
+                <a:sym typeface="Wingdings" panose="05000000000000000000" pitchFamily="2" charset="2"/>
+              </a:rPr>
+              <a:t>H. sapiens</a:t>
+            </a:r>
+            <a:r>
+              <a:rPr lang="en-CA">
+                <a:latin typeface="Verdana Pro" panose="020B0604030504040204" pitchFamily="34" charset="0"/>
+                <a:sym typeface="Wingdings" panose="05000000000000000000" pitchFamily="2" charset="2"/>
+              </a:rPr>
+              <a:t> protein pairs</a:t>
+            </a:r>
+            <a:endParaRPr lang="en-CA">
+              <a:latin typeface="Verdana Pro" panose="020B0604030504040204" pitchFamily="34" charset="0"/>
+            </a:endParaRPr>
+          </a:p>
+        </p:txBody>
+      </p:sp>
+      <p:sp>
+        <p:nvSpPr>
+          <p:cNvPr id="12" name="Arrow: Down 11">
+            <a:extLst>
+              <a:ext uri="{FF2B5EF4-FFF2-40B4-BE49-F238E27FC236}">
+                <a16:creationId xmlns:a16="http://schemas.microsoft.com/office/drawing/2014/main" id="{23F11252-A2BB-4859-9D96-C1FD460DC7B6}"/>
+              </a:ext>
+            </a:extLst>
+          </p:cNvPr>
+          <p:cNvSpPr/>
+          <p:nvPr/>
+        </p:nvSpPr>
+        <p:spPr>
+          <a:xfrm>
+            <a:off x="2306775" y="4671263"/>
+            <a:ext cx="400261" cy="541305"/>
+          </a:xfrm>
+          <a:prstGeom prst="downArrow">
+            <a:avLst/>
+          </a:prstGeom>
+          <a:solidFill>
+            <a:schemeClr val="tx1">
+              <a:lumMod val="75000"/>
+              <a:lumOff val="25000"/>
+            </a:schemeClr>
+          </a:solidFill>
+          <a:ln>
+            <a:solidFill>
+              <a:schemeClr val="tx1">
+                <a:lumMod val="75000"/>
+                <a:lumOff val="25000"/>
+              </a:schemeClr>
+            </a:solidFill>
+          </a:ln>
+        </p:spPr>
+        <p:style>
+          <a:lnRef idx="2">
+            <a:schemeClr val="accent1">
+              <a:shade val="15000"/>
+            </a:schemeClr>
+          </a:lnRef>
+          <a:fillRef idx="1">
+            <a:schemeClr val="accent1"/>
+          </a:fillRef>
+          <a:effectRef idx="0">
+            <a:schemeClr val="accent1"/>
+          </a:effectRef>
+          <a:fontRef idx="minor">
+            <a:schemeClr val="lt1"/>
+          </a:fontRef>
+        </p:style>
+        <p:txBody>
+          <a:bodyPr rtlCol="0" anchor="ctr"/>
+          <a:lstStyle/>
+          <a:p>
+            <a:pPr algn="ctr"/>
+            <a:endParaRPr lang="en-CA"/>
+          </a:p>
+        </p:txBody>
+      </p:sp>
+      <p:sp>
+        <p:nvSpPr>
+          <p:cNvPr id="13" name="TextBox 12">
+            <a:extLst>
+              <a:ext uri="{FF2B5EF4-FFF2-40B4-BE49-F238E27FC236}">
+                <a16:creationId xmlns:a16="http://schemas.microsoft.com/office/drawing/2014/main" id="{E79A94BD-85E0-019B-6FD7-D396DE211EB9}"/>
+              </a:ext>
+            </a:extLst>
+          </p:cNvPr>
+          <p:cNvSpPr txBox="1"/>
+          <p:nvPr/>
+        </p:nvSpPr>
+        <p:spPr>
+          <a:xfrm>
+            <a:off x="724550" y="5436204"/>
+            <a:ext cx="3564709" cy="1000274"/>
+          </a:xfrm>
+          <a:prstGeom prst="rect">
+            <a:avLst/>
+          </a:prstGeom>
+          <a:noFill/>
+          <a:ln>
+            <a:solidFill>
+              <a:schemeClr val="tx1">
+                <a:lumMod val="85000"/>
+                <a:lumOff val="15000"/>
+              </a:schemeClr>
+            </a:solidFill>
+          </a:ln>
+        </p:spPr>
+        <p:txBody>
+          <a:bodyPr wrap="square" rtlCol="0">
+            <a:spAutoFit/>
+          </a:bodyPr>
+          <a:lstStyle/>
+          <a:p>
+            <a:pPr algn="ctr">
+              <a:spcAft>
+                <a:spcPts val="600"/>
+              </a:spcAft>
+            </a:pPr>
+            <a:r>
+              <a:rPr lang="en-CA">
+                <a:latin typeface="Verdana Pro" panose="020B0604030504040204" pitchFamily="34" charset="0"/>
+              </a:rPr>
+              <a:t>34 </a:t>
+            </a:r>
+          </a:p>
+          <a:p>
+            <a:pPr algn="ctr"/>
+            <a:r>
+              <a:rPr lang="en-CA">
+                <a:latin typeface="Verdana Pro" panose="020B0604030504040204" pitchFamily="34" charset="0"/>
+              </a:rPr>
+              <a:t>DefenseFinder </a:t>
+            </a:r>
+            <a:r>
+              <a:rPr lang="en-CA">
+                <a:latin typeface="Verdana Pro" panose="020B0604030504040204" pitchFamily="34" charset="0"/>
+                <a:sym typeface="Wingdings" panose="05000000000000000000" pitchFamily="2" charset="2"/>
+              </a:rPr>
+              <a:t> </a:t>
+            </a:r>
+            <a:r>
+              <a:rPr lang="en-CA" i="1">
+                <a:latin typeface="Verdana Pro" panose="020B0604030504040204" pitchFamily="34" charset="0"/>
+                <a:sym typeface="Wingdings" panose="05000000000000000000" pitchFamily="2" charset="2"/>
+              </a:rPr>
+              <a:t>H. sapiens</a:t>
+            </a:r>
+            <a:r>
+              <a:rPr lang="en-CA">
+                <a:latin typeface="Verdana Pro" panose="020B0604030504040204" pitchFamily="34" charset="0"/>
+                <a:sym typeface="Wingdings" panose="05000000000000000000" pitchFamily="2" charset="2"/>
+              </a:rPr>
+              <a:t> protein pairs</a:t>
+            </a:r>
+            <a:endParaRPr lang="en-CA">
+              <a:latin typeface="Verdana Pro" panose="020B0604030504040204" pitchFamily="34" charset="0"/>
+            </a:endParaRPr>
+          </a:p>
+        </p:txBody>
+      </p:sp>
+      <p:sp>
+        <p:nvSpPr>
+          <p:cNvPr id="14" name="TextBox 13">
+            <a:extLst>
+              <a:ext uri="{FF2B5EF4-FFF2-40B4-BE49-F238E27FC236}">
+                <a16:creationId xmlns:a16="http://schemas.microsoft.com/office/drawing/2014/main" id="{FAC78FFA-CF61-EA63-94CC-4279F5467693}"/>
+              </a:ext>
+            </a:extLst>
+          </p:cNvPr>
+          <p:cNvSpPr txBox="1"/>
+          <p:nvPr/>
+        </p:nvSpPr>
+        <p:spPr>
+          <a:xfrm>
+            <a:off x="2904523" y="4788026"/>
+            <a:ext cx="3593156" cy="307777"/>
+          </a:xfrm>
+          <a:prstGeom prst="rect">
+            <a:avLst/>
+          </a:prstGeom>
+          <a:noFill/>
+        </p:spPr>
+        <p:txBody>
+          <a:bodyPr wrap="square" rtlCol="0">
+            <a:spAutoFit/>
+          </a:bodyPr>
+          <a:lstStyle/>
+          <a:p>
+            <a:r>
+              <a:rPr lang="en-US" sz="1400">
+                <a:latin typeface="Courier New" panose="02070309020205020404" pitchFamily="49" charset="0"/>
+                <a:cs typeface="Courier New" panose="02070309020205020404" pitchFamily="49" charset="0"/>
+              </a:rPr>
+              <a:t>Protein_length_difference ≤ 0.05 </a:t>
+            </a:r>
+            <a:endParaRPr lang="en-CA" sz="1400">
+              <a:latin typeface="Courier New" panose="02070309020205020404" pitchFamily="49" charset="0"/>
+              <a:cs typeface="Courier New" panose="02070309020205020404" pitchFamily="49" charset="0"/>
+            </a:endParaRPr>
+          </a:p>
+        </p:txBody>
+      </p:sp>
+      <p:sp>
+        <p:nvSpPr>
+          <p:cNvPr id="15" name="TextBox 14">
+            <a:extLst>
+              <a:ext uri="{FF2B5EF4-FFF2-40B4-BE49-F238E27FC236}">
+                <a16:creationId xmlns:a16="http://schemas.microsoft.com/office/drawing/2014/main" id="{56377CA6-9A23-742C-577B-ECBDEA9E98A8}"/>
+              </a:ext>
+            </a:extLst>
+          </p:cNvPr>
+          <p:cNvSpPr txBox="1"/>
+          <p:nvPr/>
+        </p:nvSpPr>
+        <p:spPr>
+          <a:xfrm>
+            <a:off x="2904523" y="2472035"/>
+            <a:ext cx="3593156" cy="523220"/>
+          </a:xfrm>
+          <a:prstGeom prst="rect">
+            <a:avLst/>
+          </a:prstGeom>
+          <a:noFill/>
+        </p:spPr>
+        <p:txBody>
+          <a:bodyPr wrap="square" rtlCol="0">
+            <a:spAutoFit/>
+          </a:bodyPr>
+          <a:lstStyle/>
+          <a:p>
+            <a:r>
+              <a:rPr lang="en-US" sz="1400">
+                <a:latin typeface="Courier New" panose="02070309020205020404" pitchFamily="49" charset="0"/>
+                <a:cs typeface="Courier New" panose="02070309020205020404" pitchFamily="49" charset="0"/>
+              </a:rPr>
+              <a:t>DefenseFinder cluster_id ==</a:t>
+            </a:r>
+          </a:p>
+          <a:p>
+            <a:r>
+              <a:rPr lang="en-US" sz="1400">
+                <a:latin typeface="Courier New" panose="02070309020205020404" pitchFamily="49" charset="0"/>
+                <a:cs typeface="Courier New" panose="02070309020205020404" pitchFamily="49" charset="0"/>
+              </a:rPr>
+              <a:t>H. sapiens cluster_id</a:t>
+            </a:r>
+            <a:endParaRPr lang="en-CA" sz="1400">
+              <a:latin typeface="Courier New" panose="02070309020205020404" pitchFamily="49" charset="0"/>
+              <a:cs typeface="Courier New" panose="02070309020205020404" pitchFamily="49" charset="0"/>
+            </a:endParaRPr>
+          </a:p>
+        </p:txBody>
+      </p:sp>
+      <p:pic>
+        <p:nvPicPr>
+          <p:cNvPr id="17" name="Graphic 16">
+            <a:extLst>
+              <a:ext uri="{FF2B5EF4-FFF2-40B4-BE49-F238E27FC236}">
+                <a16:creationId xmlns:a16="http://schemas.microsoft.com/office/drawing/2014/main" id="{4ECE2338-E962-3219-2BEC-675AA0198A06}"/>
+              </a:ext>
+            </a:extLst>
+          </p:cNvPr>
+          <p:cNvPicPr>
+            <a:picLocks noChangeAspect="1"/>
+          </p:cNvPicPr>
+          <p:nvPr/>
+        </p:nvPicPr>
+        <p:blipFill>
+          <a:blip r:embed="rId2">
+            <a:extLst>
+              <a:ext uri="{96DAC541-7B7A-43D3-8B79-37D633B846F1}">
+                <asvg:svgBlip xmlns:asvg="http://schemas.microsoft.com/office/drawing/2016/SVG/main" r:embed="rId3"/>
+              </a:ext>
+            </a:extLst>
+          </a:blip>
+          <a:srcRect l="5848" t="11704" r="7567"/>
+          <a:stretch>
+            <a:fillRect/>
+          </a:stretch>
+        </p:blipFill>
+        <p:spPr>
+          <a:xfrm>
+            <a:off x="7134078" y="3630656"/>
+            <a:ext cx="4901914" cy="2999231"/>
+          </a:xfrm>
+          <a:prstGeom prst="rect">
+            <a:avLst/>
+          </a:prstGeom>
+        </p:spPr>
+      </p:pic>
     </p:spTree>
     <p:extLst>
       <p:ext uri="{BB962C8B-B14F-4D97-AF65-F5344CB8AC3E}">
@@ -8416,7 +8893,7 @@
         <p:cNvPr id="1" name="">
           <a:extLst>
             <a:ext uri="{FF2B5EF4-FFF2-40B4-BE49-F238E27FC236}">
-              <a16:creationId xmlns:a16="http://schemas.microsoft.com/office/drawing/2014/main" id="{38A148B9-1E39-44FD-5A81-F75A036CFADC}"/>
+              <a16:creationId xmlns:a16="http://schemas.microsoft.com/office/drawing/2014/main" id="{052A3EB2-D499-B601-7F65-3B69125D3A7F}"/>
             </a:ext>
           </a:extLst>
         </p:cNvPr>
@@ -8433,158 +8910,93 @@
       </p:grpSpPr>
       <p:sp>
         <p:nvSpPr>
-          <p:cNvPr id="6" name="Rectangle: Rounded Corners 5">
-            <a:extLst>
-              <a:ext uri="{FF2B5EF4-FFF2-40B4-BE49-F238E27FC236}">
-                <a16:creationId xmlns:a16="http://schemas.microsoft.com/office/drawing/2014/main" id="{252B5D1A-A0D2-E302-B4E4-D1C34592AD2F}"/>
-              </a:ext>
-            </a:extLst>
-          </p:cNvPr>
-          <p:cNvSpPr/>
+          <p:cNvPr id="2" name="TextBox 1">
+            <a:extLst>
+              <a:ext uri="{FF2B5EF4-FFF2-40B4-BE49-F238E27FC236}">
+                <a16:creationId xmlns:a16="http://schemas.microsoft.com/office/drawing/2014/main" id="{077DB4CE-9751-7430-272E-D26D0606E47F}"/>
+              </a:ext>
+            </a:extLst>
+          </p:cNvPr>
+          <p:cNvSpPr txBox="1"/>
           <p:nvPr/>
         </p:nvSpPr>
         <p:spPr>
           <a:xfrm>
-            <a:off x="366637" y="275480"/>
-            <a:ext cx="7917391" cy="1141840"/>
+            <a:off x="258206" y="242412"/>
+            <a:ext cx="3564709" cy="1000274"/>
           </a:xfrm>
-          <a:prstGeom prst="roundRect">
+          <a:prstGeom prst="rect">
             <a:avLst/>
           </a:prstGeom>
-          <a:solidFill>
-            <a:srgbClr val="0162B3"/>
-          </a:solidFill>
+          <a:noFill/>
           <a:ln>
             <a:solidFill>
-              <a:srgbClr val="0162B3"/>
+              <a:schemeClr val="tx1">
+                <a:lumMod val="85000"/>
+                <a:lumOff val="15000"/>
+              </a:schemeClr>
             </a:solidFill>
           </a:ln>
         </p:spPr>
-        <p:style>
-          <a:lnRef idx="2">
-            <a:schemeClr val="accent1">
-              <a:shade val="50000"/>
-            </a:schemeClr>
-          </a:lnRef>
-          <a:fillRef idx="1">
-            <a:schemeClr val="accent1"/>
-          </a:fillRef>
-          <a:effectRef idx="0">
-            <a:schemeClr val="accent1"/>
-          </a:effectRef>
-          <a:fontRef idx="minor">
-            <a:schemeClr val="lt1"/>
-          </a:fontRef>
-        </p:style>
-        <p:txBody>
-          <a:bodyPr rtlCol="0" anchor="ctr"/>
-          <a:lstStyle>
-            <a:defPPr>
-              <a:defRPr lang="en-US"/>
-            </a:defPPr>
-            <a:lvl1pPr marL="0" algn="l" defTabSz="914400" rtl="0" eaLnBrk="1" latinLnBrk="0" hangingPunct="1">
-              <a:defRPr sz="1800" kern="1200">
-                <a:solidFill>
-                  <a:schemeClr val="lt1"/>
-                </a:solidFill>
-                <a:latin typeface="+mn-lt"/>
-                <a:ea typeface="+mn-ea"/>
-                <a:cs typeface="+mn-cs"/>
-              </a:defRPr>
-            </a:lvl1pPr>
-            <a:lvl2pPr marL="457200" algn="l" defTabSz="914400" rtl="0" eaLnBrk="1" latinLnBrk="0" hangingPunct="1">
-              <a:defRPr sz="1800" kern="1200">
-                <a:solidFill>
-                  <a:schemeClr val="lt1"/>
-                </a:solidFill>
-                <a:latin typeface="+mn-lt"/>
-                <a:ea typeface="+mn-ea"/>
-                <a:cs typeface="+mn-cs"/>
-              </a:defRPr>
-            </a:lvl2pPr>
-            <a:lvl3pPr marL="914400" algn="l" defTabSz="914400" rtl="0" eaLnBrk="1" latinLnBrk="0" hangingPunct="1">
-              <a:defRPr sz="1800" kern="1200">
-                <a:solidFill>
-                  <a:schemeClr val="lt1"/>
-                </a:solidFill>
-                <a:latin typeface="+mn-lt"/>
-                <a:ea typeface="+mn-ea"/>
-                <a:cs typeface="+mn-cs"/>
-              </a:defRPr>
-            </a:lvl3pPr>
-            <a:lvl4pPr marL="1371600" algn="l" defTabSz="914400" rtl="0" eaLnBrk="1" latinLnBrk="0" hangingPunct="1">
-              <a:defRPr sz="1800" kern="1200">
-                <a:solidFill>
-                  <a:schemeClr val="lt1"/>
-                </a:solidFill>
-                <a:latin typeface="+mn-lt"/>
-                <a:ea typeface="+mn-ea"/>
-                <a:cs typeface="+mn-cs"/>
-              </a:defRPr>
-            </a:lvl4pPr>
-            <a:lvl5pPr marL="1828800" algn="l" defTabSz="914400" rtl="0" eaLnBrk="1" latinLnBrk="0" hangingPunct="1">
-              <a:defRPr sz="1800" kern="1200">
-                <a:solidFill>
-                  <a:schemeClr val="lt1"/>
-                </a:solidFill>
-                <a:latin typeface="+mn-lt"/>
-                <a:ea typeface="+mn-ea"/>
-                <a:cs typeface="+mn-cs"/>
-              </a:defRPr>
-            </a:lvl5pPr>
-            <a:lvl6pPr marL="2286000" algn="l" defTabSz="914400" rtl="0" eaLnBrk="1" latinLnBrk="0" hangingPunct="1">
-              <a:defRPr sz="1800" kern="1200">
-                <a:solidFill>
-                  <a:schemeClr val="lt1"/>
-                </a:solidFill>
-                <a:latin typeface="+mn-lt"/>
-                <a:ea typeface="+mn-ea"/>
-                <a:cs typeface="+mn-cs"/>
-              </a:defRPr>
-            </a:lvl6pPr>
-            <a:lvl7pPr marL="2743200" algn="l" defTabSz="914400" rtl="0" eaLnBrk="1" latinLnBrk="0" hangingPunct="1">
-              <a:defRPr sz="1800" kern="1200">
-                <a:solidFill>
-                  <a:schemeClr val="lt1"/>
-                </a:solidFill>
-                <a:latin typeface="+mn-lt"/>
-                <a:ea typeface="+mn-ea"/>
-                <a:cs typeface="+mn-cs"/>
-              </a:defRPr>
-            </a:lvl7pPr>
-            <a:lvl8pPr marL="3200400" algn="l" defTabSz="914400" rtl="0" eaLnBrk="1" latinLnBrk="0" hangingPunct="1">
-              <a:defRPr sz="1800" kern="1200">
-                <a:solidFill>
-                  <a:schemeClr val="lt1"/>
-                </a:solidFill>
-                <a:latin typeface="+mn-lt"/>
-                <a:ea typeface="+mn-ea"/>
-                <a:cs typeface="+mn-cs"/>
-              </a:defRPr>
-            </a:lvl8pPr>
-            <a:lvl9pPr marL="3657600" algn="l" defTabSz="914400" rtl="0" eaLnBrk="1" latinLnBrk="0" hangingPunct="1">
-              <a:defRPr sz="1800" kern="1200">
-                <a:solidFill>
-                  <a:schemeClr val="lt1"/>
-                </a:solidFill>
-                <a:latin typeface="+mn-lt"/>
-                <a:ea typeface="+mn-ea"/>
-                <a:cs typeface="+mn-cs"/>
-              </a:defRPr>
-            </a:lvl9pPr>
-          </a:lstStyle>
+        <p:txBody>
+          <a:bodyPr wrap="square" rtlCol="0">
+            <a:spAutoFit/>
+          </a:bodyPr>
+          <a:lstStyle/>
+          <a:p>
+            <a:pPr algn="ctr">
+              <a:spcAft>
+                <a:spcPts val="600"/>
+              </a:spcAft>
+            </a:pPr>
+            <a:r>
+              <a:rPr lang="en-CA">
+                <a:latin typeface="Verdana Pro" panose="020B0604030504040204" pitchFamily="34" charset="0"/>
+              </a:rPr>
+              <a:t>34 </a:t>
+            </a:r>
+          </a:p>
           <a:p>
             <a:pPr algn="ctr"/>
-            <a:endParaRPr lang="en-CA"/>
-          </a:p>
-        </p:txBody>
-      </p:sp>
-      <p:sp>
-        <p:nvSpPr>
-          <p:cNvPr id="7" name="TextBox 6">
-            <a:extLst>
-              <a:ext uri="{FF2B5EF4-FFF2-40B4-BE49-F238E27FC236}">
-                <a16:creationId xmlns:a16="http://schemas.microsoft.com/office/drawing/2014/main" id="{4A62C4DE-285D-2298-41F3-C58EFC8CEA62}"/>
+            <a:r>
+              <a:rPr lang="en-CA">
+                <a:latin typeface="Verdana Pro" panose="020B0604030504040204" pitchFamily="34" charset="0"/>
+              </a:rPr>
+              <a:t>DefenseFinder </a:t>
+            </a:r>
+            <a:r>
+              <a:rPr lang="en-CA">
+                <a:latin typeface="Verdana Pro" panose="020B0604030504040204" pitchFamily="34" charset="0"/>
+                <a:sym typeface="Wingdings" panose="05000000000000000000" pitchFamily="2" charset="2"/>
+              </a:rPr>
+              <a:t> </a:t>
+            </a:r>
+            <a:r>
+              <a:rPr lang="en-CA" i="1">
+                <a:latin typeface="Verdana Pro" panose="020B0604030504040204" pitchFamily="34" charset="0"/>
+                <a:sym typeface="Wingdings" panose="05000000000000000000" pitchFamily="2" charset="2"/>
+              </a:rPr>
+              <a:t>H. sapiens</a:t>
+            </a:r>
+            <a:r>
+              <a:rPr lang="en-CA">
+                <a:latin typeface="Verdana Pro" panose="020B0604030504040204" pitchFamily="34" charset="0"/>
+                <a:sym typeface="Wingdings" panose="05000000000000000000" pitchFamily="2" charset="2"/>
+              </a:rPr>
+              <a:t> protein pairs</a:t>
+            </a:r>
+            <a:endParaRPr lang="en-CA">
+              <a:latin typeface="Verdana Pro" panose="020B0604030504040204" pitchFamily="34" charset="0"/>
+            </a:endParaRPr>
+          </a:p>
+        </p:txBody>
+      </p:sp>
+      <p:sp>
+        <p:nvSpPr>
+          <p:cNvPr id="3" name="TextBox 2">
+            <a:extLst>
+              <a:ext uri="{FF2B5EF4-FFF2-40B4-BE49-F238E27FC236}">
+                <a16:creationId xmlns:a16="http://schemas.microsoft.com/office/drawing/2014/main" id="{8B53FB09-2B6B-0064-11CB-046960A8A8F2}"/>
               </a:ext>
             </a:extLst>
           </p:cNvPr>
@@ -8593,8 +9005,8 @@
         </p:nvSpPr>
         <p:spPr>
           <a:xfrm>
-            <a:off x="508580" y="311794"/>
-            <a:ext cx="7561362" cy="892552"/>
+            <a:off x="851840" y="1344168"/>
+            <a:ext cx="2377440" cy="523220"/>
           </a:xfrm>
           <a:prstGeom prst="rect">
             <a:avLst/>
@@ -8607,33 +9019,35 @@
           </a:bodyPr>
           <a:lstStyle/>
           <a:p>
-            <a:r>
-              <a:rPr lang="en-US" sz="3200" b="1">
-                <a:solidFill>
-                  <a:schemeClr val="bg1"/>
-                </a:solidFill>
-                <a:latin typeface="Georgia Pro" panose="02040502050405020303" pitchFamily="18" charset="0"/>
+            <a:pPr algn="ctr"/>
+            <a:r>
+              <a:rPr lang="en-US" sz="1400">
+                <a:latin typeface="Courier New" panose="02070309020205020404" pitchFamily="49" charset="0"/>
+                <a:cs typeface="Courier New" panose="02070309020205020404" pitchFamily="49" charset="0"/>
               </a:rPr>
-              <a:t>Filtering step 2: </a:t>
-            </a:r>
-          </a:p>
-          <a:p>
-            <a:r>
-              <a:rPr lang="en-US" sz="2000" b="1">
-                <a:solidFill>
-                  <a:schemeClr val="bg1"/>
-                </a:solidFill>
-                <a:latin typeface="Georgia Pro" panose="02040502050405020303" pitchFamily="18" charset="0"/>
+              <a:t>(same cluster)</a:t>
+            </a:r>
+          </a:p>
+          <a:p>
+            <a:pPr algn="ctr"/>
+            <a:r>
+              <a:rPr lang="en-US" sz="1400">
+                <a:latin typeface="Courier New" panose="02070309020205020404" pitchFamily="49" charset="0"/>
+                <a:cs typeface="Courier New" panose="02070309020205020404" pitchFamily="49" charset="0"/>
               </a:rPr>
-              <a:t>Sequence length difference &lt;</a:t>
-            </a:r>
+              <a:t>(similar length)</a:t>
+            </a:r>
+            <a:endParaRPr lang="en-CA" sz="1400">
+              <a:latin typeface="Courier New" panose="02070309020205020404" pitchFamily="49" charset="0"/>
+              <a:cs typeface="Courier New" panose="02070309020205020404" pitchFamily="49" charset="0"/>
+            </a:endParaRPr>
           </a:p>
         </p:txBody>
       </p:sp>
     </p:spTree>
     <p:extLst>
       <p:ext uri="{BB962C8B-B14F-4D97-AF65-F5344CB8AC3E}">
-        <p14:creationId xmlns:p14="http://schemas.microsoft.com/office/powerpoint/2010/main" val="741902791"/>
+        <p14:creationId xmlns:p14="http://schemas.microsoft.com/office/powerpoint/2010/main" val="933818328"/>
       </p:ext>
     </p:extLst>
   </p:cSld>
@@ -8644,6 +9058,158 @@
 </file>
 
 <file path=ppt/slides/slide8.xml><?xml version="1.0" encoding="utf-8"?>
+<p:sld xmlns:a="http://schemas.openxmlformats.org/drawingml/2006/main" xmlns:r="http://schemas.openxmlformats.org/officeDocument/2006/relationships" xmlns:p="http://schemas.openxmlformats.org/presentationml/2006/main">
+  <p:cSld>
+    <p:spTree>
+      <p:nvGrpSpPr>
+        <p:cNvPr id="1" name=""/>
+        <p:cNvGrpSpPr/>
+        <p:nvPr/>
+      </p:nvGrpSpPr>
+      <p:grpSpPr>
+        <a:xfrm>
+          <a:off x="0" y="0"/>
+          <a:ext cx="0" cy="0"/>
+          <a:chOff x="0" y="0"/>
+          <a:chExt cx="0" cy="0"/>
+        </a:xfrm>
+      </p:grpSpPr>
+      <p:sp>
+        <p:nvSpPr>
+          <p:cNvPr id="5" name="TextBox 4">
+            <a:extLst>
+              <a:ext uri="{FF2B5EF4-FFF2-40B4-BE49-F238E27FC236}">
+                <a16:creationId xmlns:a16="http://schemas.microsoft.com/office/drawing/2014/main" id="{D4DC9F86-20C5-B794-C66D-13171E103DFD}"/>
+              </a:ext>
+            </a:extLst>
+          </p:cNvPr>
+          <p:cNvSpPr txBox="1"/>
+          <p:nvPr/>
+        </p:nvSpPr>
+        <p:spPr>
+          <a:xfrm>
+            <a:off x="294784" y="265438"/>
+            <a:ext cx="3564709" cy="1000274"/>
+          </a:xfrm>
+          <a:prstGeom prst="rect">
+            <a:avLst/>
+          </a:prstGeom>
+          <a:noFill/>
+          <a:ln>
+            <a:solidFill>
+              <a:schemeClr val="tx1">
+                <a:lumMod val="85000"/>
+                <a:lumOff val="15000"/>
+              </a:schemeClr>
+            </a:solidFill>
+          </a:ln>
+        </p:spPr>
+        <p:txBody>
+          <a:bodyPr wrap="square" rtlCol="0">
+            <a:spAutoFit/>
+          </a:bodyPr>
+          <a:lstStyle/>
+          <a:p>
+            <a:pPr algn="ctr">
+              <a:spcAft>
+                <a:spcPts val="600"/>
+              </a:spcAft>
+            </a:pPr>
+            <a:r>
+              <a:rPr lang="en-CA">
+                <a:latin typeface="Verdana Pro" panose="020B0604030504040204" pitchFamily="34" charset="0"/>
+              </a:rPr>
+              <a:t>279 </a:t>
+            </a:r>
+          </a:p>
+          <a:p>
+            <a:pPr algn="ctr"/>
+            <a:r>
+              <a:rPr lang="en-CA">
+                <a:latin typeface="Verdana Pro" panose="020B0604030504040204" pitchFamily="34" charset="0"/>
+              </a:rPr>
+              <a:t>DefenseFinder </a:t>
+            </a:r>
+            <a:r>
+              <a:rPr lang="en-CA">
+                <a:latin typeface="Verdana Pro" panose="020B0604030504040204" pitchFamily="34" charset="0"/>
+                <a:sym typeface="Wingdings" panose="05000000000000000000" pitchFamily="2" charset="2"/>
+              </a:rPr>
+              <a:t> </a:t>
+            </a:r>
+            <a:r>
+              <a:rPr lang="en-CA" i="1">
+                <a:latin typeface="Verdana Pro" panose="020B0604030504040204" pitchFamily="34" charset="0"/>
+                <a:sym typeface="Wingdings" panose="05000000000000000000" pitchFamily="2" charset="2"/>
+              </a:rPr>
+              <a:t>H. sapiens</a:t>
+            </a:r>
+            <a:r>
+              <a:rPr lang="en-CA">
+                <a:latin typeface="Verdana Pro" panose="020B0604030504040204" pitchFamily="34" charset="0"/>
+                <a:sym typeface="Wingdings" panose="05000000000000000000" pitchFamily="2" charset="2"/>
+              </a:rPr>
+              <a:t> protein pairs</a:t>
+            </a:r>
+            <a:endParaRPr lang="en-CA">
+              <a:latin typeface="Verdana Pro" panose="020B0604030504040204" pitchFamily="34" charset="0"/>
+            </a:endParaRPr>
+          </a:p>
+        </p:txBody>
+      </p:sp>
+      <p:sp>
+        <p:nvSpPr>
+          <p:cNvPr id="6" name="TextBox 5">
+            <a:extLst>
+              <a:ext uri="{FF2B5EF4-FFF2-40B4-BE49-F238E27FC236}">
+                <a16:creationId xmlns:a16="http://schemas.microsoft.com/office/drawing/2014/main" id="{1A7D2DAE-5836-47E0-0D9B-E536D872E07D}"/>
+              </a:ext>
+            </a:extLst>
+          </p:cNvPr>
+          <p:cNvSpPr txBox="1"/>
+          <p:nvPr/>
+        </p:nvSpPr>
+        <p:spPr>
+          <a:xfrm>
+            <a:off x="888418" y="1362456"/>
+            <a:ext cx="2377440" cy="307777"/>
+          </a:xfrm>
+          <a:prstGeom prst="rect">
+            <a:avLst/>
+          </a:prstGeom>
+          <a:noFill/>
+        </p:spPr>
+        <p:txBody>
+          <a:bodyPr wrap="square" rtlCol="0">
+            <a:spAutoFit/>
+          </a:bodyPr>
+          <a:lstStyle/>
+          <a:p>
+            <a:pPr algn="ctr"/>
+            <a:r>
+              <a:rPr lang="en-US" sz="1400">
+                <a:latin typeface="Courier New" panose="02070309020205020404" pitchFamily="49" charset="0"/>
+                <a:cs typeface="Courier New" panose="02070309020205020404" pitchFamily="49" charset="0"/>
+              </a:rPr>
+              <a:t>(same cluster)</a:t>
+            </a:r>
+          </a:p>
+        </p:txBody>
+      </p:sp>
+    </p:spTree>
+    <p:extLst>
+      <p:ext uri="{BB962C8B-B14F-4D97-AF65-F5344CB8AC3E}">
+        <p14:creationId xmlns:p14="http://schemas.microsoft.com/office/powerpoint/2010/main" val="3000476899"/>
+      </p:ext>
+    </p:extLst>
+  </p:cSld>
+  <p:clrMapOvr>
+    <a:masterClrMapping/>
+  </p:clrMapOvr>
+</p:sld>
+</file>
+
+<file path=ppt/slides/slide9.xml><?xml version="1.0" encoding="utf-8"?>
 <p:sld xmlns:a="http://schemas.openxmlformats.org/drawingml/2006/main" xmlns:r="http://schemas.openxmlformats.org/officeDocument/2006/relationships" xmlns:p="http://schemas.openxmlformats.org/presentationml/2006/main">
   <p:cSld>
     <p:spTree>
@@ -8872,7 +9438,7 @@
             <a:fld id="{3899FC77-40C7-4C49-9A19-86BDE9B75E8A}" type="slidenum">
               <a:rPr lang="en-CA" smtClean="0"/>
               <a:pPr/>
-              <a:t>8</a:t>
+              <a:t>9</a:t>
             </a:fld>
             <a:endParaRPr lang="en-CA" sz="1400"/>
           </a:p>

</xml_diff>

<commit_message>
Added scatter plot of RMSD v Sequence length.
</commit_message>
<xml_diff>
--- a/vis/reports/2026-02-18_projectUpdate_1.pptx
+++ b/vis/reports/2026-02-18_projectUpdate_1.pptx
@@ -5,7 +5,7 @@
     <p:sldMasterId id="2147483648" r:id="rId1"/>
   </p:sldMasterIdLst>
   <p:notesMasterIdLst>
-    <p:notesMasterId r:id="rId11"/>
+    <p:notesMasterId r:id="rId10"/>
   </p:notesMasterIdLst>
   <p:sldIdLst>
     <p:sldId id="256" r:id="rId2"/>
@@ -14,9 +14,8 @@
     <p:sldId id="257" r:id="rId5"/>
     <p:sldId id="262" r:id="rId6"/>
     <p:sldId id="261" r:id="rId7"/>
-    <p:sldId id="264" r:id="rId8"/>
-    <p:sldId id="263" r:id="rId9"/>
-    <p:sldId id="260" r:id="rId10"/>
+    <p:sldId id="263" r:id="rId8"/>
+    <p:sldId id="260" r:id="rId9"/>
   </p:sldIdLst>
   <p:sldSz cx="12192000" cy="6858000"/>
   <p:notesSz cx="6858000" cy="9144000"/>
@@ -496,6 +495,13 @@
           </p:nvPr>
         </p:nvSpPr>
         <p:spPr/>
+        <p:txBody>
+          <a:bodyPr/>
+          <a:lstStyle/>
+          <a:p>
+            <a:endParaRPr lang="en-CA"/>
+          </a:p>
+        </p:txBody>
       </p:sp>
       <p:sp>
         <p:nvSpPr>
@@ -4754,36 +4760,36 @@
                   </a:spcAft>
                 </a:pPr>
                 <a:r>
-                  <a:rPr lang="en-US" sz="1600" b="1">
+                  <a:rPr lang="en-US" sz="1600" b="1" dirty="0">
                     <a:latin typeface="Georgia Pro" panose="02040502050405020303" pitchFamily="18" charset="0"/>
                   </a:rPr>
                   <a:t>Foldseek</a:t>
                 </a:r>
                 <a:r>
-                  <a:rPr lang="en-US" sz="1600">
+                  <a:rPr lang="en-US" sz="1600" dirty="0">
                     <a:latin typeface="Georgia Pro" panose="02040502050405020303" pitchFamily="18" charset="0"/>
                   </a:rPr>
-                  <a:t>, a structure search algorithm, depends on </a:t>
+                  <a:t>, a protein structure search algorithm, depends on </a:t>
                 </a:r>
                 <a:r>
-                  <a:rPr lang="en-US" sz="1600" b="1">
+                  <a:rPr lang="en-US" sz="1600" b="1" dirty="0">
                     <a:latin typeface="Georgia Pro" panose="02040502050405020303" pitchFamily="18" charset="0"/>
                   </a:rPr>
                   <a:t>3Di</a:t>
                 </a:r>
                 <a:r>
-                  <a:rPr lang="en-US" sz="1600">
+                  <a:rPr lang="en-US" sz="1600" dirty="0">
                     <a:latin typeface="Georgia Pro" panose="02040502050405020303" pitchFamily="18" charset="0"/>
                   </a:rPr>
                   <a:t>, a method for representing 3D folded protein structures as one-dimensional sequences of a 20-letter code.</a:t>
                 </a:r>
                 <a:r>
-                  <a:rPr lang="en-US" sz="1600" baseline="30000">
+                  <a:rPr lang="en-US" sz="1600" baseline="30000" dirty="0">
                     <a:latin typeface="Georgia Pro" panose="02040502050405020303" pitchFamily="18" charset="0"/>
                   </a:rPr>
                   <a:t>1</a:t>
                 </a:r>
-                <a:endParaRPr lang="en-US" sz="1600">
+                <a:endParaRPr lang="en-US" sz="1600" dirty="0">
                   <a:latin typeface="Georgia Pro" panose="02040502050405020303" pitchFamily="18" charset="0"/>
                   <a:cs typeface="Courier New" panose="02070309020205020404" pitchFamily="49" charset="0"/>
                 </a:endParaRPr>
@@ -4795,7 +4801,7 @@
                   </a:spcAft>
                 </a:pPr>
                 <a:r>
-                  <a:rPr lang="en-US" sz="1600">
+                  <a:rPr lang="en-US" sz="1600" dirty="0">
                     <a:latin typeface="Georgia Pro" panose="02040502050405020303" pitchFamily="18" charset="0"/>
                     <a:cs typeface="Courier New" panose="02070309020205020404" pitchFamily="49" charset="0"/>
                   </a:rPr>
@@ -4809,7 +4815,7 @@
                   </a:spcAft>
                 </a:pPr>
                 <a:r>
-                  <a:rPr lang="en-US" sz="1600">
+                  <a:rPr lang="en-US" sz="1600" dirty="0">
                     <a:latin typeface="Georgia Pro" panose="02040502050405020303" pitchFamily="18" charset="0"/>
                     <a:cs typeface="Courier New" panose="02070309020205020404" pitchFamily="49" charset="0"/>
                   </a:rPr>
@@ -4827,7 +4833,7 @@
                   </m:oMath>
                 </a14:m>
                 <a:r>
-                  <a:rPr lang="en-US" sz="1600">
+                  <a:rPr lang="en-US" sz="1600" dirty="0">
                     <a:latin typeface="Georgia Pro" panose="02040502050405020303" pitchFamily="18" charset="0"/>
                     <a:cs typeface="Courier New" panose="02070309020205020404" pitchFamily="49" charset="0"/>
                   </a:rPr>
@@ -4845,7 +4851,7 @@
                   </m:oMath>
                 </a14:m>
                 <a:r>
-                  <a:rPr lang="en-US" sz="1600">
+                  <a:rPr lang="en-US" sz="1600" dirty="0">
                     <a:latin typeface="Georgia Pro" panose="02040502050405020303" pitchFamily="18" charset="0"/>
                     <a:cs typeface="Courier New" panose="02070309020205020404" pitchFamily="49" charset="0"/>
                   </a:rPr>
@@ -6299,27 +6305,27 @@
               </a:spcAft>
             </a:pPr>
             <a:r>
-              <a:rPr lang="en-US" sz="1600" b="1">
+              <a:rPr lang="en-US" sz="1600" b="1" dirty="0">
                 <a:latin typeface="Georgia Pro" panose="02040502050405020303" pitchFamily="18" charset="0"/>
                 <a:cs typeface="Courier New" panose="02070309020205020404" pitchFamily="49" charset="0"/>
               </a:rPr>
               <a:t>Foldseek cluster</a:t>
             </a:r>
             <a:r>
-              <a:rPr lang="en-US" sz="1600">
+              <a:rPr lang="en-US" sz="1600" dirty="0">
                 <a:latin typeface="Georgia Pro" panose="02040502050405020303" pitchFamily="18" charset="0"/>
                 <a:cs typeface="Courier New" panose="02070309020205020404" pitchFamily="49" charset="0"/>
               </a:rPr>
               <a:t>, a clustering algorithm, leverages both primary amino acid sequence homology and structural homology to group proteins together.</a:t>
             </a:r>
             <a:r>
-              <a:rPr lang="en-US" sz="1600" baseline="30000">
+              <a:rPr lang="en-US" sz="1600" baseline="30000" dirty="0">
                 <a:latin typeface="Georgia Pro" panose="02040502050405020303" pitchFamily="18" charset="0"/>
                 <a:cs typeface="Courier New" panose="02070309020205020404" pitchFamily="49" charset="0"/>
               </a:rPr>
               <a:t>2</a:t>
             </a:r>
-            <a:endParaRPr lang="en-US" sz="1600">
+            <a:endParaRPr lang="en-US" sz="1600" dirty="0">
               <a:latin typeface="Georgia Pro" panose="02040502050405020303" pitchFamily="18" charset="0"/>
               <a:cs typeface="Courier New" panose="02070309020205020404" pitchFamily="49" charset="0"/>
             </a:endParaRPr>
@@ -6331,11 +6337,11 @@
               </a:spcAft>
             </a:pPr>
             <a:r>
-              <a:rPr lang="en-US" sz="1600">
+              <a:rPr lang="en-US" sz="1600" dirty="0">
                 <a:latin typeface="Georgia Pro" panose="02040502050405020303" pitchFamily="18" charset="0"/>
                 <a:cs typeface="Courier New" panose="02070309020205020404" pitchFamily="49" charset="0"/>
               </a:rPr>
-              <a:t>It takes as input the entire AlphaFold database (214 million predicted structures) clustered with MMSeqs2, which uses primary amino acid sequence. Here, sequence cluster membership is thresheld at 50% sequence identity and 90% sequence alignment overlap, yielding 52 million clusters.</a:t>
+              <a:t>It takes as input the entire AlphaFold database (214 million sequences and predicted structures) clustered with MMSeqs2, which uses primary amino acid sequence. Here, sequence cluster membership is thresheld at 50% sequence identity and 90% sequence alignment overlap, yielding 52 million clusters.</a:t>
             </a:r>
           </a:p>
           <a:p>
@@ -6345,7 +6351,7 @@
               </a:spcAft>
             </a:pPr>
             <a:r>
-              <a:rPr lang="en-US" sz="1600">
+              <a:rPr lang="en-US" sz="1600" dirty="0">
                 <a:latin typeface="Georgia Pro" panose="02040502050405020303" pitchFamily="18" charset="0"/>
                 <a:cs typeface="Courier New" panose="02070309020205020404" pitchFamily="49" charset="0"/>
               </a:rPr>
@@ -6738,13 +6744,13 @@
           <a:lstStyle/>
           <a:p>
             <a:r>
-              <a:rPr lang="en-US">
+              <a:rPr lang="en-US" dirty="0">
                 <a:latin typeface="Courier New" panose="02070309020205020404" pitchFamily="49" charset="0"/>
                 <a:cs typeface="Courier New" panose="02070309020205020404" pitchFamily="49" charset="0"/>
               </a:rPr>
               <a:t>Foldseek cluster</a:t>
             </a:r>
-            <a:endParaRPr lang="en-CA">
+            <a:endParaRPr lang="en-CA" dirty="0">
               <a:latin typeface="Courier New" panose="02070309020205020404" pitchFamily="49" charset="0"/>
               <a:cs typeface="Courier New" panose="02070309020205020404" pitchFamily="49" charset="0"/>
             </a:endParaRPr>
@@ -6888,13 +6894,13 @@
           <a:lstStyle/>
           <a:p>
             <a:r>
-              <a:rPr lang="en-US" sz="1400">
+              <a:rPr lang="en-US" sz="1400" dirty="0">
                 <a:latin typeface="Verdana Pro" panose="020B0604030504040204" pitchFamily="34" charset="0"/>
                 <a:cs typeface="Arial" panose="020B0604020202020204" pitchFamily="34" charset="0"/>
               </a:rPr>
               <a:t>19 million Foldseek clusters</a:t>
             </a:r>
-            <a:endParaRPr lang="en-CA" sz="1400">
+            <a:endParaRPr lang="en-CA" sz="1400" dirty="0">
               <a:latin typeface="Verdana Pro" panose="020B0604030504040204" pitchFamily="34" charset="0"/>
               <a:cs typeface="Arial" panose="020B0604020202020204" pitchFamily="34" charset="0"/>
             </a:endParaRPr>
@@ -7167,19 +7173,19 @@
               <a:buAutoNum type="arabicPeriod"/>
             </a:pPr>
             <a:r>
-              <a:rPr lang="en-US" sz="2400">
+              <a:rPr lang="en-US" sz="2400" dirty="0">
                 <a:latin typeface="Georgia Pro" panose="02040502050405020303" pitchFamily="18" charset="0"/>
               </a:rPr>
               <a:t>Which human proteins in the Foldseek cluster dataset exhibit strong homology with bacterial immune system proteins?</a:t>
             </a:r>
-            <a:endParaRPr lang="en-US" sz="2400">
+            <a:endParaRPr lang="en-US" sz="2400" dirty="0">
               <a:latin typeface="Courier New" panose="02070309020205020404" pitchFamily="49" charset="0"/>
               <a:cs typeface="Courier New" panose="02070309020205020404" pitchFamily="49" charset="0"/>
             </a:endParaRPr>
           </a:p>
           <a:p>
             <a:pPr lvl="1"/>
-            <a:endParaRPr lang="en-US" sz="2400">
+            <a:endParaRPr lang="en-US" sz="2400" dirty="0">
               <a:latin typeface="Verdana Pro" panose="020B0604030504040204" pitchFamily="34" charset="0"/>
             </a:endParaRPr>
           </a:p>
@@ -7188,7 +7194,7 @@
               <a:buFont typeface="+mj-lt"/>
               <a:buAutoNum type="arabicPeriod"/>
             </a:pPr>
-            <a:endParaRPr lang="en-US" sz="2400">
+            <a:endParaRPr lang="en-US" sz="2400" dirty="0">
               <a:latin typeface="Verdana Pro" panose="020B0604030504040204" pitchFamily="34" charset="0"/>
             </a:endParaRPr>
           </a:p>
@@ -7201,19 +7207,47 @@
               <a:buAutoNum type="arabicPeriod"/>
             </a:pPr>
             <a:r>
-              <a:rPr lang="en-US" sz="2400">
+              <a:rPr lang="en-US" sz="2400" dirty="0">
                 <a:latin typeface="Georgia Pro" panose="02040502050405020303" pitchFamily="18" charset="0"/>
                 <a:cs typeface="Courier New" panose="02070309020205020404" pitchFamily="49" charset="0"/>
               </a:rPr>
-              <a:t>Based on the structural homology, can we hypothesise about previously uncharacterised functions of the human proteins?</a:t>
-            </a:r>
-            <a:endParaRPr lang="en-US" sz="2400">
+              <a:t>Based on the structural homology, can we </a:t>
+            </a:r>
+            <a:r>
+              <a:rPr lang="en-US" sz="2400" dirty="0" err="1">
+                <a:latin typeface="Georgia Pro" panose="02040502050405020303" pitchFamily="18" charset="0"/>
+                <a:cs typeface="Courier New" panose="02070309020205020404" pitchFamily="49" charset="0"/>
+              </a:rPr>
+              <a:t>hypothesise</a:t>
+            </a:r>
+            <a:r>
+              <a:rPr lang="en-US" sz="2400" dirty="0">
+                <a:latin typeface="Georgia Pro" panose="02040502050405020303" pitchFamily="18" charset="0"/>
+                <a:cs typeface="Courier New" panose="02070309020205020404" pitchFamily="49" charset="0"/>
+              </a:rPr>
+              <a:t> about previously </a:t>
+            </a:r>
+            <a:r>
+              <a:rPr lang="en-US" sz="2400" dirty="0" err="1">
+                <a:latin typeface="Georgia Pro" panose="02040502050405020303" pitchFamily="18" charset="0"/>
+                <a:cs typeface="Courier New" panose="02070309020205020404" pitchFamily="49" charset="0"/>
+              </a:rPr>
+              <a:t>uncharacterised</a:t>
+            </a:r>
+            <a:r>
+              <a:rPr lang="en-US" sz="2400" dirty="0">
+                <a:latin typeface="Georgia Pro" panose="02040502050405020303" pitchFamily="18" charset="0"/>
+                <a:cs typeface="Courier New" panose="02070309020205020404" pitchFamily="49" charset="0"/>
+              </a:rPr>
+              <a:t> functions of the human proteins?</a:t>
+            </a:r>
+            <a:endParaRPr lang="en-US" sz="2400" dirty="0">
               <a:latin typeface="Courier New" panose="02070309020205020404" pitchFamily="49" charset="0"/>
               <a:cs typeface="Courier New" panose="02070309020205020404" pitchFamily="49" charset="0"/>
             </a:endParaRPr>
           </a:p>
           <a:p>
-            <a:endParaRPr lang="en-US" sz="2000">
+            <a:endParaRPr lang="en-US" sz="2000" dirty="0">
               <a:latin typeface="Verdana Pro" panose="020B0604030504040204" pitchFamily="34" charset="0"/>
             </a:endParaRPr>
           </a:p>
@@ -7634,33 +7668,39 @@
               </a:spcAft>
             </a:pPr>
             <a:r>
-              <a:rPr lang="en-CA">
+              <a:rPr lang="en-CA" dirty="0" err="1">
                 <a:latin typeface="Verdana Pro" panose="020B0604030504040204" pitchFamily="34" charset="0"/>
               </a:rPr>
-              <a:t>UniprotKB annotations for DefenseFinder </a:t>
-            </a:r>
-            <a:r>
-              <a:rPr lang="en-CA">
+              <a:t>UniprotKB</a:t>
+            </a:r>
+            <a:r>
+              <a:rPr lang="en-CA" dirty="0">
+                <a:latin typeface="Verdana Pro" panose="020B0604030504040204" pitchFamily="34" charset="0"/>
+              </a:rPr>
+              <a:t> annotations for DefenseFinder </a:t>
+            </a:r>
+            <a:r>
+              <a:rPr lang="en-CA" dirty="0">
                 <a:latin typeface="Verdana Pro" panose="020B0604030504040204" pitchFamily="34" charset="0"/>
                 <a:sym typeface="Wingdings" panose="05000000000000000000" pitchFamily="2" charset="2"/>
               </a:rPr>
               <a:t> </a:t>
             </a:r>
             <a:r>
-              <a:rPr lang="en-CA" i="1">
+              <a:rPr lang="en-CA" i="1" dirty="0">
                 <a:latin typeface="Verdana Pro" panose="020B0604030504040204" pitchFamily="34" charset="0"/>
                 <a:sym typeface="Wingdings" panose="05000000000000000000" pitchFamily="2" charset="2"/>
               </a:rPr>
               <a:t>H. sapiens</a:t>
             </a:r>
             <a:r>
-              <a:rPr lang="en-CA">
+              <a:rPr lang="en-CA" dirty="0">
                 <a:latin typeface="Verdana Pro" panose="020B0604030504040204" pitchFamily="34" charset="0"/>
                 <a:sym typeface="Wingdings" panose="05000000000000000000" pitchFamily="2" charset="2"/>
               </a:rPr>
               <a:t> protein pairs</a:t>
             </a:r>
-            <a:endParaRPr lang="en-CA">
+            <a:endParaRPr lang="en-CA" dirty="0">
               <a:latin typeface="Verdana Pro" panose="020B0604030504040204" pitchFamily="34" charset="0"/>
             </a:endParaRPr>
           </a:p>
@@ -7704,12 +7744,12 @@
           <a:p>
             <a:pPr algn="ctr"/>
             <a:r>
-              <a:rPr lang="en-US">
+              <a:rPr lang="en-US" dirty="0">
                 <a:latin typeface="Verdana Pro" panose="020B0604030504040204" pitchFamily="34" charset="0"/>
               </a:rPr>
               <a:t>DefenseFinder RefSeq IDs</a:t>
             </a:r>
-            <a:endParaRPr lang="en-CA">
+            <a:endParaRPr lang="en-CA" dirty="0">
               <a:latin typeface="Verdana Pro" panose="020B0604030504040204" pitchFamily="34" charset="0"/>
             </a:endParaRPr>
           </a:p>
@@ -7753,12 +7793,12 @@
           <a:p>
             <a:pPr algn="ctr"/>
             <a:r>
-              <a:rPr lang="en-US">
+              <a:rPr lang="en-US" dirty="0">
                 <a:latin typeface="Verdana Pro" panose="020B0604030504040204" pitchFamily="34" charset="0"/>
               </a:rPr>
               <a:t>DefenseFinder UniProt IDs</a:t>
             </a:r>
-            <a:endParaRPr lang="en-CA">
+            <a:endParaRPr lang="en-CA" dirty="0">
               <a:latin typeface="Verdana Pro" panose="020B0604030504040204" pitchFamily="34" charset="0"/>
             </a:endParaRPr>
           </a:p>
@@ -7802,12 +7842,12 @@
           <a:p>
             <a:pPr algn="ctr"/>
             <a:r>
-              <a:rPr lang="en-US">
+              <a:rPr lang="en-US" dirty="0">
                 <a:latin typeface="Verdana Pro" panose="020B0604030504040204" pitchFamily="34" charset="0"/>
               </a:rPr>
               <a:t>Foldseek clusters containing DefenseFinder proteins</a:t>
             </a:r>
-            <a:endParaRPr lang="en-CA">
+            <a:endParaRPr lang="en-CA" dirty="0">
               <a:latin typeface="Verdana Pro" panose="020B0604030504040204" pitchFamily="34" charset="0"/>
             </a:endParaRPr>
           </a:p>
@@ -7851,19 +7891,19 @@
           <a:p>
             <a:pPr algn="ctr"/>
             <a:r>
-              <a:rPr lang="en-US">
+              <a:rPr lang="en-US" dirty="0">
                 <a:latin typeface="Verdana Pro" panose="020B0604030504040204" pitchFamily="34" charset="0"/>
               </a:rPr>
               <a:t>DefenseFinder proteins and their homologous </a:t>
             </a:r>
             <a:r>
-              <a:rPr lang="en-US" i="1">
+              <a:rPr lang="en-US" i="1" dirty="0">
                 <a:latin typeface="Verdana Pro" panose="020B0604030504040204" pitchFamily="34" charset="0"/>
               </a:rPr>
               <a:t>H. sapiens</a:t>
             </a:r>
             <a:r>
-              <a:rPr lang="en-US">
+              <a:rPr lang="en-US" dirty="0">
                 <a:latin typeface="Verdana Pro" panose="020B0604030504040204" pitchFamily="34" charset="0"/>
               </a:rPr>
               <a:t> proteins (based on cluster similarity)</a:t>
@@ -8415,7 +8455,7 @@
               </a:spcAft>
             </a:pPr>
             <a:r>
-              <a:rPr lang="en-CA">
+              <a:rPr lang="en-CA" dirty="0">
                 <a:latin typeface="Verdana Pro" panose="020B0604030504040204" pitchFamily="34" charset="0"/>
               </a:rPr>
               <a:t>321,575 </a:t>
@@ -8424,33 +8464,33 @@
           <a:p>
             <a:pPr algn="ctr"/>
             <a:r>
-              <a:rPr lang="en-CA">
+              <a:rPr lang="en-CA" dirty="0">
                 <a:latin typeface="Verdana Pro" panose="020B0604030504040204" pitchFamily="34" charset="0"/>
               </a:rPr>
               <a:t>DefenseFinder </a:t>
             </a:r>
             <a:r>
-              <a:rPr lang="en-CA">
+              <a:rPr lang="en-CA" dirty="0">
                 <a:latin typeface="Verdana Pro" panose="020B0604030504040204" pitchFamily="34" charset="0"/>
                 <a:sym typeface="Wingdings" panose="05000000000000000000" pitchFamily="2" charset="2"/>
               </a:rPr>
               <a:t> </a:t>
             </a:r>
             <a:r>
-              <a:rPr lang="en-CA" i="1">
+              <a:rPr lang="en-CA" i="1" dirty="0">
                 <a:latin typeface="Verdana Pro" panose="020B0604030504040204" pitchFamily="34" charset="0"/>
                 <a:sym typeface="Wingdings" panose="05000000000000000000" pitchFamily="2" charset="2"/>
               </a:rPr>
               <a:t>H. sapiens</a:t>
             </a:r>
             <a:r>
-              <a:rPr lang="en-CA">
+              <a:rPr lang="en-CA" dirty="0">
                 <a:latin typeface="Verdana Pro" panose="020B0604030504040204" pitchFamily="34" charset="0"/>
                 <a:sym typeface="Wingdings" panose="05000000000000000000" pitchFamily="2" charset="2"/>
               </a:rPr>
               <a:t> protein pairs</a:t>
             </a:r>
-            <a:endParaRPr lang="en-CA">
+            <a:endParaRPr lang="en-CA" dirty="0">
               <a:latin typeface="Verdana Pro" panose="020B0604030504040204" pitchFamily="34" charset="0"/>
             </a:endParaRPr>
           </a:p>
@@ -8558,7 +8598,7 @@
               </a:spcAft>
             </a:pPr>
             <a:r>
-              <a:rPr lang="en-CA">
+              <a:rPr lang="en-CA" dirty="0">
                 <a:latin typeface="Verdana Pro" panose="020B0604030504040204" pitchFamily="34" charset="0"/>
               </a:rPr>
               <a:t>279 </a:t>
@@ -8567,33 +8607,33 @@
           <a:p>
             <a:pPr algn="ctr"/>
             <a:r>
-              <a:rPr lang="en-CA">
+              <a:rPr lang="en-CA" dirty="0">
                 <a:latin typeface="Verdana Pro" panose="020B0604030504040204" pitchFamily="34" charset="0"/>
               </a:rPr>
               <a:t>DefenseFinder </a:t>
             </a:r>
             <a:r>
-              <a:rPr lang="en-CA">
+              <a:rPr lang="en-CA" dirty="0">
                 <a:latin typeface="Verdana Pro" panose="020B0604030504040204" pitchFamily="34" charset="0"/>
                 <a:sym typeface="Wingdings" panose="05000000000000000000" pitchFamily="2" charset="2"/>
               </a:rPr>
               <a:t> </a:t>
             </a:r>
             <a:r>
-              <a:rPr lang="en-CA" i="1">
+              <a:rPr lang="en-CA" i="1" dirty="0">
                 <a:latin typeface="Verdana Pro" panose="020B0604030504040204" pitchFamily="34" charset="0"/>
                 <a:sym typeface="Wingdings" panose="05000000000000000000" pitchFamily="2" charset="2"/>
               </a:rPr>
               <a:t>H. sapiens</a:t>
             </a:r>
             <a:r>
-              <a:rPr lang="en-CA">
+              <a:rPr lang="en-CA" dirty="0">
                 <a:latin typeface="Verdana Pro" panose="020B0604030504040204" pitchFamily="34" charset="0"/>
                 <a:sym typeface="Wingdings" panose="05000000000000000000" pitchFamily="2" charset="2"/>
               </a:rPr>
               <a:t> protein pairs</a:t>
             </a:r>
-            <a:endParaRPr lang="en-CA">
+            <a:endParaRPr lang="en-CA" dirty="0">
               <a:latin typeface="Verdana Pro" panose="020B0604030504040204" pitchFamily="34" charset="0"/>
             </a:endParaRPr>
           </a:p>
@@ -8701,7 +8741,7 @@
               </a:spcAft>
             </a:pPr>
             <a:r>
-              <a:rPr lang="en-CA">
+              <a:rPr lang="en-CA" dirty="0">
                 <a:latin typeface="Verdana Pro" panose="020B0604030504040204" pitchFamily="34" charset="0"/>
               </a:rPr>
               <a:t>34 </a:t>
@@ -8710,33 +8750,33 @@
           <a:p>
             <a:pPr algn="ctr"/>
             <a:r>
-              <a:rPr lang="en-CA">
+              <a:rPr lang="en-CA" dirty="0">
                 <a:latin typeface="Verdana Pro" panose="020B0604030504040204" pitchFamily="34" charset="0"/>
               </a:rPr>
               <a:t>DefenseFinder </a:t>
             </a:r>
             <a:r>
-              <a:rPr lang="en-CA">
+              <a:rPr lang="en-CA" dirty="0">
                 <a:latin typeface="Verdana Pro" panose="020B0604030504040204" pitchFamily="34" charset="0"/>
                 <a:sym typeface="Wingdings" panose="05000000000000000000" pitchFamily="2" charset="2"/>
               </a:rPr>
               <a:t> </a:t>
             </a:r>
             <a:r>
-              <a:rPr lang="en-CA" i="1">
+              <a:rPr lang="en-CA" i="1" dirty="0">
                 <a:latin typeface="Verdana Pro" panose="020B0604030504040204" pitchFamily="34" charset="0"/>
                 <a:sym typeface="Wingdings" panose="05000000000000000000" pitchFamily="2" charset="2"/>
               </a:rPr>
               <a:t>H. sapiens</a:t>
             </a:r>
             <a:r>
-              <a:rPr lang="en-CA">
+              <a:rPr lang="en-CA" dirty="0">
                 <a:latin typeface="Verdana Pro" panose="020B0604030504040204" pitchFamily="34" charset="0"/>
                 <a:sym typeface="Wingdings" panose="05000000000000000000" pitchFamily="2" charset="2"/>
               </a:rPr>
               <a:t> protein pairs</a:t>
             </a:r>
-            <a:endParaRPr lang="en-CA">
+            <a:endParaRPr lang="en-CA" dirty="0">
               <a:latin typeface="Verdana Pro" panose="020B0604030504040204" pitchFamily="34" charset="0"/>
             </a:endParaRPr>
           </a:p>
@@ -8813,22 +8853,43 @@
           <a:lstStyle/>
           <a:p>
             <a:r>
-              <a:rPr lang="en-US" sz="1400">
+              <a:rPr lang="en-US" sz="1400" dirty="0">
                 <a:latin typeface="Courier New" panose="02070309020205020404" pitchFamily="49" charset="0"/>
                 <a:cs typeface="Courier New" panose="02070309020205020404" pitchFamily="49" charset="0"/>
               </a:rPr>
-              <a:t>DefenseFinder cluster_id ==</a:t>
-            </a:r>
-          </a:p>
-          <a:p>
-            <a:r>
-              <a:rPr lang="en-US" sz="1400">
+              <a:t>DefenseFinder </a:t>
+            </a:r>
+            <a:r>
+              <a:rPr lang="en-US" sz="1400" dirty="0" err="1">
                 <a:latin typeface="Courier New" panose="02070309020205020404" pitchFamily="49" charset="0"/>
                 <a:cs typeface="Courier New" panose="02070309020205020404" pitchFamily="49" charset="0"/>
               </a:rPr>
-              <a:t>H. sapiens cluster_id</a:t>
-            </a:r>
-            <a:endParaRPr lang="en-CA" sz="1400">
+              <a:t>cluster_id</a:t>
+            </a:r>
+            <a:r>
+              <a:rPr lang="en-US" sz="1400" dirty="0">
+                <a:latin typeface="Courier New" panose="02070309020205020404" pitchFamily="49" charset="0"/>
+                <a:cs typeface="Courier New" panose="02070309020205020404" pitchFamily="49" charset="0"/>
+              </a:rPr>
+              <a:t> ==</a:t>
+            </a:r>
+          </a:p>
+          <a:p>
+            <a:r>
+              <a:rPr lang="en-US" sz="1400" dirty="0">
+                <a:latin typeface="Courier New" panose="02070309020205020404" pitchFamily="49" charset="0"/>
+                <a:cs typeface="Courier New" panose="02070309020205020404" pitchFamily="49" charset="0"/>
+              </a:rPr>
+              <a:t>H. sapiens </a:t>
+            </a:r>
+            <a:r>
+              <a:rPr lang="en-US" sz="1400" dirty="0" err="1">
+                <a:latin typeface="Courier New" panose="02070309020205020404" pitchFamily="49" charset="0"/>
+                <a:cs typeface="Courier New" panose="02070309020205020404" pitchFamily="49" charset="0"/>
+              </a:rPr>
+              <a:t>cluster_id</a:t>
+            </a:r>
+            <a:endParaRPr lang="en-CA" sz="1400" dirty="0">
               <a:latin typeface="Courier New" panose="02070309020205020404" pitchFamily="49" charset="0"/>
               <a:cs typeface="Courier New" panose="02070309020205020404" pitchFamily="49" charset="0"/>
             </a:endParaRPr>
@@ -8890,178 +8951,6 @@
   <p:cSld>
     <p:spTree>
       <p:nvGrpSpPr>
-        <p:cNvPr id="1" name="">
-          <a:extLst>
-            <a:ext uri="{FF2B5EF4-FFF2-40B4-BE49-F238E27FC236}">
-              <a16:creationId xmlns:a16="http://schemas.microsoft.com/office/drawing/2014/main" id="{052A3EB2-D499-B601-7F65-3B69125D3A7F}"/>
-            </a:ext>
-          </a:extLst>
-        </p:cNvPr>
-        <p:cNvGrpSpPr/>
-        <p:nvPr/>
-      </p:nvGrpSpPr>
-      <p:grpSpPr>
-        <a:xfrm>
-          <a:off x="0" y="0"/>
-          <a:ext cx="0" cy="0"/>
-          <a:chOff x="0" y="0"/>
-          <a:chExt cx="0" cy="0"/>
-        </a:xfrm>
-      </p:grpSpPr>
-      <p:sp>
-        <p:nvSpPr>
-          <p:cNvPr id="2" name="TextBox 1">
-            <a:extLst>
-              <a:ext uri="{FF2B5EF4-FFF2-40B4-BE49-F238E27FC236}">
-                <a16:creationId xmlns:a16="http://schemas.microsoft.com/office/drawing/2014/main" id="{077DB4CE-9751-7430-272E-D26D0606E47F}"/>
-              </a:ext>
-            </a:extLst>
-          </p:cNvPr>
-          <p:cNvSpPr txBox="1"/>
-          <p:nvPr/>
-        </p:nvSpPr>
-        <p:spPr>
-          <a:xfrm>
-            <a:off x="258206" y="242412"/>
-            <a:ext cx="3564709" cy="1000274"/>
-          </a:xfrm>
-          <a:prstGeom prst="rect">
-            <a:avLst/>
-          </a:prstGeom>
-          <a:noFill/>
-          <a:ln>
-            <a:solidFill>
-              <a:schemeClr val="tx1">
-                <a:lumMod val="85000"/>
-                <a:lumOff val="15000"/>
-              </a:schemeClr>
-            </a:solidFill>
-          </a:ln>
-        </p:spPr>
-        <p:txBody>
-          <a:bodyPr wrap="square" rtlCol="0">
-            <a:spAutoFit/>
-          </a:bodyPr>
-          <a:lstStyle/>
-          <a:p>
-            <a:pPr algn="ctr">
-              <a:spcAft>
-                <a:spcPts val="600"/>
-              </a:spcAft>
-            </a:pPr>
-            <a:r>
-              <a:rPr lang="en-CA">
-                <a:latin typeface="Verdana Pro" panose="020B0604030504040204" pitchFamily="34" charset="0"/>
-              </a:rPr>
-              <a:t>34 </a:t>
-            </a:r>
-          </a:p>
-          <a:p>
-            <a:pPr algn="ctr"/>
-            <a:r>
-              <a:rPr lang="en-CA">
-                <a:latin typeface="Verdana Pro" panose="020B0604030504040204" pitchFamily="34" charset="0"/>
-              </a:rPr>
-              <a:t>DefenseFinder </a:t>
-            </a:r>
-            <a:r>
-              <a:rPr lang="en-CA">
-                <a:latin typeface="Verdana Pro" panose="020B0604030504040204" pitchFamily="34" charset="0"/>
-                <a:sym typeface="Wingdings" panose="05000000000000000000" pitchFamily="2" charset="2"/>
-              </a:rPr>
-              <a:t> </a:t>
-            </a:r>
-            <a:r>
-              <a:rPr lang="en-CA" i="1">
-                <a:latin typeface="Verdana Pro" panose="020B0604030504040204" pitchFamily="34" charset="0"/>
-                <a:sym typeface="Wingdings" panose="05000000000000000000" pitchFamily="2" charset="2"/>
-              </a:rPr>
-              <a:t>H. sapiens</a:t>
-            </a:r>
-            <a:r>
-              <a:rPr lang="en-CA">
-                <a:latin typeface="Verdana Pro" panose="020B0604030504040204" pitchFamily="34" charset="0"/>
-                <a:sym typeface="Wingdings" panose="05000000000000000000" pitchFamily="2" charset="2"/>
-              </a:rPr>
-              <a:t> protein pairs</a:t>
-            </a:r>
-            <a:endParaRPr lang="en-CA">
-              <a:latin typeface="Verdana Pro" panose="020B0604030504040204" pitchFamily="34" charset="0"/>
-            </a:endParaRPr>
-          </a:p>
-        </p:txBody>
-      </p:sp>
-      <p:sp>
-        <p:nvSpPr>
-          <p:cNvPr id="3" name="TextBox 2">
-            <a:extLst>
-              <a:ext uri="{FF2B5EF4-FFF2-40B4-BE49-F238E27FC236}">
-                <a16:creationId xmlns:a16="http://schemas.microsoft.com/office/drawing/2014/main" id="{8B53FB09-2B6B-0064-11CB-046960A8A8F2}"/>
-              </a:ext>
-            </a:extLst>
-          </p:cNvPr>
-          <p:cNvSpPr txBox="1"/>
-          <p:nvPr/>
-        </p:nvSpPr>
-        <p:spPr>
-          <a:xfrm>
-            <a:off x="851840" y="1344168"/>
-            <a:ext cx="2377440" cy="523220"/>
-          </a:xfrm>
-          <a:prstGeom prst="rect">
-            <a:avLst/>
-          </a:prstGeom>
-          <a:noFill/>
-        </p:spPr>
-        <p:txBody>
-          <a:bodyPr wrap="square" rtlCol="0">
-            <a:spAutoFit/>
-          </a:bodyPr>
-          <a:lstStyle/>
-          <a:p>
-            <a:pPr algn="ctr"/>
-            <a:r>
-              <a:rPr lang="en-US" sz="1400">
-                <a:latin typeface="Courier New" panose="02070309020205020404" pitchFamily="49" charset="0"/>
-                <a:cs typeface="Courier New" panose="02070309020205020404" pitchFamily="49" charset="0"/>
-              </a:rPr>
-              <a:t>(same cluster)</a:t>
-            </a:r>
-          </a:p>
-          <a:p>
-            <a:pPr algn="ctr"/>
-            <a:r>
-              <a:rPr lang="en-US" sz="1400">
-                <a:latin typeface="Courier New" panose="02070309020205020404" pitchFamily="49" charset="0"/>
-                <a:cs typeface="Courier New" panose="02070309020205020404" pitchFamily="49" charset="0"/>
-              </a:rPr>
-              <a:t>(similar length)</a:t>
-            </a:r>
-            <a:endParaRPr lang="en-CA" sz="1400">
-              <a:latin typeface="Courier New" panose="02070309020205020404" pitchFamily="49" charset="0"/>
-              <a:cs typeface="Courier New" panose="02070309020205020404" pitchFamily="49" charset="0"/>
-            </a:endParaRPr>
-          </a:p>
-        </p:txBody>
-      </p:sp>
-    </p:spTree>
-    <p:extLst>
-      <p:ext uri="{BB962C8B-B14F-4D97-AF65-F5344CB8AC3E}">
-        <p14:creationId xmlns:p14="http://schemas.microsoft.com/office/powerpoint/2010/main" val="933818328"/>
-      </p:ext>
-    </p:extLst>
-  </p:cSld>
-  <p:clrMapOvr>
-    <a:masterClrMapping/>
-  </p:clrMapOvr>
-</p:sld>
-</file>
-
-<file path=ppt/slides/slide8.xml><?xml version="1.0" encoding="utf-8"?>
-<p:sld xmlns:a="http://schemas.openxmlformats.org/drawingml/2006/main" xmlns:r="http://schemas.openxmlformats.org/officeDocument/2006/relationships" xmlns:p="http://schemas.openxmlformats.org/presentationml/2006/main">
-  <p:cSld>
-    <p:spTree>
-      <p:nvGrpSpPr>
         <p:cNvPr id="1" name=""/>
         <p:cNvGrpSpPr/>
         <p:nvPr/>
@@ -9116,7 +9005,7 @@
               </a:spcAft>
             </a:pPr>
             <a:r>
-              <a:rPr lang="en-CA">
+              <a:rPr lang="en-CA" dirty="0">
                 <a:latin typeface="Verdana Pro" panose="020B0604030504040204" pitchFamily="34" charset="0"/>
               </a:rPr>
               <a:t>279 </a:t>
@@ -9125,77 +9014,75 @@
           <a:p>
             <a:pPr algn="ctr"/>
             <a:r>
-              <a:rPr lang="en-CA">
+              <a:rPr lang="en-CA" dirty="0">
                 <a:latin typeface="Verdana Pro" panose="020B0604030504040204" pitchFamily="34" charset="0"/>
               </a:rPr>
               <a:t>DefenseFinder </a:t>
             </a:r>
             <a:r>
-              <a:rPr lang="en-CA">
+              <a:rPr lang="en-CA" dirty="0">
                 <a:latin typeface="Verdana Pro" panose="020B0604030504040204" pitchFamily="34" charset="0"/>
                 <a:sym typeface="Wingdings" panose="05000000000000000000" pitchFamily="2" charset="2"/>
               </a:rPr>
               <a:t> </a:t>
             </a:r>
             <a:r>
-              <a:rPr lang="en-CA" i="1">
+              <a:rPr lang="en-CA" i="1" dirty="0">
                 <a:latin typeface="Verdana Pro" panose="020B0604030504040204" pitchFamily="34" charset="0"/>
                 <a:sym typeface="Wingdings" panose="05000000000000000000" pitchFamily="2" charset="2"/>
               </a:rPr>
               <a:t>H. sapiens</a:t>
             </a:r>
             <a:r>
-              <a:rPr lang="en-CA">
+              <a:rPr lang="en-CA" dirty="0">
                 <a:latin typeface="Verdana Pro" panose="020B0604030504040204" pitchFamily="34" charset="0"/>
                 <a:sym typeface="Wingdings" panose="05000000000000000000" pitchFamily="2" charset="2"/>
               </a:rPr>
-              <a:t> protein pairs</a:t>
-            </a:r>
-            <a:endParaRPr lang="en-CA">
+              <a:t> same-cluster protein pairs</a:t>
+            </a:r>
+            <a:endParaRPr lang="en-CA" dirty="0">
               <a:latin typeface="Verdana Pro" panose="020B0604030504040204" pitchFamily="34" charset="0"/>
             </a:endParaRPr>
           </a:p>
         </p:txBody>
       </p:sp>
-      <p:sp>
-        <p:nvSpPr>
-          <p:cNvPr id="6" name="TextBox 5">
-            <a:extLst>
-              <a:ext uri="{FF2B5EF4-FFF2-40B4-BE49-F238E27FC236}">
-                <a16:creationId xmlns:a16="http://schemas.microsoft.com/office/drawing/2014/main" id="{1A7D2DAE-5836-47E0-0D9B-E536D872E07D}"/>
-              </a:ext>
-            </a:extLst>
-          </p:cNvPr>
-          <p:cNvSpPr txBox="1"/>
+      <p:pic>
+        <p:nvPicPr>
+          <p:cNvPr id="9" name="Graphic 8">
+            <a:extLst>
+              <a:ext uri="{FF2B5EF4-FFF2-40B4-BE49-F238E27FC236}">
+                <a16:creationId xmlns:a16="http://schemas.microsoft.com/office/drawing/2014/main" id="{9F7EF653-1BC7-4E64-765E-E1F0D14C272C}"/>
+              </a:ext>
+            </a:extLst>
+          </p:cNvPr>
+          <p:cNvPicPr>
+            <a:picLocks noChangeAspect="1"/>
+          </p:cNvPicPr>
           <p:nvPr/>
-        </p:nvSpPr>
+        </p:nvPicPr>
+        <p:blipFill>
+          <a:blip r:embed="rId2">
+            <a:extLst>
+              <a:ext uri="{96DAC541-7B7A-43D3-8B79-37D633B846F1}">
+                <asvg:svgBlip xmlns:asvg="http://schemas.microsoft.com/office/drawing/2016/SVG/main" r:embed="rId3"/>
+              </a:ext>
+            </a:extLst>
+          </a:blip>
+          <a:srcRect l="390" t="10879" r="8279"/>
+          <a:stretch>
+            <a:fillRect/>
+          </a:stretch>
+        </p:blipFill>
         <p:spPr>
           <a:xfrm>
-            <a:off x="888418" y="1362456"/>
-            <a:ext cx="2377440" cy="307777"/>
+            <a:off x="7059168" y="2441448"/>
+            <a:ext cx="4258034" cy="4154880"/>
           </a:xfrm>
           <a:prstGeom prst="rect">
             <a:avLst/>
           </a:prstGeom>
-          <a:noFill/>
         </p:spPr>
-        <p:txBody>
-          <a:bodyPr wrap="square" rtlCol="0">
-            <a:spAutoFit/>
-          </a:bodyPr>
-          <a:lstStyle/>
-          <a:p>
-            <a:pPr algn="ctr"/>
-            <a:r>
-              <a:rPr lang="en-US" sz="1400">
-                <a:latin typeface="Courier New" panose="02070309020205020404" pitchFamily="49" charset="0"/>
-                <a:cs typeface="Courier New" panose="02070309020205020404" pitchFamily="49" charset="0"/>
-              </a:rPr>
-              <a:t>(same cluster)</a:t>
-            </a:r>
-          </a:p>
-        </p:txBody>
-      </p:sp>
+      </p:pic>
     </p:spTree>
     <p:extLst>
       <p:ext uri="{BB962C8B-B14F-4D97-AF65-F5344CB8AC3E}">
@@ -9209,7 +9096,7 @@
 </p:sld>
 </file>
 
-<file path=ppt/slides/slide9.xml><?xml version="1.0" encoding="utf-8"?>
+<file path=ppt/slides/slide8.xml><?xml version="1.0" encoding="utf-8"?>
 <p:sld xmlns:a="http://schemas.openxmlformats.org/drawingml/2006/main" xmlns:r="http://schemas.openxmlformats.org/officeDocument/2006/relationships" xmlns:p="http://schemas.openxmlformats.org/presentationml/2006/main">
   <p:cSld>
     <p:spTree>
@@ -9438,7 +9325,7 @@
             <a:fld id="{3899FC77-40C7-4C49-9A19-86BDE9B75E8A}" type="slidenum">
               <a:rPr lang="en-CA" smtClean="0"/>
               <a:pPr/>
-              <a:t>9</a:t>
+              <a:t>8</a:t>
             </a:fld>
             <a:endParaRPr lang="en-CA" sz="1400"/>
           </a:p>

</xml_diff>

<commit_message>
Added table of g-profiler results.
</commit_message>
<xml_diff>
--- a/vis/reports/2026-02-18_projectUpdate_1.pptx
+++ b/vis/reports/2026-02-18_projectUpdate_1.pptx
@@ -9075,7 +9075,7 @@
         </p:blipFill>
         <p:spPr>
           <a:xfrm>
-            <a:off x="7059168" y="2441448"/>
+            <a:off x="6611112" y="1510389"/>
             <a:ext cx="4258034" cy="4154880"/>
           </a:xfrm>
           <a:prstGeom prst="rect">
@@ -9083,6 +9083,1492 @@
           </a:prstGeom>
         </p:spPr>
       </p:pic>
+      <p:graphicFrame>
+        <p:nvGraphicFramePr>
+          <p:cNvPr id="10" name="Table 9">
+            <a:extLst>
+              <a:ext uri="{FF2B5EF4-FFF2-40B4-BE49-F238E27FC236}">
+                <a16:creationId xmlns:a16="http://schemas.microsoft.com/office/drawing/2014/main" id="{DE2AA96C-16EB-A891-3710-9215F0D67EAE}"/>
+              </a:ext>
+            </a:extLst>
+          </p:cNvPr>
+          <p:cNvGraphicFramePr>
+            <a:graphicFrameLocks noGrp="1"/>
+          </p:cNvGraphicFramePr>
+          <p:nvPr>
+            <p:extLst>
+              <p:ext uri="{D42A27DB-BD31-4B8C-83A1-F6EECF244321}">
+                <p14:modId xmlns:p14="http://schemas.microsoft.com/office/powerpoint/2010/main" val="527733694"/>
+              </p:ext>
+            </p:extLst>
+          </p:nvPr>
+        </p:nvGraphicFramePr>
+        <p:xfrm>
+          <a:off x="294784" y="1843913"/>
+          <a:ext cx="5575836" cy="3757346"/>
+        </p:xfrm>
+        <a:graphic>
+          <a:graphicData uri="http://schemas.openxmlformats.org/drawingml/2006/table">
+            <a:tbl>
+              <a:tblPr>
+                <a:tableStyleId>{5940675A-B579-460E-94D1-54222C63F5DA}</a:tableStyleId>
+              </a:tblPr>
+              <a:tblGrid>
+                <a:gridCol w="2787918">
+                  <a:extLst>
+                    <a:ext uri="{9D8B030D-6E8A-4147-A177-3AD203B41FA5}">
+                      <a16:colId xmlns:a16="http://schemas.microsoft.com/office/drawing/2014/main" val="2883141624"/>
+                    </a:ext>
+                  </a:extLst>
+                </a:gridCol>
+                <a:gridCol w="2787918">
+                  <a:extLst>
+                    <a:ext uri="{9D8B030D-6E8A-4147-A177-3AD203B41FA5}">
+                      <a16:colId xmlns:a16="http://schemas.microsoft.com/office/drawing/2014/main" val="3161232302"/>
+                    </a:ext>
+                  </a:extLst>
+                </a:gridCol>
+              </a:tblGrid>
+              <a:tr h="242487">
+                <a:tc gridSpan="2">
+                  <a:txBody>
+                    <a:bodyPr/>
+                    <a:lstStyle/>
+                    <a:p>
+                      <a:pPr algn="l" fontAlgn="b">
+                        <a:buNone/>
+                      </a:pPr>
+                      <a:r>
+                        <a:rPr lang="en-US" sz="1400" b="0" i="0" u="none" strike="noStrike" dirty="0">
+                          <a:solidFill>
+                            <a:srgbClr val="000000"/>
+                          </a:solidFill>
+                          <a:effectLst/>
+                          <a:latin typeface="Verdana Pro" panose="020B0604030504040204" pitchFamily="34" charset="0"/>
+                        </a:rPr>
+                        <a:t>G profiler GO terms </a:t>
+                      </a:r>
+                      <a:endParaRPr lang="en-CA" sz="1400" b="0" i="0" u="none" strike="noStrike" dirty="0">
+                        <a:solidFill>
+                          <a:srgbClr val="000000"/>
+                        </a:solidFill>
+                        <a:effectLst/>
+                        <a:latin typeface="Verdana Pro" panose="020B0604030504040204" pitchFamily="34" charset="0"/>
+                      </a:endParaRPr>
+                    </a:p>
+                  </a:txBody>
+                  <a:tcPr marL="3472" marR="3472" marT="3472" marB="0" anchor="b"/>
+                </a:tc>
+                <a:tc hMerge="1">
+                  <a:txBody>
+                    <a:bodyPr/>
+                    <a:lstStyle/>
+                    <a:p>
+                      <a:pPr algn="l" fontAlgn="b">
+                        <a:buNone/>
+                      </a:pPr>
+                      <a:endParaRPr lang="en-CA" sz="1400" b="0" i="0" u="none" strike="noStrike" dirty="0">
+                        <a:solidFill>
+                          <a:srgbClr val="000000"/>
+                        </a:solidFill>
+                        <a:effectLst/>
+                        <a:latin typeface="Verdana Pro" panose="020B0604030504040204" pitchFamily="34" charset="0"/>
+                      </a:endParaRPr>
+                    </a:p>
+                  </a:txBody>
+                  <a:tcPr marL="3472" marR="3472" marT="3472" marB="0" anchor="b"/>
+                </a:tc>
+                <a:extLst>
+                  <a:ext uri="{0D108BD9-81ED-4DB2-BD59-A6C34878D82A}">
+                    <a16:rowId xmlns:a16="http://schemas.microsoft.com/office/drawing/2014/main" val="3254720063"/>
+                  </a:ext>
+                </a:extLst>
+              </a:tr>
+              <a:tr h="242487">
+                <a:tc>
+                  <a:txBody>
+                    <a:bodyPr/>
+                    <a:lstStyle/>
+                    <a:p>
+                      <a:pPr algn="l" fontAlgn="b">
+                        <a:buNone/>
+                      </a:pPr>
+                      <a:r>
+                        <a:rPr lang="en-CA" sz="1400" b="0" u="none" strike="noStrike" dirty="0">
+                          <a:solidFill>
+                            <a:srgbClr val="000000"/>
+                          </a:solidFill>
+                          <a:effectLst/>
+                          <a:latin typeface="Verdana Pro" panose="020B0604030504040204" pitchFamily="34" charset="0"/>
+                        </a:rPr>
+                        <a:t>name</a:t>
+                      </a:r>
+                      <a:endParaRPr lang="en-CA" sz="1400" b="0" i="0" u="none" strike="noStrike" dirty="0">
+                        <a:solidFill>
+                          <a:srgbClr val="000000"/>
+                        </a:solidFill>
+                        <a:effectLst/>
+                        <a:latin typeface="Verdana Pro" panose="020B0604030504040204" pitchFamily="34" charset="0"/>
+                      </a:endParaRPr>
+                    </a:p>
+                  </a:txBody>
+                  <a:tcPr marL="3472" marR="3472" marT="3472" marB="0" anchor="b"/>
+                </a:tc>
+                <a:tc>
+                  <a:txBody>
+                    <a:bodyPr/>
+                    <a:lstStyle/>
+                    <a:p>
+                      <a:pPr algn="l" fontAlgn="b">
+                        <a:buNone/>
+                      </a:pPr>
+                      <a:r>
+                        <a:rPr lang="en-CA" sz="1400" b="0" u="none" strike="noStrike" dirty="0" err="1">
+                          <a:solidFill>
+                            <a:srgbClr val="000000"/>
+                          </a:solidFill>
+                          <a:effectLst/>
+                          <a:latin typeface="Verdana Pro" panose="020B0604030504040204" pitchFamily="34" charset="0"/>
+                        </a:rPr>
+                        <a:t>p_value</a:t>
+                      </a:r>
+                      <a:endParaRPr lang="en-CA" sz="1400" b="0" i="0" u="none" strike="noStrike" dirty="0">
+                        <a:solidFill>
+                          <a:srgbClr val="000000"/>
+                        </a:solidFill>
+                        <a:effectLst/>
+                        <a:latin typeface="Verdana Pro" panose="020B0604030504040204" pitchFamily="34" charset="0"/>
+                      </a:endParaRPr>
+                    </a:p>
+                  </a:txBody>
+                  <a:tcPr marL="3472" marR="3472" marT="3472" marB="0" anchor="b"/>
+                </a:tc>
+                <a:extLst>
+                  <a:ext uri="{0D108BD9-81ED-4DB2-BD59-A6C34878D82A}">
+                    <a16:rowId xmlns:a16="http://schemas.microsoft.com/office/drawing/2014/main" val="697414357"/>
+                  </a:ext>
+                </a:extLst>
+              </a:tr>
+              <a:tr h="208401">
+                <a:tc>
+                  <a:txBody>
+                    <a:bodyPr/>
+                    <a:lstStyle/>
+                    <a:p>
+                      <a:pPr algn="l" fontAlgn="b">
+                        <a:spcAft>
+                          <a:spcPts val="600"/>
+                        </a:spcAft>
+                        <a:buNone/>
+                      </a:pPr>
+                      <a:r>
+                        <a:rPr lang="en-CA" sz="1200" b="0" u="none" strike="noStrike" dirty="0">
+                          <a:solidFill>
+                            <a:srgbClr val="000000"/>
+                          </a:solidFill>
+                          <a:effectLst/>
+                          <a:latin typeface="Courier New" panose="02070309020205020404" pitchFamily="49" charset="0"/>
+                          <a:cs typeface="Courier New" panose="02070309020205020404" pitchFamily="49" charset="0"/>
+                        </a:rPr>
+                        <a:t>ATP hydrolysis activity</a:t>
+                      </a:r>
+                      <a:endParaRPr lang="en-CA" sz="1200" b="0" i="0" u="none" strike="noStrike" dirty="0">
+                        <a:solidFill>
+                          <a:srgbClr val="000000"/>
+                        </a:solidFill>
+                        <a:effectLst/>
+                        <a:latin typeface="Courier New" panose="02070309020205020404" pitchFamily="49" charset="0"/>
+                        <a:cs typeface="Courier New" panose="02070309020205020404" pitchFamily="49" charset="0"/>
+                      </a:endParaRPr>
+                    </a:p>
+                  </a:txBody>
+                  <a:tcPr marL="3472" marR="3472" marT="3472" marB="0" anchor="b">
+                    <a:lnR w="12700" cap="flat" cmpd="sng" algn="ctr">
+                      <a:solidFill>
+                        <a:schemeClr val="tx1"/>
+                      </a:solidFill>
+                      <a:prstDash val="solid"/>
+                      <a:round/>
+                      <a:headEnd type="none" w="med" len="med"/>
+                      <a:tailEnd type="none" w="med" len="med"/>
+                    </a:lnR>
+                    <a:lnB w="12700" cap="flat" cmpd="sng" algn="ctr">
+                      <a:solidFill>
+                        <a:schemeClr val="bg1">
+                          <a:lumMod val="75000"/>
+                        </a:schemeClr>
+                      </a:solidFill>
+                      <a:prstDash val="solid"/>
+                      <a:round/>
+                      <a:headEnd type="none" w="med" len="med"/>
+                      <a:tailEnd type="none" w="med" len="med"/>
+                    </a:lnB>
+                  </a:tcPr>
+                </a:tc>
+                <a:tc>
+                  <a:txBody>
+                    <a:bodyPr/>
+                    <a:lstStyle/>
+                    <a:p>
+                      <a:pPr algn="l" fontAlgn="b">
+                        <a:buNone/>
+                      </a:pPr>
+                      <a:r>
+                        <a:rPr lang="en-CA" sz="1200" b="0" u="none" strike="noStrike" dirty="0">
+                          <a:solidFill>
+                            <a:srgbClr val="000000"/>
+                          </a:solidFill>
+                          <a:effectLst/>
+                          <a:latin typeface="Courier New" panose="02070309020205020404" pitchFamily="49" charset="0"/>
+                          <a:cs typeface="Courier New" panose="02070309020205020404" pitchFamily="49" charset="0"/>
+                        </a:rPr>
+                        <a:t>5.32E-14</a:t>
+                      </a:r>
+                      <a:endParaRPr lang="en-CA" sz="1200" b="0" i="0" u="none" strike="noStrike" dirty="0">
+                        <a:solidFill>
+                          <a:srgbClr val="000000"/>
+                        </a:solidFill>
+                        <a:effectLst/>
+                        <a:latin typeface="Courier New" panose="02070309020205020404" pitchFamily="49" charset="0"/>
+                        <a:cs typeface="Courier New" panose="02070309020205020404" pitchFamily="49" charset="0"/>
+                      </a:endParaRPr>
+                    </a:p>
+                  </a:txBody>
+                  <a:tcPr marL="3472" marR="3472" marT="3472" marB="0" anchor="b">
+                    <a:lnL w="12700" cap="flat" cmpd="sng" algn="ctr">
+                      <a:solidFill>
+                        <a:schemeClr val="tx1"/>
+                      </a:solidFill>
+                      <a:prstDash val="solid"/>
+                      <a:round/>
+                      <a:headEnd type="none" w="med" len="med"/>
+                      <a:tailEnd type="none" w="med" len="med"/>
+                    </a:lnL>
+                    <a:lnB w="12700" cap="flat" cmpd="sng" algn="ctr">
+                      <a:solidFill>
+                        <a:schemeClr val="bg1">
+                          <a:lumMod val="75000"/>
+                        </a:schemeClr>
+                      </a:solidFill>
+                      <a:prstDash val="solid"/>
+                      <a:round/>
+                      <a:headEnd type="none" w="med" len="med"/>
+                      <a:tailEnd type="none" w="med" len="med"/>
+                    </a:lnB>
+                  </a:tcPr>
+                </a:tc>
+                <a:extLst>
+                  <a:ext uri="{0D108BD9-81ED-4DB2-BD59-A6C34878D82A}">
+                    <a16:rowId xmlns:a16="http://schemas.microsoft.com/office/drawing/2014/main" val="3517527668"/>
+                  </a:ext>
+                </a:extLst>
+              </a:tr>
+              <a:tr h="208401">
+                <a:tc>
+                  <a:txBody>
+                    <a:bodyPr/>
+                    <a:lstStyle/>
+                    <a:p>
+                      <a:pPr algn="l" fontAlgn="b">
+                        <a:spcAft>
+                          <a:spcPts val="600"/>
+                        </a:spcAft>
+                        <a:buNone/>
+                      </a:pPr>
+                      <a:r>
+                        <a:rPr lang="en-CA" sz="1200" b="0" u="none" strike="noStrike" dirty="0">
+                          <a:solidFill>
+                            <a:srgbClr val="000000"/>
+                          </a:solidFill>
+                          <a:effectLst/>
+                          <a:latin typeface="Courier New" panose="02070309020205020404" pitchFamily="49" charset="0"/>
+                          <a:cs typeface="Courier New" panose="02070309020205020404" pitchFamily="49" charset="0"/>
+                        </a:rPr>
+                        <a:t>ATP-dependent activity</a:t>
+                      </a:r>
+                      <a:endParaRPr lang="en-CA" sz="1200" b="0" i="0" u="none" strike="noStrike" dirty="0">
+                        <a:solidFill>
+                          <a:srgbClr val="000000"/>
+                        </a:solidFill>
+                        <a:effectLst/>
+                        <a:latin typeface="Courier New" panose="02070309020205020404" pitchFamily="49" charset="0"/>
+                        <a:cs typeface="Courier New" panose="02070309020205020404" pitchFamily="49" charset="0"/>
+                      </a:endParaRPr>
+                    </a:p>
+                  </a:txBody>
+                  <a:tcPr marL="3472" marR="3472" marT="3472" marB="0" anchor="b">
+                    <a:lnR w="12700" cap="flat" cmpd="sng" algn="ctr">
+                      <a:solidFill>
+                        <a:schemeClr val="tx1"/>
+                      </a:solidFill>
+                      <a:prstDash val="solid"/>
+                      <a:round/>
+                      <a:headEnd type="none" w="med" len="med"/>
+                      <a:tailEnd type="none" w="med" len="med"/>
+                    </a:lnR>
+                    <a:lnT w="12700" cap="flat" cmpd="sng" algn="ctr">
+                      <a:solidFill>
+                        <a:schemeClr val="bg1">
+                          <a:lumMod val="75000"/>
+                        </a:schemeClr>
+                      </a:solidFill>
+                      <a:prstDash val="solid"/>
+                      <a:round/>
+                      <a:headEnd type="none" w="med" len="med"/>
+                      <a:tailEnd type="none" w="med" len="med"/>
+                    </a:lnT>
+                    <a:lnB w="12700" cap="flat" cmpd="sng" algn="ctr">
+                      <a:solidFill>
+                        <a:schemeClr val="bg1">
+                          <a:lumMod val="75000"/>
+                        </a:schemeClr>
+                      </a:solidFill>
+                      <a:prstDash val="solid"/>
+                      <a:round/>
+                      <a:headEnd type="none" w="med" len="med"/>
+                      <a:tailEnd type="none" w="med" len="med"/>
+                    </a:lnB>
+                  </a:tcPr>
+                </a:tc>
+                <a:tc>
+                  <a:txBody>
+                    <a:bodyPr/>
+                    <a:lstStyle/>
+                    <a:p>
+                      <a:pPr algn="l" fontAlgn="b">
+                        <a:buNone/>
+                      </a:pPr>
+                      <a:r>
+                        <a:rPr lang="en-CA" sz="1200" b="0" u="none" strike="noStrike" dirty="0">
+                          <a:solidFill>
+                            <a:srgbClr val="000000"/>
+                          </a:solidFill>
+                          <a:effectLst/>
+                          <a:latin typeface="Courier New" panose="02070309020205020404" pitchFamily="49" charset="0"/>
+                          <a:cs typeface="Courier New" panose="02070309020205020404" pitchFamily="49" charset="0"/>
+                        </a:rPr>
+                        <a:t>8.18E-12</a:t>
+                      </a:r>
+                      <a:endParaRPr lang="en-CA" sz="1200" b="0" i="0" u="none" strike="noStrike" dirty="0">
+                        <a:solidFill>
+                          <a:srgbClr val="000000"/>
+                        </a:solidFill>
+                        <a:effectLst/>
+                        <a:latin typeface="Courier New" panose="02070309020205020404" pitchFamily="49" charset="0"/>
+                        <a:cs typeface="Courier New" panose="02070309020205020404" pitchFamily="49" charset="0"/>
+                      </a:endParaRPr>
+                    </a:p>
+                  </a:txBody>
+                  <a:tcPr marL="3472" marR="3472" marT="3472" marB="0" anchor="b">
+                    <a:lnL w="12700" cap="flat" cmpd="sng" algn="ctr">
+                      <a:solidFill>
+                        <a:schemeClr val="tx1"/>
+                      </a:solidFill>
+                      <a:prstDash val="solid"/>
+                      <a:round/>
+                      <a:headEnd type="none" w="med" len="med"/>
+                      <a:tailEnd type="none" w="med" len="med"/>
+                    </a:lnL>
+                    <a:lnT w="12700" cap="flat" cmpd="sng" algn="ctr">
+                      <a:solidFill>
+                        <a:schemeClr val="bg1">
+                          <a:lumMod val="75000"/>
+                        </a:schemeClr>
+                      </a:solidFill>
+                      <a:prstDash val="solid"/>
+                      <a:round/>
+                      <a:headEnd type="none" w="med" len="med"/>
+                      <a:tailEnd type="none" w="med" len="med"/>
+                    </a:lnT>
+                    <a:lnB w="12700" cap="flat" cmpd="sng" algn="ctr">
+                      <a:solidFill>
+                        <a:schemeClr val="bg1">
+                          <a:lumMod val="75000"/>
+                        </a:schemeClr>
+                      </a:solidFill>
+                      <a:prstDash val="solid"/>
+                      <a:round/>
+                      <a:headEnd type="none" w="med" len="med"/>
+                      <a:tailEnd type="none" w="med" len="med"/>
+                    </a:lnB>
+                  </a:tcPr>
+                </a:tc>
+                <a:extLst>
+                  <a:ext uri="{0D108BD9-81ED-4DB2-BD59-A6C34878D82A}">
+                    <a16:rowId xmlns:a16="http://schemas.microsoft.com/office/drawing/2014/main" val="2117434380"/>
+                  </a:ext>
+                </a:extLst>
+              </a:tr>
+              <a:tr h="412919">
+                <a:tc>
+                  <a:txBody>
+                    <a:bodyPr/>
+                    <a:lstStyle/>
+                    <a:p>
+                      <a:pPr algn="l" fontAlgn="b">
+                        <a:spcAft>
+                          <a:spcPts val="600"/>
+                        </a:spcAft>
+                        <a:buNone/>
+                      </a:pPr>
+                      <a:r>
+                        <a:rPr lang="en-CA" sz="1200" b="0" u="none" strike="noStrike" dirty="0">
+                          <a:solidFill>
+                            <a:srgbClr val="000000"/>
+                          </a:solidFill>
+                          <a:effectLst/>
+                          <a:latin typeface="Courier New" panose="02070309020205020404" pitchFamily="49" charset="0"/>
+                          <a:cs typeface="Courier New" panose="02070309020205020404" pitchFamily="49" charset="0"/>
+                        </a:rPr>
+                        <a:t>ribonucleoside triphosphate phosphatase activity</a:t>
+                      </a:r>
+                      <a:endParaRPr lang="en-CA" sz="1200" b="0" i="0" u="none" strike="noStrike" dirty="0">
+                        <a:solidFill>
+                          <a:srgbClr val="000000"/>
+                        </a:solidFill>
+                        <a:effectLst/>
+                        <a:latin typeface="Courier New" panose="02070309020205020404" pitchFamily="49" charset="0"/>
+                        <a:cs typeface="Courier New" panose="02070309020205020404" pitchFamily="49" charset="0"/>
+                      </a:endParaRPr>
+                    </a:p>
+                  </a:txBody>
+                  <a:tcPr marL="3472" marR="3472" marT="3472" marB="0" anchor="b">
+                    <a:lnR w="12700" cap="flat" cmpd="sng" algn="ctr">
+                      <a:solidFill>
+                        <a:schemeClr val="tx1"/>
+                      </a:solidFill>
+                      <a:prstDash val="solid"/>
+                      <a:round/>
+                      <a:headEnd type="none" w="med" len="med"/>
+                      <a:tailEnd type="none" w="med" len="med"/>
+                    </a:lnR>
+                    <a:lnT w="12700" cap="flat" cmpd="sng" algn="ctr">
+                      <a:solidFill>
+                        <a:schemeClr val="bg1">
+                          <a:lumMod val="75000"/>
+                        </a:schemeClr>
+                      </a:solidFill>
+                      <a:prstDash val="solid"/>
+                      <a:round/>
+                      <a:headEnd type="none" w="med" len="med"/>
+                      <a:tailEnd type="none" w="med" len="med"/>
+                    </a:lnT>
+                    <a:lnB w="12700" cap="flat" cmpd="sng" algn="ctr">
+                      <a:solidFill>
+                        <a:schemeClr val="bg1">
+                          <a:lumMod val="75000"/>
+                        </a:schemeClr>
+                      </a:solidFill>
+                      <a:prstDash val="solid"/>
+                      <a:round/>
+                      <a:headEnd type="none" w="med" len="med"/>
+                      <a:tailEnd type="none" w="med" len="med"/>
+                    </a:lnB>
+                  </a:tcPr>
+                </a:tc>
+                <a:tc>
+                  <a:txBody>
+                    <a:bodyPr/>
+                    <a:lstStyle/>
+                    <a:p>
+                      <a:pPr algn="l" fontAlgn="b">
+                        <a:buNone/>
+                      </a:pPr>
+                      <a:r>
+                        <a:rPr lang="en-CA" sz="1200" b="0" u="none" strike="noStrike" dirty="0">
+                          <a:solidFill>
+                            <a:srgbClr val="000000"/>
+                          </a:solidFill>
+                          <a:effectLst/>
+                          <a:latin typeface="Courier New" panose="02070309020205020404" pitchFamily="49" charset="0"/>
+                          <a:cs typeface="Courier New" panose="02070309020205020404" pitchFamily="49" charset="0"/>
+                        </a:rPr>
+                        <a:t>5.90E-10</a:t>
+                      </a:r>
+                      <a:endParaRPr lang="en-CA" sz="1200" b="0" i="0" u="none" strike="noStrike" dirty="0">
+                        <a:solidFill>
+                          <a:srgbClr val="000000"/>
+                        </a:solidFill>
+                        <a:effectLst/>
+                        <a:latin typeface="Courier New" panose="02070309020205020404" pitchFamily="49" charset="0"/>
+                        <a:cs typeface="Courier New" panose="02070309020205020404" pitchFamily="49" charset="0"/>
+                      </a:endParaRPr>
+                    </a:p>
+                  </a:txBody>
+                  <a:tcPr marL="3472" marR="3472" marT="3472" marB="0" anchor="b">
+                    <a:lnL w="12700" cap="flat" cmpd="sng" algn="ctr">
+                      <a:solidFill>
+                        <a:schemeClr val="tx1"/>
+                      </a:solidFill>
+                      <a:prstDash val="solid"/>
+                      <a:round/>
+                      <a:headEnd type="none" w="med" len="med"/>
+                      <a:tailEnd type="none" w="med" len="med"/>
+                    </a:lnL>
+                    <a:lnT w="12700" cap="flat" cmpd="sng" algn="ctr">
+                      <a:solidFill>
+                        <a:schemeClr val="bg1">
+                          <a:lumMod val="75000"/>
+                        </a:schemeClr>
+                      </a:solidFill>
+                      <a:prstDash val="solid"/>
+                      <a:round/>
+                      <a:headEnd type="none" w="med" len="med"/>
+                      <a:tailEnd type="none" w="med" len="med"/>
+                    </a:lnT>
+                    <a:lnB w="12700" cap="flat" cmpd="sng" algn="ctr">
+                      <a:solidFill>
+                        <a:schemeClr val="bg1">
+                          <a:lumMod val="75000"/>
+                        </a:schemeClr>
+                      </a:solidFill>
+                      <a:prstDash val="solid"/>
+                      <a:round/>
+                      <a:headEnd type="none" w="med" len="med"/>
+                      <a:tailEnd type="none" w="med" len="med"/>
+                    </a:lnB>
+                  </a:tcPr>
+                </a:tc>
+                <a:extLst>
+                  <a:ext uri="{0D108BD9-81ED-4DB2-BD59-A6C34878D82A}">
+                    <a16:rowId xmlns:a16="http://schemas.microsoft.com/office/drawing/2014/main" val="740033294"/>
+                  </a:ext>
+                </a:extLst>
+              </a:tr>
+              <a:tr h="208401">
+                <a:tc>
+                  <a:txBody>
+                    <a:bodyPr/>
+                    <a:lstStyle/>
+                    <a:p>
+                      <a:pPr algn="l" fontAlgn="b">
+                        <a:spcAft>
+                          <a:spcPts val="600"/>
+                        </a:spcAft>
+                        <a:buNone/>
+                      </a:pPr>
+                      <a:r>
+                        <a:rPr lang="en-CA" sz="1200" b="0" u="none" strike="noStrike" dirty="0">
+                          <a:solidFill>
+                            <a:srgbClr val="000000"/>
+                          </a:solidFill>
+                          <a:effectLst/>
+                          <a:latin typeface="Courier New" panose="02070309020205020404" pitchFamily="49" charset="0"/>
+                          <a:cs typeface="Courier New" panose="02070309020205020404" pitchFamily="49" charset="0"/>
+                        </a:rPr>
+                        <a:t>pyrophosphatase activity</a:t>
+                      </a:r>
+                      <a:endParaRPr lang="en-CA" sz="1200" b="0" i="0" u="none" strike="noStrike" dirty="0">
+                        <a:solidFill>
+                          <a:srgbClr val="000000"/>
+                        </a:solidFill>
+                        <a:effectLst/>
+                        <a:latin typeface="Courier New" panose="02070309020205020404" pitchFamily="49" charset="0"/>
+                        <a:cs typeface="Courier New" panose="02070309020205020404" pitchFamily="49" charset="0"/>
+                      </a:endParaRPr>
+                    </a:p>
+                  </a:txBody>
+                  <a:tcPr marL="3472" marR="3472" marT="3472" marB="0" anchor="b">
+                    <a:lnR w="12700" cap="flat" cmpd="sng" algn="ctr">
+                      <a:solidFill>
+                        <a:schemeClr val="tx1"/>
+                      </a:solidFill>
+                      <a:prstDash val="solid"/>
+                      <a:round/>
+                      <a:headEnd type="none" w="med" len="med"/>
+                      <a:tailEnd type="none" w="med" len="med"/>
+                    </a:lnR>
+                    <a:lnT w="12700" cap="flat" cmpd="sng" algn="ctr">
+                      <a:solidFill>
+                        <a:schemeClr val="bg1">
+                          <a:lumMod val="75000"/>
+                        </a:schemeClr>
+                      </a:solidFill>
+                      <a:prstDash val="solid"/>
+                      <a:round/>
+                      <a:headEnd type="none" w="med" len="med"/>
+                      <a:tailEnd type="none" w="med" len="med"/>
+                    </a:lnT>
+                    <a:lnB w="12700" cap="flat" cmpd="sng" algn="ctr">
+                      <a:solidFill>
+                        <a:schemeClr val="bg1">
+                          <a:lumMod val="75000"/>
+                        </a:schemeClr>
+                      </a:solidFill>
+                      <a:prstDash val="solid"/>
+                      <a:round/>
+                      <a:headEnd type="none" w="med" len="med"/>
+                      <a:tailEnd type="none" w="med" len="med"/>
+                    </a:lnB>
+                  </a:tcPr>
+                </a:tc>
+                <a:tc>
+                  <a:txBody>
+                    <a:bodyPr/>
+                    <a:lstStyle/>
+                    <a:p>
+                      <a:pPr algn="l" fontAlgn="b">
+                        <a:buNone/>
+                      </a:pPr>
+                      <a:r>
+                        <a:rPr lang="en-CA" sz="1200" b="0" u="none" strike="noStrike">
+                          <a:solidFill>
+                            <a:srgbClr val="000000"/>
+                          </a:solidFill>
+                          <a:effectLst/>
+                          <a:latin typeface="Courier New" panose="02070309020205020404" pitchFamily="49" charset="0"/>
+                          <a:cs typeface="Courier New" panose="02070309020205020404" pitchFamily="49" charset="0"/>
+                        </a:rPr>
+                        <a:t>1.10E-09</a:t>
+                      </a:r>
+                      <a:endParaRPr lang="en-CA" sz="1200" b="0" i="0" u="none" strike="noStrike">
+                        <a:solidFill>
+                          <a:srgbClr val="000000"/>
+                        </a:solidFill>
+                        <a:effectLst/>
+                        <a:latin typeface="Courier New" panose="02070309020205020404" pitchFamily="49" charset="0"/>
+                        <a:cs typeface="Courier New" panose="02070309020205020404" pitchFamily="49" charset="0"/>
+                      </a:endParaRPr>
+                    </a:p>
+                  </a:txBody>
+                  <a:tcPr marL="3472" marR="3472" marT="3472" marB="0" anchor="b">
+                    <a:lnL w="12700" cap="flat" cmpd="sng" algn="ctr">
+                      <a:solidFill>
+                        <a:schemeClr val="tx1"/>
+                      </a:solidFill>
+                      <a:prstDash val="solid"/>
+                      <a:round/>
+                      <a:headEnd type="none" w="med" len="med"/>
+                      <a:tailEnd type="none" w="med" len="med"/>
+                    </a:lnL>
+                    <a:lnT w="12700" cap="flat" cmpd="sng" algn="ctr">
+                      <a:solidFill>
+                        <a:schemeClr val="bg1">
+                          <a:lumMod val="75000"/>
+                        </a:schemeClr>
+                      </a:solidFill>
+                      <a:prstDash val="solid"/>
+                      <a:round/>
+                      <a:headEnd type="none" w="med" len="med"/>
+                      <a:tailEnd type="none" w="med" len="med"/>
+                    </a:lnT>
+                    <a:lnB w="12700" cap="flat" cmpd="sng" algn="ctr">
+                      <a:solidFill>
+                        <a:schemeClr val="bg1">
+                          <a:lumMod val="75000"/>
+                        </a:schemeClr>
+                      </a:solidFill>
+                      <a:prstDash val="solid"/>
+                      <a:round/>
+                      <a:headEnd type="none" w="med" len="med"/>
+                      <a:tailEnd type="none" w="med" len="med"/>
+                    </a:lnB>
+                  </a:tcPr>
+                </a:tc>
+                <a:extLst>
+                  <a:ext uri="{0D108BD9-81ED-4DB2-BD59-A6C34878D82A}">
+                    <a16:rowId xmlns:a16="http://schemas.microsoft.com/office/drawing/2014/main" val="2893406690"/>
+                  </a:ext>
+                </a:extLst>
+              </a:tr>
+              <a:tr h="412919">
+                <a:tc>
+                  <a:txBody>
+                    <a:bodyPr/>
+                    <a:lstStyle/>
+                    <a:p>
+                      <a:pPr algn="l" fontAlgn="b">
+                        <a:spcAft>
+                          <a:spcPts val="600"/>
+                        </a:spcAft>
+                        <a:buNone/>
+                      </a:pPr>
+                      <a:r>
+                        <a:rPr lang="en-US" sz="1200" b="0" u="none" strike="noStrike" dirty="0">
+                          <a:solidFill>
+                            <a:srgbClr val="000000"/>
+                          </a:solidFill>
+                          <a:effectLst/>
+                          <a:latin typeface="Courier New" panose="02070309020205020404" pitchFamily="49" charset="0"/>
+                          <a:cs typeface="Courier New" panose="02070309020205020404" pitchFamily="49" charset="0"/>
+                        </a:rPr>
+                        <a:t>hydrolase activity, acting on acid anhydrides</a:t>
+                      </a:r>
+                      <a:endParaRPr lang="en-US" sz="1200" b="0" i="0" u="none" strike="noStrike" dirty="0">
+                        <a:solidFill>
+                          <a:srgbClr val="000000"/>
+                        </a:solidFill>
+                        <a:effectLst/>
+                        <a:latin typeface="Courier New" panose="02070309020205020404" pitchFamily="49" charset="0"/>
+                        <a:cs typeface="Courier New" panose="02070309020205020404" pitchFamily="49" charset="0"/>
+                      </a:endParaRPr>
+                    </a:p>
+                  </a:txBody>
+                  <a:tcPr marL="3472" marR="3472" marT="3472" marB="0" anchor="b">
+                    <a:lnR w="12700" cap="flat" cmpd="sng" algn="ctr">
+                      <a:solidFill>
+                        <a:schemeClr val="tx1"/>
+                      </a:solidFill>
+                      <a:prstDash val="solid"/>
+                      <a:round/>
+                      <a:headEnd type="none" w="med" len="med"/>
+                      <a:tailEnd type="none" w="med" len="med"/>
+                    </a:lnR>
+                    <a:lnT w="12700" cap="flat" cmpd="sng" algn="ctr">
+                      <a:solidFill>
+                        <a:schemeClr val="bg1">
+                          <a:lumMod val="75000"/>
+                        </a:schemeClr>
+                      </a:solidFill>
+                      <a:prstDash val="solid"/>
+                      <a:round/>
+                      <a:headEnd type="none" w="med" len="med"/>
+                      <a:tailEnd type="none" w="med" len="med"/>
+                    </a:lnT>
+                    <a:lnB w="12700" cap="flat" cmpd="sng" algn="ctr">
+                      <a:solidFill>
+                        <a:schemeClr val="bg1">
+                          <a:lumMod val="75000"/>
+                        </a:schemeClr>
+                      </a:solidFill>
+                      <a:prstDash val="solid"/>
+                      <a:round/>
+                      <a:headEnd type="none" w="med" len="med"/>
+                      <a:tailEnd type="none" w="med" len="med"/>
+                    </a:lnB>
+                  </a:tcPr>
+                </a:tc>
+                <a:tc>
+                  <a:txBody>
+                    <a:bodyPr/>
+                    <a:lstStyle/>
+                    <a:p>
+                      <a:pPr algn="l" fontAlgn="b">
+                        <a:buNone/>
+                      </a:pPr>
+                      <a:r>
+                        <a:rPr lang="en-CA" sz="1200" b="0" u="none" strike="noStrike" dirty="0">
+                          <a:solidFill>
+                            <a:srgbClr val="000000"/>
+                          </a:solidFill>
+                          <a:effectLst/>
+                          <a:latin typeface="Courier New" panose="02070309020205020404" pitchFamily="49" charset="0"/>
+                          <a:cs typeface="Courier New" panose="02070309020205020404" pitchFamily="49" charset="0"/>
+                        </a:rPr>
+                        <a:t>1.11E-09</a:t>
+                      </a:r>
+                      <a:endParaRPr lang="en-CA" sz="1200" b="0" i="0" u="none" strike="noStrike" dirty="0">
+                        <a:solidFill>
+                          <a:srgbClr val="000000"/>
+                        </a:solidFill>
+                        <a:effectLst/>
+                        <a:latin typeface="Courier New" panose="02070309020205020404" pitchFamily="49" charset="0"/>
+                        <a:cs typeface="Courier New" panose="02070309020205020404" pitchFamily="49" charset="0"/>
+                      </a:endParaRPr>
+                    </a:p>
+                  </a:txBody>
+                  <a:tcPr marL="3472" marR="3472" marT="3472" marB="0" anchor="b">
+                    <a:lnL w="12700" cap="flat" cmpd="sng" algn="ctr">
+                      <a:solidFill>
+                        <a:schemeClr val="tx1"/>
+                      </a:solidFill>
+                      <a:prstDash val="solid"/>
+                      <a:round/>
+                      <a:headEnd type="none" w="med" len="med"/>
+                      <a:tailEnd type="none" w="med" len="med"/>
+                    </a:lnL>
+                    <a:lnT w="12700" cap="flat" cmpd="sng" algn="ctr">
+                      <a:solidFill>
+                        <a:schemeClr val="bg1">
+                          <a:lumMod val="75000"/>
+                        </a:schemeClr>
+                      </a:solidFill>
+                      <a:prstDash val="solid"/>
+                      <a:round/>
+                      <a:headEnd type="none" w="med" len="med"/>
+                      <a:tailEnd type="none" w="med" len="med"/>
+                    </a:lnT>
+                    <a:lnB w="12700" cap="flat" cmpd="sng" algn="ctr">
+                      <a:solidFill>
+                        <a:schemeClr val="bg1">
+                          <a:lumMod val="75000"/>
+                        </a:schemeClr>
+                      </a:solidFill>
+                      <a:prstDash val="solid"/>
+                      <a:round/>
+                      <a:headEnd type="none" w="med" len="med"/>
+                      <a:tailEnd type="none" w="med" len="med"/>
+                    </a:lnB>
+                  </a:tcPr>
+                </a:tc>
+                <a:extLst>
+                  <a:ext uri="{0D108BD9-81ED-4DB2-BD59-A6C34878D82A}">
+                    <a16:rowId xmlns:a16="http://schemas.microsoft.com/office/drawing/2014/main" val="1015402240"/>
+                  </a:ext>
+                </a:extLst>
+              </a:tr>
+              <a:tr h="821956">
+                <a:tc>
+                  <a:txBody>
+                    <a:bodyPr/>
+                    <a:lstStyle/>
+                    <a:p>
+                      <a:pPr algn="l" fontAlgn="b">
+                        <a:spcAft>
+                          <a:spcPts val="600"/>
+                        </a:spcAft>
+                        <a:buNone/>
+                      </a:pPr>
+                      <a:r>
+                        <a:rPr lang="en-US" sz="1200" b="0" u="none" strike="noStrike" dirty="0">
+                          <a:solidFill>
+                            <a:srgbClr val="000000"/>
+                          </a:solidFill>
+                          <a:effectLst/>
+                          <a:latin typeface="Courier New" panose="02070309020205020404" pitchFamily="49" charset="0"/>
+                          <a:cs typeface="Courier New" panose="02070309020205020404" pitchFamily="49" charset="0"/>
+                        </a:rPr>
+                        <a:t>hydrolase activity, acting on acid anhydrides, in phosphorus-containing anhydrides</a:t>
+                      </a:r>
+                      <a:endParaRPr lang="en-US" sz="1200" b="0" i="0" u="none" strike="noStrike" dirty="0">
+                        <a:solidFill>
+                          <a:srgbClr val="000000"/>
+                        </a:solidFill>
+                        <a:effectLst/>
+                        <a:latin typeface="Courier New" panose="02070309020205020404" pitchFamily="49" charset="0"/>
+                        <a:cs typeface="Courier New" panose="02070309020205020404" pitchFamily="49" charset="0"/>
+                      </a:endParaRPr>
+                    </a:p>
+                  </a:txBody>
+                  <a:tcPr marL="3472" marR="3472" marT="3472" marB="0" anchor="b">
+                    <a:lnR w="12700" cap="flat" cmpd="sng" algn="ctr">
+                      <a:solidFill>
+                        <a:schemeClr val="tx1"/>
+                      </a:solidFill>
+                      <a:prstDash val="solid"/>
+                      <a:round/>
+                      <a:headEnd type="none" w="med" len="med"/>
+                      <a:tailEnd type="none" w="med" len="med"/>
+                    </a:lnR>
+                    <a:lnT w="12700" cap="flat" cmpd="sng" algn="ctr">
+                      <a:solidFill>
+                        <a:schemeClr val="bg1">
+                          <a:lumMod val="75000"/>
+                        </a:schemeClr>
+                      </a:solidFill>
+                      <a:prstDash val="solid"/>
+                      <a:round/>
+                      <a:headEnd type="none" w="med" len="med"/>
+                      <a:tailEnd type="none" w="med" len="med"/>
+                    </a:lnT>
+                    <a:lnB w="12700" cap="flat" cmpd="sng" algn="ctr">
+                      <a:solidFill>
+                        <a:schemeClr val="bg1">
+                          <a:lumMod val="75000"/>
+                        </a:schemeClr>
+                      </a:solidFill>
+                      <a:prstDash val="solid"/>
+                      <a:round/>
+                      <a:headEnd type="none" w="med" len="med"/>
+                      <a:tailEnd type="none" w="med" len="med"/>
+                    </a:lnB>
+                  </a:tcPr>
+                </a:tc>
+                <a:tc>
+                  <a:txBody>
+                    <a:bodyPr/>
+                    <a:lstStyle/>
+                    <a:p>
+                      <a:pPr algn="l" fontAlgn="b">
+                        <a:buNone/>
+                      </a:pPr>
+                      <a:r>
+                        <a:rPr lang="en-CA" sz="1200" b="0" u="none" strike="noStrike" dirty="0">
+                          <a:solidFill>
+                            <a:srgbClr val="000000"/>
+                          </a:solidFill>
+                          <a:effectLst/>
+                          <a:latin typeface="Courier New" panose="02070309020205020404" pitchFamily="49" charset="0"/>
+                          <a:cs typeface="Courier New" panose="02070309020205020404" pitchFamily="49" charset="0"/>
+                        </a:rPr>
+                        <a:t>1.11E-09</a:t>
+                      </a:r>
+                      <a:endParaRPr lang="en-CA" sz="1200" b="0" i="0" u="none" strike="noStrike" dirty="0">
+                        <a:solidFill>
+                          <a:srgbClr val="000000"/>
+                        </a:solidFill>
+                        <a:effectLst/>
+                        <a:latin typeface="Courier New" panose="02070309020205020404" pitchFamily="49" charset="0"/>
+                        <a:cs typeface="Courier New" panose="02070309020205020404" pitchFamily="49" charset="0"/>
+                      </a:endParaRPr>
+                    </a:p>
+                  </a:txBody>
+                  <a:tcPr marL="3472" marR="3472" marT="3472" marB="0" anchor="b">
+                    <a:lnL w="12700" cap="flat" cmpd="sng" algn="ctr">
+                      <a:solidFill>
+                        <a:schemeClr val="tx1"/>
+                      </a:solidFill>
+                      <a:prstDash val="solid"/>
+                      <a:round/>
+                      <a:headEnd type="none" w="med" len="med"/>
+                      <a:tailEnd type="none" w="med" len="med"/>
+                    </a:lnL>
+                    <a:lnT w="12700" cap="flat" cmpd="sng" algn="ctr">
+                      <a:solidFill>
+                        <a:schemeClr val="bg1">
+                          <a:lumMod val="75000"/>
+                        </a:schemeClr>
+                      </a:solidFill>
+                      <a:prstDash val="solid"/>
+                      <a:round/>
+                      <a:headEnd type="none" w="med" len="med"/>
+                      <a:tailEnd type="none" w="med" len="med"/>
+                    </a:lnT>
+                    <a:lnB w="12700" cap="flat" cmpd="sng" algn="ctr">
+                      <a:solidFill>
+                        <a:schemeClr val="bg1">
+                          <a:lumMod val="75000"/>
+                        </a:schemeClr>
+                      </a:solidFill>
+                      <a:prstDash val="solid"/>
+                      <a:round/>
+                      <a:headEnd type="none" w="med" len="med"/>
+                      <a:tailEnd type="none" w="med" len="med"/>
+                    </a:lnB>
+                  </a:tcPr>
+                </a:tc>
+                <a:extLst>
+                  <a:ext uri="{0D108BD9-81ED-4DB2-BD59-A6C34878D82A}">
+                    <a16:rowId xmlns:a16="http://schemas.microsoft.com/office/drawing/2014/main" val="216578652"/>
+                  </a:ext>
+                </a:extLst>
+              </a:tr>
+              <a:tr h="263658">
+                <a:tc>
+                  <a:txBody>
+                    <a:bodyPr/>
+                    <a:lstStyle/>
+                    <a:p>
+                      <a:pPr algn="l" fontAlgn="b">
+                        <a:spcAft>
+                          <a:spcPts val="600"/>
+                        </a:spcAft>
+                        <a:buNone/>
+                      </a:pPr>
+                      <a:r>
+                        <a:rPr lang="en-CA" sz="1200" b="0" u="none" strike="noStrike" dirty="0">
+                          <a:solidFill>
+                            <a:srgbClr val="000000"/>
+                          </a:solidFill>
+                          <a:effectLst/>
+                          <a:latin typeface="Courier New" panose="02070309020205020404" pitchFamily="49" charset="0"/>
+                          <a:cs typeface="Courier New" panose="02070309020205020404" pitchFamily="49" charset="0"/>
+                        </a:rPr>
+                        <a:t>condensed chromosome</a:t>
+                      </a:r>
+                      <a:endParaRPr lang="en-CA" sz="1200" b="0" i="0" u="none" strike="noStrike" dirty="0">
+                        <a:solidFill>
+                          <a:srgbClr val="000000"/>
+                        </a:solidFill>
+                        <a:effectLst/>
+                        <a:latin typeface="Courier New" panose="02070309020205020404" pitchFamily="49" charset="0"/>
+                        <a:cs typeface="Courier New" panose="02070309020205020404" pitchFamily="49" charset="0"/>
+                      </a:endParaRPr>
+                    </a:p>
+                  </a:txBody>
+                  <a:tcPr marL="3472" marR="3472" marT="3472" marB="0" anchor="b">
+                    <a:lnR w="12700" cap="flat" cmpd="sng" algn="ctr">
+                      <a:solidFill>
+                        <a:schemeClr val="tx1"/>
+                      </a:solidFill>
+                      <a:prstDash val="solid"/>
+                      <a:round/>
+                      <a:headEnd type="none" w="med" len="med"/>
+                      <a:tailEnd type="none" w="med" len="med"/>
+                    </a:lnR>
+                    <a:lnT w="12700" cap="flat" cmpd="sng" algn="ctr">
+                      <a:solidFill>
+                        <a:schemeClr val="bg1">
+                          <a:lumMod val="75000"/>
+                        </a:schemeClr>
+                      </a:solidFill>
+                      <a:prstDash val="solid"/>
+                      <a:round/>
+                      <a:headEnd type="none" w="med" len="med"/>
+                      <a:tailEnd type="none" w="med" len="med"/>
+                    </a:lnT>
+                    <a:lnB w="12700" cap="flat" cmpd="sng" algn="ctr">
+                      <a:solidFill>
+                        <a:schemeClr val="bg1">
+                          <a:lumMod val="75000"/>
+                        </a:schemeClr>
+                      </a:solidFill>
+                      <a:prstDash val="solid"/>
+                      <a:round/>
+                      <a:headEnd type="none" w="med" len="med"/>
+                      <a:tailEnd type="none" w="med" len="med"/>
+                    </a:lnB>
+                  </a:tcPr>
+                </a:tc>
+                <a:tc>
+                  <a:txBody>
+                    <a:bodyPr/>
+                    <a:lstStyle/>
+                    <a:p>
+                      <a:pPr algn="l" fontAlgn="b">
+                        <a:buNone/>
+                      </a:pPr>
+                      <a:r>
+                        <a:rPr lang="en-CA" sz="1200" b="0" u="none" strike="noStrike" dirty="0">
+                          <a:solidFill>
+                            <a:srgbClr val="000000"/>
+                          </a:solidFill>
+                          <a:effectLst/>
+                          <a:latin typeface="Courier New" panose="02070309020205020404" pitchFamily="49" charset="0"/>
+                          <a:cs typeface="Courier New" panose="02070309020205020404" pitchFamily="49" charset="0"/>
+                        </a:rPr>
+                        <a:t>7.14E-09</a:t>
+                      </a:r>
+                      <a:endParaRPr lang="en-CA" sz="1200" b="0" i="0" u="none" strike="noStrike" dirty="0">
+                        <a:solidFill>
+                          <a:srgbClr val="000000"/>
+                        </a:solidFill>
+                        <a:effectLst/>
+                        <a:latin typeface="Courier New" panose="02070309020205020404" pitchFamily="49" charset="0"/>
+                        <a:cs typeface="Courier New" panose="02070309020205020404" pitchFamily="49" charset="0"/>
+                      </a:endParaRPr>
+                    </a:p>
+                  </a:txBody>
+                  <a:tcPr marL="3472" marR="3472" marT="3472" marB="0" anchor="b">
+                    <a:lnL w="12700" cap="flat" cmpd="sng" algn="ctr">
+                      <a:solidFill>
+                        <a:schemeClr val="tx1"/>
+                      </a:solidFill>
+                      <a:prstDash val="solid"/>
+                      <a:round/>
+                      <a:headEnd type="none" w="med" len="med"/>
+                      <a:tailEnd type="none" w="med" len="med"/>
+                    </a:lnL>
+                    <a:lnT w="12700" cap="flat" cmpd="sng" algn="ctr">
+                      <a:solidFill>
+                        <a:schemeClr val="bg1">
+                          <a:lumMod val="75000"/>
+                        </a:schemeClr>
+                      </a:solidFill>
+                      <a:prstDash val="solid"/>
+                      <a:round/>
+                      <a:headEnd type="none" w="med" len="med"/>
+                      <a:tailEnd type="none" w="med" len="med"/>
+                    </a:lnT>
+                    <a:lnB w="12700" cap="flat" cmpd="sng" algn="ctr">
+                      <a:solidFill>
+                        <a:schemeClr val="bg1">
+                          <a:lumMod val="75000"/>
+                        </a:schemeClr>
+                      </a:solidFill>
+                      <a:prstDash val="solid"/>
+                      <a:round/>
+                      <a:headEnd type="none" w="med" len="med"/>
+                      <a:tailEnd type="none" w="med" len="med"/>
+                    </a:lnB>
+                  </a:tcPr>
+                </a:tc>
+                <a:extLst>
+                  <a:ext uri="{0D108BD9-81ED-4DB2-BD59-A6C34878D82A}">
+                    <a16:rowId xmlns:a16="http://schemas.microsoft.com/office/drawing/2014/main" val="1957212222"/>
+                  </a:ext>
+                </a:extLst>
+              </a:tr>
+              <a:tr h="263658">
+                <a:tc>
+                  <a:txBody>
+                    <a:bodyPr/>
+                    <a:lstStyle/>
+                    <a:p>
+                      <a:pPr algn="l" fontAlgn="b">
+                        <a:spcAft>
+                          <a:spcPts val="600"/>
+                        </a:spcAft>
+                        <a:buNone/>
+                      </a:pPr>
+                      <a:r>
+                        <a:rPr lang="en-CA" sz="1200" b="0" u="none" strike="noStrike" dirty="0">
+                          <a:solidFill>
+                            <a:srgbClr val="000000"/>
+                          </a:solidFill>
+                          <a:effectLst/>
+                          <a:latin typeface="Courier New" panose="02070309020205020404" pitchFamily="49" charset="0"/>
+                          <a:cs typeface="Courier New" panose="02070309020205020404" pitchFamily="49" charset="0"/>
+                        </a:rPr>
+                        <a:t>condensed nuclear chromosome</a:t>
+                      </a:r>
+                      <a:endParaRPr lang="en-CA" sz="1200" b="0" i="0" u="none" strike="noStrike" dirty="0">
+                        <a:solidFill>
+                          <a:srgbClr val="000000"/>
+                        </a:solidFill>
+                        <a:effectLst/>
+                        <a:latin typeface="Courier New" panose="02070309020205020404" pitchFamily="49" charset="0"/>
+                        <a:cs typeface="Courier New" panose="02070309020205020404" pitchFamily="49" charset="0"/>
+                      </a:endParaRPr>
+                    </a:p>
+                  </a:txBody>
+                  <a:tcPr marL="3472" marR="3472" marT="3472" marB="0" anchor="b">
+                    <a:lnR w="12700" cap="flat" cmpd="sng" algn="ctr">
+                      <a:solidFill>
+                        <a:schemeClr val="tx1"/>
+                      </a:solidFill>
+                      <a:prstDash val="solid"/>
+                      <a:round/>
+                      <a:headEnd type="none" w="med" len="med"/>
+                      <a:tailEnd type="none" w="med" len="med"/>
+                    </a:lnR>
+                    <a:lnT w="12700" cap="flat" cmpd="sng" algn="ctr">
+                      <a:solidFill>
+                        <a:schemeClr val="bg1">
+                          <a:lumMod val="75000"/>
+                        </a:schemeClr>
+                      </a:solidFill>
+                      <a:prstDash val="solid"/>
+                      <a:round/>
+                      <a:headEnd type="none" w="med" len="med"/>
+                      <a:tailEnd type="none" w="med" len="med"/>
+                    </a:lnT>
+                    <a:lnB w="12700" cap="flat" cmpd="sng" algn="ctr">
+                      <a:solidFill>
+                        <a:schemeClr val="bg1">
+                          <a:lumMod val="75000"/>
+                        </a:schemeClr>
+                      </a:solidFill>
+                      <a:prstDash val="solid"/>
+                      <a:round/>
+                      <a:headEnd type="none" w="med" len="med"/>
+                      <a:tailEnd type="none" w="med" len="med"/>
+                    </a:lnB>
+                  </a:tcPr>
+                </a:tc>
+                <a:tc>
+                  <a:txBody>
+                    <a:bodyPr/>
+                    <a:lstStyle/>
+                    <a:p>
+                      <a:pPr algn="l" fontAlgn="b">
+                        <a:buNone/>
+                      </a:pPr>
+                      <a:r>
+                        <a:rPr lang="en-CA" sz="1200" b="0" u="none" strike="noStrike" dirty="0">
+                          <a:solidFill>
+                            <a:srgbClr val="000000"/>
+                          </a:solidFill>
+                          <a:effectLst/>
+                          <a:latin typeface="Courier New" panose="02070309020205020404" pitchFamily="49" charset="0"/>
+                          <a:cs typeface="Courier New" panose="02070309020205020404" pitchFamily="49" charset="0"/>
+                        </a:rPr>
+                        <a:t>8.75E-09</a:t>
+                      </a:r>
+                      <a:endParaRPr lang="en-CA" sz="1200" b="0" i="0" u="none" strike="noStrike" dirty="0">
+                        <a:solidFill>
+                          <a:srgbClr val="000000"/>
+                        </a:solidFill>
+                        <a:effectLst/>
+                        <a:latin typeface="Courier New" panose="02070309020205020404" pitchFamily="49" charset="0"/>
+                        <a:cs typeface="Courier New" panose="02070309020205020404" pitchFamily="49" charset="0"/>
+                      </a:endParaRPr>
+                    </a:p>
+                  </a:txBody>
+                  <a:tcPr marL="3472" marR="3472" marT="3472" marB="0" anchor="b">
+                    <a:lnL w="12700" cap="flat" cmpd="sng" algn="ctr">
+                      <a:solidFill>
+                        <a:schemeClr val="tx1"/>
+                      </a:solidFill>
+                      <a:prstDash val="solid"/>
+                      <a:round/>
+                      <a:headEnd type="none" w="med" len="med"/>
+                      <a:tailEnd type="none" w="med" len="med"/>
+                    </a:lnL>
+                    <a:lnT w="12700" cap="flat" cmpd="sng" algn="ctr">
+                      <a:solidFill>
+                        <a:schemeClr val="bg1">
+                          <a:lumMod val="75000"/>
+                        </a:schemeClr>
+                      </a:solidFill>
+                      <a:prstDash val="solid"/>
+                      <a:round/>
+                      <a:headEnd type="none" w="med" len="med"/>
+                      <a:tailEnd type="none" w="med" len="med"/>
+                    </a:lnT>
+                    <a:lnB w="12700" cap="flat" cmpd="sng" algn="ctr">
+                      <a:solidFill>
+                        <a:schemeClr val="bg1">
+                          <a:lumMod val="75000"/>
+                        </a:schemeClr>
+                      </a:solidFill>
+                      <a:prstDash val="solid"/>
+                      <a:round/>
+                      <a:headEnd type="none" w="med" len="med"/>
+                      <a:tailEnd type="none" w="med" len="med"/>
+                    </a:lnB>
+                  </a:tcPr>
+                </a:tc>
+                <a:extLst>
+                  <a:ext uri="{0D108BD9-81ED-4DB2-BD59-A6C34878D82A}">
+                    <a16:rowId xmlns:a16="http://schemas.microsoft.com/office/drawing/2014/main" val="4151670983"/>
+                  </a:ext>
+                </a:extLst>
+              </a:tr>
+              <a:tr h="208401">
+                <a:tc>
+                  <a:txBody>
+                    <a:bodyPr/>
+                    <a:lstStyle/>
+                    <a:p>
+                      <a:pPr algn="l" fontAlgn="b">
+                        <a:spcAft>
+                          <a:spcPts val="600"/>
+                        </a:spcAft>
+                        <a:buNone/>
+                      </a:pPr>
+                      <a:r>
+                        <a:rPr lang="en-CA" sz="1200" b="0" u="none" strike="noStrike" dirty="0">
+                          <a:solidFill>
+                            <a:srgbClr val="000000"/>
+                          </a:solidFill>
+                          <a:effectLst/>
+                          <a:latin typeface="Courier New" panose="02070309020205020404" pitchFamily="49" charset="0"/>
+                          <a:cs typeface="Courier New" panose="02070309020205020404" pitchFamily="49" charset="0"/>
+                        </a:rPr>
+                        <a:t>ATP binding</a:t>
+                      </a:r>
+                      <a:endParaRPr lang="en-CA" sz="1200" b="0" i="0" u="none" strike="noStrike" dirty="0">
+                        <a:solidFill>
+                          <a:srgbClr val="000000"/>
+                        </a:solidFill>
+                        <a:effectLst/>
+                        <a:latin typeface="Courier New" panose="02070309020205020404" pitchFamily="49" charset="0"/>
+                        <a:cs typeface="Courier New" panose="02070309020205020404" pitchFamily="49" charset="0"/>
+                      </a:endParaRPr>
+                    </a:p>
+                  </a:txBody>
+                  <a:tcPr marL="3472" marR="3472" marT="3472" marB="0" anchor="b">
+                    <a:lnR w="12700" cap="flat" cmpd="sng" algn="ctr">
+                      <a:solidFill>
+                        <a:schemeClr val="tx1"/>
+                      </a:solidFill>
+                      <a:prstDash val="solid"/>
+                      <a:round/>
+                      <a:headEnd type="none" w="med" len="med"/>
+                      <a:tailEnd type="none" w="med" len="med"/>
+                    </a:lnR>
+                    <a:lnT w="12700" cap="flat" cmpd="sng" algn="ctr">
+                      <a:solidFill>
+                        <a:schemeClr val="bg1">
+                          <a:lumMod val="75000"/>
+                        </a:schemeClr>
+                      </a:solidFill>
+                      <a:prstDash val="solid"/>
+                      <a:round/>
+                      <a:headEnd type="none" w="med" len="med"/>
+                      <a:tailEnd type="none" w="med" len="med"/>
+                    </a:lnT>
+                    <a:lnB w="12700" cap="flat" cmpd="sng" algn="ctr">
+                      <a:solidFill>
+                        <a:schemeClr val="bg1">
+                          <a:lumMod val="75000"/>
+                        </a:schemeClr>
+                      </a:solidFill>
+                      <a:prstDash val="solid"/>
+                      <a:round/>
+                      <a:headEnd type="none" w="med" len="med"/>
+                      <a:tailEnd type="none" w="med" len="med"/>
+                    </a:lnB>
+                  </a:tcPr>
+                </a:tc>
+                <a:tc>
+                  <a:txBody>
+                    <a:bodyPr/>
+                    <a:lstStyle/>
+                    <a:p>
+                      <a:pPr algn="l" fontAlgn="b">
+                        <a:buNone/>
+                      </a:pPr>
+                      <a:r>
+                        <a:rPr lang="en-CA" sz="1200" b="0" u="none" strike="noStrike" dirty="0">
+                          <a:solidFill>
+                            <a:srgbClr val="000000"/>
+                          </a:solidFill>
+                          <a:effectLst/>
+                          <a:latin typeface="Courier New" panose="02070309020205020404" pitchFamily="49" charset="0"/>
+                          <a:cs typeface="Courier New" panose="02070309020205020404" pitchFamily="49" charset="0"/>
+                        </a:rPr>
+                        <a:t>1.13E-08</a:t>
+                      </a:r>
+                      <a:endParaRPr lang="en-CA" sz="1200" b="0" i="0" u="none" strike="noStrike" dirty="0">
+                        <a:solidFill>
+                          <a:srgbClr val="000000"/>
+                        </a:solidFill>
+                        <a:effectLst/>
+                        <a:latin typeface="Courier New" panose="02070309020205020404" pitchFamily="49" charset="0"/>
+                        <a:cs typeface="Courier New" panose="02070309020205020404" pitchFamily="49" charset="0"/>
+                      </a:endParaRPr>
+                    </a:p>
+                  </a:txBody>
+                  <a:tcPr marL="3472" marR="3472" marT="3472" marB="0" anchor="b">
+                    <a:lnL w="12700" cap="flat" cmpd="sng" algn="ctr">
+                      <a:solidFill>
+                        <a:schemeClr val="tx1"/>
+                      </a:solidFill>
+                      <a:prstDash val="solid"/>
+                      <a:round/>
+                      <a:headEnd type="none" w="med" len="med"/>
+                      <a:tailEnd type="none" w="med" len="med"/>
+                    </a:lnL>
+                    <a:lnT w="12700" cap="flat" cmpd="sng" algn="ctr">
+                      <a:solidFill>
+                        <a:schemeClr val="bg1">
+                          <a:lumMod val="75000"/>
+                        </a:schemeClr>
+                      </a:solidFill>
+                      <a:prstDash val="solid"/>
+                      <a:round/>
+                      <a:headEnd type="none" w="med" len="med"/>
+                      <a:tailEnd type="none" w="med" len="med"/>
+                    </a:lnT>
+                    <a:lnB w="12700" cap="flat" cmpd="sng" algn="ctr">
+                      <a:solidFill>
+                        <a:schemeClr val="bg1">
+                          <a:lumMod val="75000"/>
+                        </a:schemeClr>
+                      </a:solidFill>
+                      <a:prstDash val="solid"/>
+                      <a:round/>
+                      <a:headEnd type="none" w="med" len="med"/>
+                      <a:tailEnd type="none" w="med" len="med"/>
+                    </a:lnB>
+                  </a:tcPr>
+                </a:tc>
+                <a:extLst>
+                  <a:ext uri="{0D108BD9-81ED-4DB2-BD59-A6C34878D82A}">
+                    <a16:rowId xmlns:a16="http://schemas.microsoft.com/office/drawing/2014/main" val="694408269"/>
+                  </a:ext>
+                </a:extLst>
+              </a:tr>
+              <a:tr h="263658">
+                <a:tc>
+                  <a:txBody>
+                    <a:bodyPr/>
+                    <a:lstStyle/>
+                    <a:p>
+                      <a:pPr algn="l" fontAlgn="b">
+                        <a:spcAft>
+                          <a:spcPts val="600"/>
+                        </a:spcAft>
+                        <a:buNone/>
+                      </a:pPr>
+                      <a:r>
+                        <a:rPr lang="en-CA" sz="1200" b="0" u="none" strike="noStrike" dirty="0">
+                          <a:solidFill>
+                            <a:srgbClr val="000000"/>
+                          </a:solidFill>
+                          <a:effectLst/>
+                          <a:latin typeface="Courier New" panose="02070309020205020404" pitchFamily="49" charset="0"/>
+                          <a:cs typeface="Courier New" panose="02070309020205020404" pitchFamily="49" charset="0"/>
+                        </a:rPr>
+                        <a:t>chromosome organization</a:t>
+                      </a:r>
+                      <a:endParaRPr lang="en-CA" sz="1200" b="0" i="0" u="none" strike="noStrike" dirty="0">
+                        <a:solidFill>
+                          <a:srgbClr val="000000"/>
+                        </a:solidFill>
+                        <a:effectLst/>
+                        <a:latin typeface="Courier New" panose="02070309020205020404" pitchFamily="49" charset="0"/>
+                        <a:cs typeface="Courier New" panose="02070309020205020404" pitchFamily="49" charset="0"/>
+                      </a:endParaRPr>
+                    </a:p>
+                  </a:txBody>
+                  <a:tcPr marL="3472" marR="3472" marT="3472" marB="0" anchor="b">
+                    <a:lnR w="12700" cap="flat" cmpd="sng" algn="ctr">
+                      <a:solidFill>
+                        <a:schemeClr val="tx1"/>
+                      </a:solidFill>
+                      <a:prstDash val="solid"/>
+                      <a:round/>
+                      <a:headEnd type="none" w="med" len="med"/>
+                      <a:tailEnd type="none" w="med" len="med"/>
+                    </a:lnR>
+                    <a:lnT w="12700" cap="flat" cmpd="sng" algn="ctr">
+                      <a:solidFill>
+                        <a:schemeClr val="bg1">
+                          <a:lumMod val="75000"/>
+                        </a:schemeClr>
+                      </a:solidFill>
+                      <a:prstDash val="solid"/>
+                      <a:round/>
+                      <a:headEnd type="none" w="med" len="med"/>
+                      <a:tailEnd type="none" w="med" len="med"/>
+                    </a:lnT>
+                  </a:tcPr>
+                </a:tc>
+                <a:tc>
+                  <a:txBody>
+                    <a:bodyPr/>
+                    <a:lstStyle/>
+                    <a:p>
+                      <a:pPr algn="l" fontAlgn="b">
+                        <a:buNone/>
+                      </a:pPr>
+                      <a:r>
+                        <a:rPr lang="en-CA" sz="1200" b="0" u="none" strike="noStrike" dirty="0">
+                          <a:solidFill>
+                            <a:srgbClr val="000000"/>
+                          </a:solidFill>
+                          <a:effectLst/>
+                          <a:latin typeface="Courier New" panose="02070309020205020404" pitchFamily="49" charset="0"/>
+                          <a:cs typeface="Courier New" panose="02070309020205020404" pitchFamily="49" charset="0"/>
+                        </a:rPr>
+                        <a:t>1.19E-08</a:t>
+                      </a:r>
+                      <a:endParaRPr lang="en-CA" sz="1200" b="0" i="0" u="none" strike="noStrike" dirty="0">
+                        <a:solidFill>
+                          <a:srgbClr val="000000"/>
+                        </a:solidFill>
+                        <a:effectLst/>
+                        <a:latin typeface="Courier New" panose="02070309020205020404" pitchFamily="49" charset="0"/>
+                        <a:cs typeface="Courier New" panose="02070309020205020404" pitchFamily="49" charset="0"/>
+                      </a:endParaRPr>
+                    </a:p>
+                  </a:txBody>
+                  <a:tcPr marL="3472" marR="3472" marT="3472" marB="0" anchor="b">
+                    <a:lnL w="12700" cap="flat" cmpd="sng" algn="ctr">
+                      <a:solidFill>
+                        <a:schemeClr val="tx1"/>
+                      </a:solidFill>
+                      <a:prstDash val="solid"/>
+                      <a:round/>
+                      <a:headEnd type="none" w="med" len="med"/>
+                      <a:tailEnd type="none" w="med" len="med"/>
+                    </a:lnL>
+                    <a:lnT w="12700" cap="flat" cmpd="sng" algn="ctr">
+                      <a:solidFill>
+                        <a:schemeClr val="bg1">
+                          <a:lumMod val="75000"/>
+                        </a:schemeClr>
+                      </a:solidFill>
+                      <a:prstDash val="solid"/>
+                      <a:round/>
+                      <a:headEnd type="none" w="med" len="med"/>
+                      <a:tailEnd type="none" w="med" len="med"/>
+                    </a:lnT>
+                  </a:tcPr>
+                </a:tc>
+                <a:extLst>
+                  <a:ext uri="{0D108BD9-81ED-4DB2-BD59-A6C34878D82A}">
+                    <a16:rowId xmlns:a16="http://schemas.microsoft.com/office/drawing/2014/main" val="1892658907"/>
+                  </a:ext>
+                </a:extLst>
+              </a:tr>
+            </a:tbl>
+          </a:graphicData>
+        </a:graphic>
+      </p:graphicFrame>
     </p:spTree>
     <p:extLst>
       <p:ext uri="{BB962C8B-B14F-4D97-AF65-F5344CB8AC3E}">

</xml_diff>

<commit_message>
Added slide for B4DY67_HUMAN alignment.
</commit_message>
<xml_diff>
--- a/vis/reports/2026-02-18_projectUpdate_1.pptx
+++ b/vis/reports/2026-02-18_projectUpdate_1.pptx
@@ -5,7 +5,7 @@
     <p:sldMasterId id="2147483648" r:id="rId1"/>
   </p:sldMasterIdLst>
   <p:notesMasterIdLst>
-    <p:notesMasterId r:id="rId10"/>
+    <p:notesMasterId r:id="rId11"/>
   </p:notesMasterIdLst>
   <p:sldIdLst>
     <p:sldId id="256" r:id="rId2"/>
@@ -15,7 +15,8 @@
     <p:sldId id="262" r:id="rId6"/>
     <p:sldId id="261" r:id="rId7"/>
     <p:sldId id="263" r:id="rId8"/>
-    <p:sldId id="260" r:id="rId9"/>
+    <p:sldId id="264" r:id="rId9"/>
+    <p:sldId id="260" r:id="rId10"/>
   </p:sldIdLst>
   <p:sldSz cx="12192000" cy="6858000"/>
   <p:notesSz cx="6858000" cy="9144000"/>
@@ -9075,8 +9076,8 @@
         </p:blipFill>
         <p:spPr>
           <a:xfrm>
-            <a:off x="6611112" y="1510389"/>
-            <a:ext cx="4258034" cy="4154880"/>
+            <a:off x="6630162" y="1843913"/>
+            <a:ext cx="3942588" cy="3847076"/>
           </a:xfrm>
           <a:prstGeom prst="rect">
             <a:avLst/>
@@ -9223,7 +9224,7 @@
                         <a:buNone/>
                       </a:pPr>
                       <a:r>
-                        <a:rPr lang="en-CA" sz="1400" b="0" u="none" strike="noStrike" dirty="0" err="1">
+                        <a:rPr lang="en-CA" sz="1400" b="0" u="none" strike="noStrike" dirty="0">
                           <a:solidFill>
                             <a:srgbClr val="000000"/>
                           </a:solidFill>
@@ -10569,6 +10570,228 @@
           </a:graphicData>
         </a:graphic>
       </p:graphicFrame>
+      <p:cxnSp>
+        <p:nvCxnSpPr>
+          <p:cNvPr id="12" name="Straight Connector 11">
+            <a:extLst>
+              <a:ext uri="{FF2B5EF4-FFF2-40B4-BE49-F238E27FC236}">
+                <a16:creationId xmlns:a16="http://schemas.microsoft.com/office/drawing/2014/main" id="{C9D015D3-6C93-96AC-884B-2A6EADED208F}"/>
+              </a:ext>
+            </a:extLst>
+          </p:cNvPr>
+          <p:cNvCxnSpPr>
+            <a:cxnSpLocks/>
+          </p:cNvCxnSpPr>
+          <p:nvPr/>
+        </p:nvCxnSpPr>
+        <p:spPr>
+          <a:xfrm>
+            <a:off x="3712464" y="429768"/>
+            <a:ext cx="1444752" cy="0"/>
+          </a:xfrm>
+          <a:prstGeom prst="line">
+            <a:avLst/>
+          </a:prstGeom>
+          <a:ln w="28575">
+            <a:solidFill>
+              <a:schemeClr val="tx1">
+                <a:lumMod val="95000"/>
+                <a:lumOff val="5000"/>
+              </a:schemeClr>
+            </a:solidFill>
+          </a:ln>
+        </p:spPr>
+        <p:style>
+          <a:lnRef idx="2">
+            <a:schemeClr val="accent1"/>
+          </a:lnRef>
+          <a:fillRef idx="0">
+            <a:schemeClr val="accent1"/>
+          </a:fillRef>
+          <a:effectRef idx="1">
+            <a:schemeClr val="accent1"/>
+          </a:effectRef>
+          <a:fontRef idx="minor">
+            <a:schemeClr val="tx1"/>
+          </a:fontRef>
+        </p:style>
+      </p:cxnSp>
+      <p:sp>
+        <p:nvSpPr>
+          <p:cNvPr id="14" name="TextBox 13">
+            <a:extLst>
+              <a:ext uri="{FF2B5EF4-FFF2-40B4-BE49-F238E27FC236}">
+                <a16:creationId xmlns:a16="http://schemas.microsoft.com/office/drawing/2014/main" id="{AD168F6E-F847-3753-EFEF-6693E070ABA7}"/>
+              </a:ext>
+            </a:extLst>
+          </p:cNvPr>
+          <p:cNvSpPr txBox="1"/>
+          <p:nvPr/>
+        </p:nvSpPr>
+        <p:spPr>
+          <a:xfrm>
+            <a:off x="5230368" y="198935"/>
+            <a:ext cx="2514600" cy="461665"/>
+          </a:xfrm>
+          <a:prstGeom prst="rect">
+            <a:avLst/>
+          </a:prstGeom>
+          <a:noFill/>
+        </p:spPr>
+        <p:txBody>
+          <a:bodyPr wrap="square" rtlCol="0">
+            <a:spAutoFit/>
+          </a:bodyPr>
+          <a:lstStyle/>
+          <a:p>
+            <a:r>
+              <a:rPr lang="en-US" sz="1200" dirty="0">
+                <a:latin typeface="Courier New" panose="02070309020205020404" pitchFamily="49" charset="0"/>
+                <a:cs typeface="Courier New" panose="02070309020205020404" pitchFamily="49" charset="0"/>
+              </a:rPr>
+              <a:t>contains proteins from 17 distinct clusters</a:t>
+            </a:r>
+            <a:endParaRPr lang="en-CA" sz="1200" dirty="0">
+              <a:latin typeface="Courier New" panose="02070309020205020404" pitchFamily="49" charset="0"/>
+              <a:cs typeface="Courier New" panose="02070309020205020404" pitchFamily="49" charset="0"/>
+            </a:endParaRPr>
+          </a:p>
+        </p:txBody>
+      </p:sp>
+      <p:cxnSp>
+        <p:nvCxnSpPr>
+          <p:cNvPr id="15" name="Straight Connector 14">
+            <a:extLst>
+              <a:ext uri="{FF2B5EF4-FFF2-40B4-BE49-F238E27FC236}">
+                <a16:creationId xmlns:a16="http://schemas.microsoft.com/office/drawing/2014/main" id="{3B35B9B2-75E2-21C4-C4B0-903AB365669E}"/>
+              </a:ext>
+            </a:extLst>
+          </p:cNvPr>
+          <p:cNvCxnSpPr>
+            <a:cxnSpLocks/>
+          </p:cNvCxnSpPr>
+          <p:nvPr/>
+        </p:nvCxnSpPr>
+        <p:spPr>
+          <a:xfrm>
+            <a:off x="3712464" y="587057"/>
+            <a:ext cx="576072" cy="420913"/>
+          </a:xfrm>
+          <a:prstGeom prst="line">
+            <a:avLst/>
+          </a:prstGeom>
+          <a:ln w="28575">
+            <a:solidFill>
+              <a:schemeClr val="tx1">
+                <a:lumMod val="95000"/>
+                <a:lumOff val="5000"/>
+              </a:schemeClr>
+            </a:solidFill>
+          </a:ln>
+        </p:spPr>
+        <p:style>
+          <a:lnRef idx="2">
+            <a:schemeClr val="accent1"/>
+          </a:lnRef>
+          <a:fillRef idx="0">
+            <a:schemeClr val="accent1"/>
+          </a:fillRef>
+          <a:effectRef idx="1">
+            <a:schemeClr val="accent1"/>
+          </a:effectRef>
+          <a:fontRef idx="minor">
+            <a:schemeClr val="tx1"/>
+          </a:fontRef>
+        </p:style>
+      </p:cxnSp>
+      <p:cxnSp>
+        <p:nvCxnSpPr>
+          <p:cNvPr id="18" name="Straight Connector 17">
+            <a:extLst>
+              <a:ext uri="{FF2B5EF4-FFF2-40B4-BE49-F238E27FC236}">
+                <a16:creationId xmlns:a16="http://schemas.microsoft.com/office/drawing/2014/main" id="{5EE9BB5F-06F0-B954-03A0-7CE763E44F3C}"/>
+              </a:ext>
+            </a:extLst>
+          </p:cNvPr>
+          <p:cNvCxnSpPr>
+            <a:cxnSpLocks/>
+          </p:cNvCxnSpPr>
+          <p:nvPr/>
+        </p:nvCxnSpPr>
+        <p:spPr>
+          <a:xfrm>
+            <a:off x="4276631" y="1007970"/>
+            <a:ext cx="880585" cy="0"/>
+          </a:xfrm>
+          <a:prstGeom prst="line">
+            <a:avLst/>
+          </a:prstGeom>
+          <a:ln w="28575">
+            <a:solidFill>
+              <a:schemeClr val="tx1">
+                <a:lumMod val="95000"/>
+                <a:lumOff val="5000"/>
+              </a:schemeClr>
+            </a:solidFill>
+          </a:ln>
+        </p:spPr>
+        <p:style>
+          <a:lnRef idx="2">
+            <a:schemeClr val="accent1"/>
+          </a:lnRef>
+          <a:fillRef idx="0">
+            <a:schemeClr val="accent1"/>
+          </a:fillRef>
+          <a:effectRef idx="1">
+            <a:schemeClr val="accent1"/>
+          </a:effectRef>
+          <a:fontRef idx="minor">
+            <a:schemeClr val="tx1"/>
+          </a:fontRef>
+        </p:style>
+      </p:cxnSp>
+      <p:sp>
+        <p:nvSpPr>
+          <p:cNvPr id="22" name="TextBox 21">
+            <a:extLst>
+              <a:ext uri="{FF2B5EF4-FFF2-40B4-BE49-F238E27FC236}">
+                <a16:creationId xmlns:a16="http://schemas.microsoft.com/office/drawing/2014/main" id="{1D07A6DF-281B-02B0-1C6D-015E97A43D46}"/>
+              </a:ext>
+            </a:extLst>
+          </p:cNvPr>
+          <p:cNvSpPr txBox="1"/>
+          <p:nvPr/>
+        </p:nvSpPr>
+        <p:spPr>
+          <a:xfrm>
+            <a:off x="5230368" y="777137"/>
+            <a:ext cx="2514600" cy="830997"/>
+          </a:xfrm>
+          <a:prstGeom prst="rect">
+            <a:avLst/>
+          </a:prstGeom>
+          <a:noFill/>
+        </p:spPr>
+        <p:txBody>
+          <a:bodyPr wrap="square" rtlCol="0">
+            <a:spAutoFit/>
+          </a:bodyPr>
+          <a:lstStyle/>
+          <a:p>
+            <a:r>
+              <a:rPr lang="en-US" sz="1200" dirty="0">
+                <a:latin typeface="Courier New" panose="02070309020205020404" pitchFamily="49" charset="0"/>
+                <a:cs typeface="Courier New" panose="02070309020205020404" pitchFamily="49" charset="0"/>
+              </a:rPr>
+              <a:t>functions generally pertain to triphosphate metabolism and chromosome organization</a:t>
+            </a:r>
+            <a:endParaRPr lang="en-CA" sz="1200" dirty="0">
+              <a:latin typeface="Courier New" panose="02070309020205020404" pitchFamily="49" charset="0"/>
+              <a:cs typeface="Courier New" panose="02070309020205020404" pitchFamily="49" charset="0"/>
+            </a:endParaRPr>
+          </a:p>
+        </p:txBody>
+      </p:sp>
     </p:spTree>
     <p:extLst>
       <p:ext uri="{BB962C8B-B14F-4D97-AF65-F5344CB8AC3E}">
@@ -10583,6 +10806,595 @@
 </file>
 
 <file path=ppt/slides/slide8.xml><?xml version="1.0" encoding="utf-8"?>
+<p:sld xmlns:a="http://schemas.openxmlformats.org/drawingml/2006/main" xmlns:r="http://schemas.openxmlformats.org/officeDocument/2006/relationships" xmlns:p="http://schemas.openxmlformats.org/presentationml/2006/main">
+  <p:cSld>
+    <p:spTree>
+      <p:nvGrpSpPr>
+        <p:cNvPr id="1" name=""/>
+        <p:cNvGrpSpPr/>
+        <p:nvPr/>
+      </p:nvGrpSpPr>
+      <p:grpSpPr>
+        <a:xfrm>
+          <a:off x="0" y="0"/>
+          <a:ext cx="0" cy="0"/>
+          <a:chOff x="0" y="0"/>
+          <a:chExt cx="0" cy="0"/>
+        </a:xfrm>
+      </p:grpSpPr>
+      <p:pic>
+        <p:nvPicPr>
+          <p:cNvPr id="6" name="Picture 5">
+            <a:extLst>
+              <a:ext uri="{FF2B5EF4-FFF2-40B4-BE49-F238E27FC236}">
+                <a16:creationId xmlns:a16="http://schemas.microsoft.com/office/drawing/2014/main" id="{96F77067-24FC-9535-0EBC-6A8C58BC8504}"/>
+              </a:ext>
+            </a:extLst>
+          </p:cNvPr>
+          <p:cNvPicPr>
+            <a:picLocks noChangeAspect="1"/>
+          </p:cNvPicPr>
+          <p:nvPr/>
+        </p:nvPicPr>
+        <p:blipFill>
+          <a:blip r:embed="rId2"/>
+          <a:stretch>
+            <a:fillRect/>
+          </a:stretch>
+        </p:blipFill>
+        <p:spPr>
+          <a:xfrm>
+            <a:off x="6795573" y="1523999"/>
+            <a:ext cx="4562470" cy="3991425"/>
+          </a:xfrm>
+          <a:prstGeom prst="rect">
+            <a:avLst/>
+          </a:prstGeom>
+        </p:spPr>
+      </p:pic>
+      <p:sp>
+        <p:nvSpPr>
+          <p:cNvPr id="9" name="TextBox 8">
+            <a:extLst>
+              <a:ext uri="{FF2B5EF4-FFF2-40B4-BE49-F238E27FC236}">
+                <a16:creationId xmlns:a16="http://schemas.microsoft.com/office/drawing/2014/main" id="{472E00D6-513F-9237-58C0-620B89DDF978}"/>
+              </a:ext>
+            </a:extLst>
+          </p:cNvPr>
+          <p:cNvSpPr txBox="1"/>
+          <p:nvPr/>
+        </p:nvSpPr>
+        <p:spPr>
+          <a:xfrm>
+            <a:off x="8662467" y="1295310"/>
+            <a:ext cx="2695576" cy="954107"/>
+          </a:xfrm>
+          <a:prstGeom prst="rect">
+            <a:avLst/>
+          </a:prstGeom>
+          <a:noFill/>
+        </p:spPr>
+        <p:txBody>
+          <a:bodyPr wrap="square" rtlCol="0">
+            <a:spAutoFit/>
+          </a:bodyPr>
+          <a:lstStyle/>
+          <a:p>
+            <a:r>
+              <a:rPr lang="en-US" sz="1400" dirty="0">
+                <a:latin typeface="Verdana Pro" panose="020B0604030504040204" pitchFamily="34" charset="0"/>
+                <a:cs typeface="Courier New" panose="02070309020205020404" pitchFamily="49" charset="0"/>
+              </a:rPr>
+              <a:t>RMSD: 2.7 Å</a:t>
+            </a:r>
+            <a:endParaRPr lang="en-CA" sz="1400" dirty="0">
+              <a:latin typeface="Verdana Pro" panose="020B0604030504040204" pitchFamily="34" charset="0"/>
+              <a:cs typeface="Courier New" panose="02070309020205020404" pitchFamily="49" charset="0"/>
+            </a:endParaRPr>
+          </a:p>
+          <a:p>
+            <a:r>
+              <a:rPr lang="en-US" sz="1400" dirty="0">
+                <a:latin typeface="Verdana Pro" panose="020B0604030504040204" pitchFamily="34" charset="0"/>
+                <a:cs typeface="Courier New" panose="02070309020205020404" pitchFamily="49" charset="0"/>
+              </a:rPr>
+              <a:t>TM-score: 0.72</a:t>
+            </a:r>
+          </a:p>
+          <a:p>
+            <a:r>
+              <a:rPr lang="en-US" sz="1400" dirty="0">
+                <a:latin typeface="Verdana Pro" panose="020B0604030504040204" pitchFamily="34" charset="0"/>
+                <a:cs typeface="Courier New" panose="02070309020205020404" pitchFamily="49" charset="0"/>
+              </a:rPr>
+              <a:t>Identity: 11%</a:t>
+            </a:r>
+          </a:p>
+          <a:p>
+            <a:r>
+              <a:rPr lang="en-US" sz="1400" dirty="0">
+                <a:latin typeface="Verdana Pro" panose="020B0604030504040204" pitchFamily="34" charset="0"/>
+                <a:cs typeface="Courier New" panose="02070309020205020404" pitchFamily="49" charset="0"/>
+              </a:rPr>
+              <a:t>Aligned residues: 351</a:t>
+            </a:r>
+          </a:p>
+        </p:txBody>
+      </p:sp>
+      <p:sp>
+        <p:nvSpPr>
+          <p:cNvPr id="10" name="TextBox 9">
+            <a:extLst>
+              <a:ext uri="{FF2B5EF4-FFF2-40B4-BE49-F238E27FC236}">
+                <a16:creationId xmlns:a16="http://schemas.microsoft.com/office/drawing/2014/main" id="{F1FA6637-E092-1B6C-7935-EA705C837392}"/>
+              </a:ext>
+            </a:extLst>
+          </p:cNvPr>
+          <p:cNvSpPr txBox="1"/>
+          <p:nvPr/>
+        </p:nvSpPr>
+        <p:spPr>
+          <a:xfrm>
+            <a:off x="5819774" y="4476660"/>
+            <a:ext cx="2466975" cy="646331"/>
+          </a:xfrm>
+          <a:prstGeom prst="rect">
+            <a:avLst/>
+          </a:prstGeom>
+          <a:noFill/>
+        </p:spPr>
+        <p:txBody>
+          <a:bodyPr wrap="square" rtlCol="0">
+            <a:spAutoFit/>
+          </a:bodyPr>
+          <a:lstStyle/>
+          <a:p>
+            <a:r>
+              <a:rPr lang="en-CA" b="1" dirty="0">
+                <a:solidFill>
+                  <a:srgbClr val="E0913A"/>
+                </a:solidFill>
+                <a:latin typeface="Verdana Pro" panose="020B0604030504040204" pitchFamily="34" charset="0"/>
+                <a:cs typeface="Courier New" panose="02070309020205020404" pitchFamily="49" charset="0"/>
+              </a:rPr>
+              <a:t>A0A414Z6D3</a:t>
+            </a:r>
+          </a:p>
+          <a:p>
+            <a:r>
+              <a:rPr lang="en-CA" dirty="0">
+                <a:solidFill>
+                  <a:srgbClr val="E0913A"/>
+                </a:solidFill>
+                <a:latin typeface="Verdana Pro" panose="020B0604030504040204" pitchFamily="34" charset="0"/>
+                <a:cs typeface="Courier New" panose="02070309020205020404" pitchFamily="49" charset="0"/>
+              </a:rPr>
+              <a:t>(469 AAs)</a:t>
+            </a:r>
+          </a:p>
+        </p:txBody>
+      </p:sp>
+      <p:sp>
+        <p:nvSpPr>
+          <p:cNvPr id="11" name="TextBox 10">
+            <a:extLst>
+              <a:ext uri="{FF2B5EF4-FFF2-40B4-BE49-F238E27FC236}">
+                <a16:creationId xmlns:a16="http://schemas.microsoft.com/office/drawing/2014/main" id="{ABF68326-63AC-E717-6320-1C3CA8B60D96}"/>
+              </a:ext>
+            </a:extLst>
+          </p:cNvPr>
+          <p:cNvSpPr txBox="1"/>
+          <p:nvPr/>
+        </p:nvSpPr>
+        <p:spPr>
+          <a:xfrm>
+            <a:off x="5262045" y="1849308"/>
+            <a:ext cx="2466975" cy="646331"/>
+          </a:xfrm>
+          <a:prstGeom prst="rect">
+            <a:avLst/>
+          </a:prstGeom>
+          <a:noFill/>
+        </p:spPr>
+        <p:txBody>
+          <a:bodyPr wrap="square" rtlCol="0">
+            <a:spAutoFit/>
+          </a:bodyPr>
+          <a:lstStyle/>
+          <a:p>
+            <a:r>
+              <a:rPr lang="en-CA" b="1" dirty="0">
+                <a:solidFill>
+                  <a:srgbClr val="4779C6"/>
+                </a:solidFill>
+                <a:latin typeface="Verdana Pro" panose="020B0604030504040204" pitchFamily="34" charset="0"/>
+                <a:cs typeface="Courier New" panose="02070309020205020404" pitchFamily="49" charset="0"/>
+              </a:rPr>
+              <a:t>B4DY67_HUMAN</a:t>
+            </a:r>
+          </a:p>
+          <a:p>
+            <a:r>
+              <a:rPr lang="en-CA" dirty="0">
+                <a:solidFill>
+                  <a:srgbClr val="4779C6"/>
+                </a:solidFill>
+                <a:latin typeface="Verdana Pro" panose="020B0604030504040204" pitchFamily="34" charset="0"/>
+                <a:cs typeface="Courier New" panose="02070309020205020404" pitchFamily="49" charset="0"/>
+              </a:rPr>
+              <a:t>(496 AAs)</a:t>
+            </a:r>
+          </a:p>
+        </p:txBody>
+      </p:sp>
+      <p:sp>
+        <p:nvSpPr>
+          <p:cNvPr id="13" name="TextBox 12">
+            <a:extLst>
+              <a:ext uri="{FF2B5EF4-FFF2-40B4-BE49-F238E27FC236}">
+                <a16:creationId xmlns:a16="http://schemas.microsoft.com/office/drawing/2014/main" id="{0552D1E4-33FD-0AE3-C6D0-97DFE648224E}"/>
+              </a:ext>
+            </a:extLst>
+          </p:cNvPr>
+          <p:cNvSpPr txBox="1"/>
+          <p:nvPr/>
+        </p:nvSpPr>
+        <p:spPr>
+          <a:xfrm>
+            <a:off x="709871" y="363467"/>
+            <a:ext cx="4324868" cy="3970318"/>
+          </a:xfrm>
+          <a:prstGeom prst="rect">
+            <a:avLst/>
+          </a:prstGeom>
+          <a:noFill/>
+          <a:ln>
+            <a:solidFill>
+              <a:srgbClr val="4779C6"/>
+            </a:solidFill>
+          </a:ln>
+        </p:spPr>
+        <p:txBody>
+          <a:bodyPr wrap="square" rtlCol="0">
+            <a:spAutoFit/>
+          </a:bodyPr>
+          <a:lstStyle/>
+          <a:p>
+            <a:r>
+              <a:rPr lang="en-US" sz="1400" b="1" dirty="0">
+                <a:solidFill>
+                  <a:srgbClr val="4779C6"/>
+                </a:solidFill>
+                <a:latin typeface="Verdana Pro" panose="020B0604030504040204" pitchFamily="34" charset="0"/>
+                <a:cs typeface="Courier New" panose="02070309020205020404" pitchFamily="49" charset="0"/>
+              </a:rPr>
+              <a:t>cDNA FLJ56591, highly similar to Eukaryotic translation initiation factor 2C3</a:t>
+            </a:r>
+          </a:p>
+          <a:p>
+            <a:endParaRPr lang="en-CA" sz="1400" dirty="0">
+              <a:solidFill>
+                <a:srgbClr val="4779C6"/>
+              </a:solidFill>
+              <a:latin typeface="Verdana Pro" panose="020B0604030504040204" pitchFamily="34" charset="0"/>
+              <a:cs typeface="Courier New" panose="02070309020205020404" pitchFamily="49" charset="0"/>
+            </a:endParaRPr>
+          </a:p>
+          <a:p>
+            <a:r>
+              <a:rPr lang="en-CA" sz="1400" dirty="0">
+                <a:solidFill>
+                  <a:srgbClr val="4779C6"/>
+                </a:solidFill>
+                <a:latin typeface="Verdana Pro" panose="020B0604030504040204" pitchFamily="34" charset="0"/>
+                <a:cs typeface="Courier New" panose="02070309020205020404" pitchFamily="49" charset="0"/>
+              </a:rPr>
+              <a:t>Molecular functions</a:t>
+            </a:r>
+          </a:p>
+          <a:p>
+            <a:pPr marL="285750" indent="-285750">
+              <a:buFont typeface="Arial" panose="020B0604020202020204" pitchFamily="34" charset="0"/>
+              <a:buChar char="•"/>
+            </a:pPr>
+            <a:r>
+              <a:rPr lang="en-CA" sz="1400" dirty="0">
+                <a:solidFill>
+                  <a:srgbClr val="4779C6"/>
+                </a:solidFill>
+                <a:latin typeface="Verdana Pro" panose="020B0604030504040204" pitchFamily="34" charset="0"/>
+                <a:cs typeface="Courier New" panose="02070309020205020404" pitchFamily="49" charset="0"/>
+              </a:rPr>
+              <a:t>DNA binding</a:t>
+            </a:r>
+          </a:p>
+          <a:p>
+            <a:pPr marL="285750" indent="-285750">
+              <a:buFont typeface="Arial" panose="020B0604020202020204" pitchFamily="34" charset="0"/>
+              <a:buChar char="•"/>
+            </a:pPr>
+            <a:r>
+              <a:rPr lang="en-CA" sz="1400" dirty="0">
+                <a:solidFill>
+                  <a:srgbClr val="4779C6"/>
+                </a:solidFill>
+                <a:latin typeface="Verdana Pro" panose="020B0604030504040204" pitchFamily="34" charset="0"/>
+                <a:cs typeface="Courier New" panose="02070309020205020404" pitchFamily="49" charset="0"/>
+              </a:rPr>
+              <a:t>DNA-binding transcription factor activ.</a:t>
+            </a:r>
+          </a:p>
+          <a:p>
+            <a:pPr marL="285750" indent="-285750">
+              <a:buFont typeface="Arial" panose="020B0604020202020204" pitchFamily="34" charset="0"/>
+              <a:buChar char="•"/>
+            </a:pPr>
+            <a:r>
+              <a:rPr lang="en-CA" sz="1400" dirty="0">
+                <a:solidFill>
+                  <a:srgbClr val="4779C6"/>
+                </a:solidFill>
+                <a:latin typeface="Verdana Pro" panose="020B0604030504040204" pitchFamily="34" charset="0"/>
+                <a:cs typeface="Courier New" panose="02070309020205020404" pitchFamily="49" charset="0"/>
+              </a:rPr>
+              <a:t>RNA binding</a:t>
+            </a:r>
+          </a:p>
+          <a:p>
+            <a:endParaRPr lang="en-CA" sz="1400" dirty="0">
+              <a:solidFill>
+                <a:srgbClr val="4779C6"/>
+              </a:solidFill>
+              <a:latin typeface="Verdana Pro" panose="020B0604030504040204" pitchFamily="34" charset="0"/>
+              <a:cs typeface="Courier New" panose="02070309020205020404" pitchFamily="49" charset="0"/>
+            </a:endParaRPr>
+          </a:p>
+          <a:p>
+            <a:r>
+              <a:rPr lang="en-CA" sz="1400" dirty="0">
+                <a:solidFill>
+                  <a:srgbClr val="4779C6"/>
+                </a:solidFill>
+                <a:latin typeface="Verdana Pro" panose="020B0604030504040204" pitchFamily="34" charset="0"/>
+                <a:cs typeface="Courier New" panose="02070309020205020404" pitchFamily="49" charset="0"/>
+              </a:rPr>
+              <a:t>Biological processes</a:t>
+            </a:r>
+          </a:p>
+          <a:p>
+            <a:pPr marL="285750" indent="-285750">
+              <a:buFont typeface="Arial" panose="020B0604020202020204" pitchFamily="34" charset="0"/>
+              <a:buChar char="•"/>
+            </a:pPr>
+            <a:r>
+              <a:rPr lang="en-CA" sz="1400" dirty="0">
+                <a:solidFill>
+                  <a:srgbClr val="4779C6"/>
+                </a:solidFill>
+                <a:latin typeface="Verdana Pro" panose="020B0604030504040204" pitchFamily="34" charset="0"/>
+                <a:cs typeface="Courier New" panose="02070309020205020404" pitchFamily="49" charset="0"/>
+              </a:rPr>
+              <a:t>immune system process</a:t>
+            </a:r>
+          </a:p>
+          <a:p>
+            <a:pPr marL="285750" indent="-285750">
+              <a:buFont typeface="Arial" panose="020B0604020202020204" pitchFamily="34" charset="0"/>
+              <a:buChar char="•"/>
+            </a:pPr>
+            <a:r>
+              <a:rPr lang="en-CA" sz="1400" dirty="0">
+                <a:solidFill>
+                  <a:srgbClr val="4779C6"/>
+                </a:solidFill>
+                <a:latin typeface="Verdana Pro" panose="020B0604030504040204" pitchFamily="34" charset="0"/>
+                <a:cs typeface="Courier New" panose="02070309020205020404" pitchFamily="49" charset="0"/>
+              </a:rPr>
+              <a:t>carbohydrate metabolic process</a:t>
+            </a:r>
+          </a:p>
+          <a:p>
+            <a:pPr marL="285750" indent="-285750">
+              <a:buFont typeface="Arial" panose="020B0604020202020204" pitchFamily="34" charset="0"/>
+              <a:buChar char="•"/>
+            </a:pPr>
+            <a:r>
+              <a:rPr lang="en-CA" sz="1400" dirty="0">
+                <a:solidFill>
+                  <a:srgbClr val="4779C6"/>
+                </a:solidFill>
+                <a:latin typeface="Verdana Pro" panose="020B0604030504040204" pitchFamily="34" charset="0"/>
+                <a:cs typeface="Courier New" panose="02070309020205020404" pitchFamily="49" charset="0"/>
+              </a:rPr>
+              <a:t>DNA metabolic process</a:t>
+            </a:r>
+          </a:p>
+          <a:p>
+            <a:endParaRPr lang="en-CA" sz="1400" dirty="0">
+              <a:solidFill>
+                <a:srgbClr val="4779C6"/>
+              </a:solidFill>
+              <a:latin typeface="Verdana Pro" panose="020B0604030504040204" pitchFamily="34" charset="0"/>
+              <a:cs typeface="Courier New" panose="02070309020205020404" pitchFamily="49" charset="0"/>
+            </a:endParaRPr>
+          </a:p>
+          <a:p>
+            <a:r>
+              <a:rPr lang="en-CA" sz="1400" dirty="0">
+                <a:solidFill>
+                  <a:srgbClr val="4779C6"/>
+                </a:solidFill>
+                <a:latin typeface="Verdana Pro" panose="020B0604030504040204" pitchFamily="34" charset="0"/>
+                <a:cs typeface="Courier New" panose="02070309020205020404" pitchFamily="49" charset="0"/>
+              </a:rPr>
+              <a:t>Domains</a:t>
+            </a:r>
+          </a:p>
+          <a:p>
+            <a:pPr marL="285750" indent="-285750">
+              <a:buFont typeface="Arial" panose="020B0604020202020204" pitchFamily="34" charset="0"/>
+              <a:buChar char="•"/>
+            </a:pPr>
+            <a:r>
+              <a:rPr lang="en-CA" sz="1400" dirty="0">
+                <a:solidFill>
+                  <a:srgbClr val="4779C6"/>
+                </a:solidFill>
+                <a:latin typeface="Verdana Pro" panose="020B0604030504040204" pitchFamily="34" charset="0"/>
+                <a:cs typeface="Courier New" panose="02070309020205020404" pitchFamily="49" charset="0"/>
+              </a:rPr>
+              <a:t>Argonaute-like, PIWI domain (29-454)</a:t>
+            </a:r>
+          </a:p>
+          <a:p>
+            <a:pPr marL="285750" indent="-285750">
+              <a:buFont typeface="Arial" panose="020B0604020202020204" pitchFamily="34" charset="0"/>
+              <a:buChar char="•"/>
+            </a:pPr>
+            <a:r>
+              <a:rPr lang="en-CA" sz="1400" dirty="0">
+                <a:solidFill>
+                  <a:srgbClr val="4779C6"/>
+                </a:solidFill>
+                <a:latin typeface="Verdana Pro" panose="020B0604030504040204" pitchFamily="34" charset="0"/>
+                <a:cs typeface="Courier New" panose="02070309020205020404" pitchFamily="49" charset="0"/>
+              </a:rPr>
+              <a:t>Ribonuclease H-like superfamily (140-456)</a:t>
+            </a:r>
+          </a:p>
+          <a:p>
+            <a:endParaRPr lang="en-CA" sz="1400" dirty="0">
+              <a:solidFill>
+                <a:srgbClr val="4779C6"/>
+              </a:solidFill>
+              <a:latin typeface="Verdana Pro" panose="020B0604030504040204" pitchFamily="34" charset="0"/>
+              <a:cs typeface="Courier New" panose="02070309020205020404" pitchFamily="49" charset="0"/>
+            </a:endParaRPr>
+          </a:p>
+        </p:txBody>
+      </p:sp>
+      <p:sp>
+        <p:nvSpPr>
+          <p:cNvPr id="14" name="TextBox 13">
+            <a:extLst>
+              <a:ext uri="{FF2B5EF4-FFF2-40B4-BE49-F238E27FC236}">
+                <a16:creationId xmlns:a16="http://schemas.microsoft.com/office/drawing/2014/main" id="{19C3D78A-F949-C05E-8924-0232E8E9B64B}"/>
+              </a:ext>
+            </a:extLst>
+          </p:cNvPr>
+          <p:cNvSpPr txBox="1"/>
+          <p:nvPr/>
+        </p:nvSpPr>
+        <p:spPr>
+          <a:xfrm>
+            <a:off x="1138496" y="4940173"/>
+            <a:ext cx="4490778" cy="1600438"/>
+          </a:xfrm>
+          <a:prstGeom prst="rect">
+            <a:avLst/>
+          </a:prstGeom>
+          <a:noFill/>
+          <a:ln>
+            <a:solidFill>
+              <a:srgbClr val="E0913A"/>
+            </a:solidFill>
+          </a:ln>
+        </p:spPr>
+        <p:txBody>
+          <a:bodyPr wrap="square" rtlCol="0">
+            <a:spAutoFit/>
+          </a:bodyPr>
+          <a:lstStyle/>
+          <a:p>
+            <a:r>
+              <a:rPr lang="en-US" sz="1400" b="1" dirty="0">
+                <a:solidFill>
+                  <a:srgbClr val="E0913A"/>
+                </a:solidFill>
+                <a:latin typeface="Verdana Pro" panose="020B0604030504040204" pitchFamily="34" charset="0"/>
+                <a:cs typeface="Courier New" panose="02070309020205020404" pitchFamily="49" charset="0"/>
+              </a:rPr>
+              <a:t>Protein argonaute (Bacteroides sp. AM16-24)</a:t>
+            </a:r>
+          </a:p>
+          <a:p>
+            <a:endParaRPr lang="en-US" sz="1400" b="1" dirty="0">
+              <a:solidFill>
+                <a:srgbClr val="E0913A"/>
+              </a:solidFill>
+              <a:latin typeface="Verdana Pro" panose="020B0604030504040204" pitchFamily="34" charset="0"/>
+              <a:cs typeface="Courier New" panose="02070309020205020404" pitchFamily="49" charset="0"/>
+            </a:endParaRPr>
+          </a:p>
+          <a:p>
+            <a:r>
+              <a:rPr lang="en-US" sz="1400" dirty="0">
+                <a:solidFill>
+                  <a:srgbClr val="E0913A"/>
+                </a:solidFill>
+                <a:latin typeface="Verdana Pro" panose="020B0604030504040204" pitchFamily="34" charset="0"/>
+                <a:cs typeface="Courier New" panose="02070309020205020404" pitchFamily="49" charset="0"/>
+              </a:rPr>
+              <a:t>Domains</a:t>
+            </a:r>
+          </a:p>
+          <a:p>
+            <a:pPr marL="285750" indent="-285750">
+              <a:buFont typeface="Arial" panose="020B0604020202020204" pitchFamily="34" charset="0"/>
+              <a:buChar char="•"/>
+            </a:pPr>
+            <a:r>
+              <a:rPr lang="en-US" sz="1400" dirty="0">
+                <a:solidFill>
+                  <a:srgbClr val="E0913A"/>
+                </a:solidFill>
+                <a:latin typeface="Verdana Pro" panose="020B0604030504040204" pitchFamily="34" charset="0"/>
+                <a:cs typeface="Courier New" panose="02070309020205020404" pitchFamily="49" charset="0"/>
+              </a:rPr>
+              <a:t>Ribonuclease H-like superfamily (2-469)</a:t>
+            </a:r>
+          </a:p>
+          <a:p>
+            <a:pPr marL="285750" indent="-285750">
+              <a:buFont typeface="Arial" panose="020B0604020202020204" pitchFamily="34" charset="0"/>
+              <a:buChar char="•"/>
+            </a:pPr>
+            <a:r>
+              <a:rPr lang="en-US" sz="1400" dirty="0">
+                <a:solidFill>
+                  <a:srgbClr val="E0913A"/>
+                </a:solidFill>
+                <a:latin typeface="Verdana Pro" panose="020B0604030504040204" pitchFamily="34" charset="0"/>
+                <a:cs typeface="Courier New" panose="02070309020205020404" pitchFamily="49" charset="0"/>
+              </a:rPr>
+              <a:t>PIWI domain (144-457)</a:t>
+            </a:r>
+          </a:p>
+          <a:p>
+            <a:endParaRPr lang="en-CA" sz="1400" dirty="0">
+              <a:solidFill>
+                <a:srgbClr val="4779C6"/>
+              </a:solidFill>
+              <a:latin typeface="Verdana Pro" panose="020B0604030504040204" pitchFamily="34" charset="0"/>
+              <a:cs typeface="Courier New" panose="02070309020205020404" pitchFamily="49" charset="0"/>
+            </a:endParaRPr>
+          </a:p>
+        </p:txBody>
+      </p:sp>
+    </p:spTree>
+    <p:extLst>
+      <p:ext uri="{BB962C8B-B14F-4D97-AF65-F5344CB8AC3E}">
+        <p14:creationId xmlns:p14="http://schemas.microsoft.com/office/powerpoint/2010/main" val="3504614833"/>
+      </p:ext>
+    </p:extLst>
+  </p:cSld>
+  <p:clrMapOvr>
+    <a:masterClrMapping/>
+  </p:clrMapOvr>
+</p:sld>
+</file>
+
+<file path=ppt/slides/slide9.xml><?xml version="1.0" encoding="utf-8"?>
 <p:sld xmlns:a="http://schemas.openxmlformats.org/drawingml/2006/main" xmlns:r="http://schemas.openxmlformats.org/officeDocument/2006/relationships" xmlns:p="http://schemas.openxmlformats.org/presentationml/2006/main">
   <p:cSld>
     <p:spTree>
@@ -10811,7 +11623,7 @@
             <a:fld id="{3899FC77-40C7-4C49-9A19-86BDE9B75E8A}" type="slidenum">
               <a:rPr lang="en-CA" smtClean="0"/>
               <a:pPr/>
-              <a:t>8</a:t>
+              <a:t>9</a:t>
             </a:fld>
             <a:endParaRPr lang="en-CA" sz="1400"/>
           </a:p>

</xml_diff>